<commit_message>
docs: keep STX rack labels off the connection arrows
The NVMe tag and the OSFP caption sat on top of the arrows. Egress between SPX, the compute BlueField-4, and GPU HBM now uses downward arrows.

Co-authored-by: 69515164-rgb <69515164-rgb@users.noreply.github.com>
</commit_message>
<xml_diff>
--- a/docs/stx-storage-pod.pptx
+++ b/docs/stx-storage-pod.pptx
@@ -3984,7 +3984,7 @@
         </p:nvSpPr>
         <p:spPr>
           <a:xfrm>
-            <a:off x="1792224" y="1993392"/>
+            <a:off x="1792224" y="2011680"/>
             <a:ext cx="201168" cy="201168"/>
           </a:xfrm>
           <a:prstGeom prst="rightArrow">
@@ -4021,49 +4021,7 @@
       </p:sp>
       <p:sp>
         <p:nvSpPr>
-          <p:cNvPr id="13" name="TextBox 12"/>
-          <p:cNvSpPr txBox="1"/>
-          <p:nvPr/>
-        </p:nvSpPr>
-        <p:spPr>
-          <a:xfrm>
-            <a:off x="1737360" y="2560320"/>
-            <a:ext cx="640080" cy="201168"/>
-          </a:xfrm>
-          <a:prstGeom prst="rect">
-            <a:avLst/>
-          </a:prstGeom>
-          <a:noFill/>
-        </p:spPr>
-        <p:txBody>
-          <a:bodyPr wrap="square" lIns="0" rIns="0" tIns="0" bIns="0" anchor="ctr"/>
-          <a:lstStyle/>
-          <a:p>
-            <a:pPr algn="ctr">
-              <a:spcBef>
-                <a:spcPts val="0"/>
-              </a:spcBef>
-              <a:spcAft>
-                <a:spcPts val="0"/>
-              </a:spcAft>
-            </a:pPr>
-            <a:r>
-              <a:rPr sz="1000" b="1">
-                <a:solidFill>
-                  <a:srgbClr val="7A541C"/>
-                </a:solidFill>
-                <a:latin typeface="Microsoft YaHei"/>
-                <a:ea typeface="Microsoft YaHei"/>
-                <a:cs typeface="Microsoft YaHei"/>
-              </a:rPr>
-              <a:t>NVMe</a:t>
-            </a:r>
-          </a:p>
-        </p:txBody>
-      </p:sp>
-      <p:sp>
-        <p:nvSpPr>
-          <p:cNvPr id="14" name="Rectangle 13"/>
+          <p:cNvPr id="13" name="Rectangle 12"/>
           <p:cNvSpPr/>
           <p:nvPr/>
         </p:nvSpPr>
@@ -4108,7 +4066,7 @@
       </p:sp>
       <p:sp>
         <p:nvSpPr>
-          <p:cNvPr id="15" name="Rectangle 14"/>
+          <p:cNvPr id="14" name="Rectangle 13"/>
           <p:cNvSpPr/>
           <p:nvPr/>
         </p:nvSpPr>
@@ -4151,7 +4109,7 @@
       </p:sp>
       <p:sp>
         <p:nvSpPr>
-          <p:cNvPr id="16" name="TextBox 15"/>
+          <p:cNvPr id="15" name="TextBox 14"/>
           <p:cNvSpPr txBox="1"/>
           <p:nvPr/>
         </p:nvSpPr>
@@ -4193,7 +4151,7 @@
       </p:sp>
       <p:sp>
         <p:nvSpPr>
-          <p:cNvPr id="17" name="Rectangle 16"/>
+          <p:cNvPr id="16" name="Rectangle 15"/>
           <p:cNvSpPr/>
           <p:nvPr/>
         </p:nvSpPr>
@@ -4236,7 +4194,7 @@
       </p:sp>
       <p:sp>
         <p:nvSpPr>
-          <p:cNvPr id="18" name="TextBox 17"/>
+          <p:cNvPr id="17" name="TextBox 16"/>
           <p:cNvSpPr txBox="1"/>
           <p:nvPr/>
         </p:nvSpPr>
@@ -4299,7 +4257,7 @@
       </p:sp>
       <p:sp>
         <p:nvSpPr>
-          <p:cNvPr id="19" name="Rectangle 18"/>
+          <p:cNvPr id="18" name="Rectangle 17"/>
           <p:cNvSpPr/>
           <p:nvPr/>
         </p:nvSpPr>
@@ -4342,7 +4300,7 @@
       </p:sp>
       <p:sp>
         <p:nvSpPr>
-          <p:cNvPr id="20" name="TextBox 19"/>
+          <p:cNvPr id="19" name="TextBox 18"/>
           <p:cNvSpPr txBox="1"/>
           <p:nvPr/>
         </p:nvSpPr>
@@ -4405,7 +4363,7 @@
       </p:sp>
       <p:sp>
         <p:nvSpPr>
-          <p:cNvPr id="21" name="Right Arrow 20"/>
+          <p:cNvPr id="20" name="Right Arrow 19"/>
           <p:cNvSpPr/>
           <p:nvPr/>
         </p:nvSpPr>
@@ -4448,7 +4406,7 @@
       </p:sp>
       <p:sp>
         <p:nvSpPr>
-          <p:cNvPr id="22" name="Rectangle 21"/>
+          <p:cNvPr id="21" name="Rectangle 20"/>
           <p:cNvSpPr/>
           <p:nvPr/>
         </p:nvSpPr>
@@ -4491,7 +4449,7 @@
       </p:sp>
       <p:sp>
         <p:nvSpPr>
-          <p:cNvPr id="23" name="TextBox 22"/>
+          <p:cNvPr id="22" name="TextBox 21"/>
           <p:cNvSpPr txBox="1"/>
           <p:nvPr/>
         </p:nvSpPr>
@@ -4533,7 +4491,7 @@
       </p:sp>
       <p:sp>
         <p:nvSpPr>
-          <p:cNvPr id="24" name="TextBox 23"/>
+          <p:cNvPr id="23" name="TextBox 22"/>
           <p:cNvSpPr txBox="1"/>
           <p:nvPr/>
         </p:nvSpPr>
@@ -4617,13 +4575,13 @@
       </p:sp>
       <p:sp>
         <p:nvSpPr>
-          <p:cNvPr id="25" name="Right Arrow 24"/>
+          <p:cNvPr id="24" name="Right Arrow 23"/>
           <p:cNvSpPr/>
           <p:nvPr/>
         </p:nvSpPr>
         <p:spPr>
           <a:xfrm>
-            <a:off x="1792224" y="3511296"/>
+            <a:off x="1792224" y="3529584"/>
             <a:ext cx="201168" cy="201168"/>
           </a:xfrm>
           <a:prstGeom prst="rightArrow">
@@ -4660,49 +4618,7 @@
       </p:sp>
       <p:sp>
         <p:nvSpPr>
-          <p:cNvPr id="26" name="TextBox 25"/>
-          <p:cNvSpPr txBox="1"/>
-          <p:nvPr/>
-        </p:nvSpPr>
-        <p:spPr>
-          <a:xfrm>
-            <a:off x="1737360" y="4078224"/>
-            <a:ext cx="640080" cy="201168"/>
-          </a:xfrm>
-          <a:prstGeom prst="rect">
-            <a:avLst/>
-          </a:prstGeom>
-          <a:noFill/>
-        </p:spPr>
-        <p:txBody>
-          <a:bodyPr wrap="square" lIns="0" rIns="0" tIns="0" bIns="0" anchor="ctr"/>
-          <a:lstStyle/>
-          <a:p>
-            <a:pPr algn="ctr">
-              <a:spcBef>
-                <a:spcPts val="0"/>
-              </a:spcBef>
-              <a:spcAft>
-                <a:spcPts val="0"/>
-              </a:spcAft>
-            </a:pPr>
-            <a:r>
-              <a:rPr sz="1000" b="1">
-                <a:solidFill>
-                  <a:srgbClr val="7A541C"/>
-                </a:solidFill>
-                <a:latin typeface="Microsoft YaHei"/>
-                <a:ea typeface="Microsoft YaHei"/>
-                <a:cs typeface="Microsoft YaHei"/>
-              </a:rPr>
-              <a:t>NVMe</a:t>
-            </a:r>
-          </a:p>
-        </p:txBody>
-      </p:sp>
-      <p:sp>
-        <p:nvSpPr>
-          <p:cNvPr id="27" name="Rectangle 26"/>
+          <p:cNvPr id="25" name="Rectangle 24"/>
           <p:cNvSpPr/>
           <p:nvPr/>
         </p:nvSpPr>
@@ -4747,7 +4663,7 @@
       </p:sp>
       <p:sp>
         <p:nvSpPr>
-          <p:cNvPr id="28" name="Rectangle 27"/>
+          <p:cNvPr id="26" name="Rectangle 25"/>
           <p:cNvSpPr/>
           <p:nvPr/>
         </p:nvSpPr>
@@ -4790,7 +4706,7 @@
       </p:sp>
       <p:sp>
         <p:nvSpPr>
-          <p:cNvPr id="29" name="TextBox 28"/>
+          <p:cNvPr id="27" name="TextBox 26"/>
           <p:cNvSpPr txBox="1"/>
           <p:nvPr/>
         </p:nvSpPr>
@@ -4832,7 +4748,7 @@
       </p:sp>
       <p:sp>
         <p:nvSpPr>
-          <p:cNvPr id="30" name="Rectangle 29"/>
+          <p:cNvPr id="28" name="Rectangle 27"/>
           <p:cNvSpPr/>
           <p:nvPr/>
         </p:nvSpPr>
@@ -4875,7 +4791,7 @@
       </p:sp>
       <p:sp>
         <p:nvSpPr>
-          <p:cNvPr id="31" name="TextBox 30"/>
+          <p:cNvPr id="29" name="TextBox 28"/>
           <p:cNvSpPr txBox="1"/>
           <p:nvPr/>
         </p:nvSpPr>
@@ -4938,7 +4854,7 @@
       </p:sp>
       <p:sp>
         <p:nvSpPr>
-          <p:cNvPr id="32" name="Rectangle 31"/>
+          <p:cNvPr id="30" name="Rectangle 29"/>
           <p:cNvSpPr/>
           <p:nvPr/>
         </p:nvSpPr>
@@ -4981,7 +4897,7 @@
       </p:sp>
       <p:sp>
         <p:nvSpPr>
-          <p:cNvPr id="33" name="TextBox 32"/>
+          <p:cNvPr id="31" name="TextBox 30"/>
           <p:cNvSpPr txBox="1"/>
           <p:nvPr/>
         </p:nvSpPr>
@@ -5044,7 +4960,7 @@
       </p:sp>
       <p:sp>
         <p:nvSpPr>
-          <p:cNvPr id="34" name="Right Arrow 33"/>
+          <p:cNvPr id="32" name="Right Arrow 31"/>
           <p:cNvSpPr/>
           <p:nvPr/>
         </p:nvSpPr>
@@ -5087,7 +5003,7 @@
       </p:sp>
       <p:sp>
         <p:nvSpPr>
-          <p:cNvPr id="35" name="Rectangle 34"/>
+          <p:cNvPr id="33" name="Rectangle 32"/>
           <p:cNvSpPr/>
           <p:nvPr/>
         </p:nvSpPr>
@@ -5130,7 +5046,7 @@
       </p:sp>
       <p:sp>
         <p:nvSpPr>
-          <p:cNvPr id="36" name="TextBox 35"/>
+          <p:cNvPr id="34" name="TextBox 33"/>
           <p:cNvSpPr txBox="1"/>
           <p:nvPr/>
         </p:nvSpPr>
@@ -5361,7 +5277,7 @@
       </p:sp>
       <p:sp>
         <p:nvSpPr>
-          <p:cNvPr id="37" name="Right Arrow 36"/>
+          <p:cNvPr id="35" name="Right Arrow 34"/>
           <p:cNvSpPr/>
           <p:nvPr/>
         </p:nvSpPr>
@@ -5404,7 +5320,7 @@
       </p:sp>
       <p:sp>
         <p:nvSpPr>
-          <p:cNvPr id="38" name="Rectangle 37"/>
+          <p:cNvPr id="36" name="Rectangle 35"/>
           <p:cNvSpPr/>
           <p:nvPr/>
         </p:nvSpPr>
@@ -5447,7 +5363,7 @@
       </p:sp>
       <p:sp>
         <p:nvSpPr>
-          <p:cNvPr id="39" name="TextBox 38"/>
+          <p:cNvPr id="37" name="TextBox 36"/>
           <p:cNvSpPr txBox="1"/>
           <p:nvPr/>
         </p:nvSpPr>
@@ -5657,7 +5573,7 @@
       </p:sp>
       <p:sp>
         <p:nvSpPr>
-          <p:cNvPr id="40" name="Rectangle 39"/>
+          <p:cNvPr id="38" name="Rectangle 37"/>
           <p:cNvSpPr/>
           <p:nvPr/>
         </p:nvSpPr>
@@ -5702,7 +5618,7 @@
       </p:sp>
       <p:sp>
         <p:nvSpPr>
-          <p:cNvPr id="41" name="TextBox 40"/>
+          <p:cNvPr id="39" name="TextBox 38"/>
           <p:cNvSpPr txBox="1"/>
           <p:nvPr/>
         </p:nvSpPr>
@@ -5744,7 +5660,7 @@
       </p:sp>
       <p:sp>
         <p:nvSpPr>
-          <p:cNvPr id="42" name="Rectangle 41"/>
+          <p:cNvPr id="40" name="Rectangle 39"/>
           <p:cNvSpPr/>
           <p:nvPr/>
         </p:nvSpPr>
@@ -5787,7 +5703,7 @@
       </p:sp>
       <p:sp>
         <p:nvSpPr>
-          <p:cNvPr id="43" name="TextBox 42"/>
+          <p:cNvPr id="41" name="TextBox 40"/>
           <p:cNvSpPr txBox="1"/>
           <p:nvPr/>
         </p:nvSpPr>
@@ -5829,7 +5745,7 @@
       </p:sp>
       <p:sp>
         <p:nvSpPr>
-          <p:cNvPr id="44" name="TextBox 43"/>
+          <p:cNvPr id="42" name="TextBox 41"/>
           <p:cNvSpPr txBox="1"/>
           <p:nvPr/>
         </p:nvSpPr>
@@ -5892,16 +5808,16 @@
       </p:sp>
       <p:sp>
         <p:nvSpPr>
-          <p:cNvPr id="45" name="Right Arrow 44"/>
+          <p:cNvPr id="43" name="Down Arrow 42"/>
           <p:cNvSpPr/>
           <p:nvPr/>
         </p:nvSpPr>
         <p:spPr>
           <a:xfrm>
-            <a:off x="10122408" y="2359152"/>
-            <a:ext cx="256032" cy="182880"/>
-          </a:xfrm>
-          <a:prstGeom prst="rightArrow">
+            <a:off x="10058400" y="2340864"/>
+            <a:ext cx="256032" cy="219456"/>
+          </a:xfrm>
+          <a:prstGeom prst="downArrow">
             <a:avLst/>
           </a:prstGeom>
           <a:solidFill>
@@ -5935,7 +5851,7 @@
       </p:sp>
       <p:sp>
         <p:nvSpPr>
-          <p:cNvPr id="46" name="Rectangle 45"/>
+          <p:cNvPr id="44" name="Rectangle 43"/>
           <p:cNvSpPr/>
           <p:nvPr/>
         </p:nvSpPr>
@@ -5978,7 +5894,7 @@
       </p:sp>
       <p:sp>
         <p:nvSpPr>
-          <p:cNvPr id="47" name="TextBox 46"/>
+          <p:cNvPr id="45" name="TextBox 44"/>
           <p:cNvSpPr txBox="1"/>
           <p:nvPr/>
         </p:nvSpPr>
@@ -6020,7 +5936,7 @@
       </p:sp>
       <p:sp>
         <p:nvSpPr>
-          <p:cNvPr id="48" name="TextBox 47"/>
+          <p:cNvPr id="46" name="TextBox 45"/>
           <p:cNvSpPr txBox="1"/>
           <p:nvPr/>
         </p:nvSpPr>
@@ -6083,16 +5999,16 @@
       </p:sp>
       <p:sp>
         <p:nvSpPr>
-          <p:cNvPr id="49" name="Right Arrow 48"/>
+          <p:cNvPr id="47" name="Down Arrow 46"/>
           <p:cNvSpPr/>
           <p:nvPr/>
         </p:nvSpPr>
         <p:spPr>
           <a:xfrm>
-            <a:off x="10122408" y="3602736"/>
-            <a:ext cx="256032" cy="182880"/>
-          </a:xfrm>
-          <a:prstGeom prst="rightArrow">
+            <a:off x="10058400" y="3584448"/>
+            <a:ext cx="256032" cy="219456"/>
+          </a:xfrm>
+          <a:prstGeom prst="downArrow">
             <a:avLst/>
           </a:prstGeom>
           <a:solidFill>
@@ -6126,7 +6042,7 @@
       </p:sp>
       <p:sp>
         <p:nvSpPr>
-          <p:cNvPr id="50" name="Rectangle 49"/>
+          <p:cNvPr id="48" name="Rectangle 47"/>
           <p:cNvSpPr/>
           <p:nvPr/>
         </p:nvSpPr>
@@ -6169,7 +6085,7 @@
       </p:sp>
       <p:sp>
         <p:nvSpPr>
-          <p:cNvPr id="51" name="TextBox 50"/>
+          <p:cNvPr id="49" name="TextBox 48"/>
           <p:cNvSpPr txBox="1"/>
           <p:nvPr/>
         </p:nvSpPr>
@@ -6211,7 +6127,7 @@
       </p:sp>
       <p:sp>
         <p:nvSpPr>
-          <p:cNvPr id="52" name="TextBox 51"/>
+          <p:cNvPr id="50" name="TextBox 49"/>
           <p:cNvSpPr txBox="1"/>
           <p:nvPr/>
         </p:nvSpPr>
@@ -6253,70 +6169,7 @@
       </p:sp>
       <p:sp>
         <p:nvSpPr>
-          <p:cNvPr id="53" name="TextBox 52"/>
-          <p:cNvSpPr txBox="1"/>
-          <p:nvPr/>
-        </p:nvSpPr>
-        <p:spPr>
-          <a:xfrm>
-            <a:off x="7818120" y="4160520"/>
-            <a:ext cx="1417320" cy="502920"/>
-          </a:xfrm>
-          <a:prstGeom prst="rect">
-            <a:avLst/>
-          </a:prstGeom>
-          <a:noFill/>
-        </p:spPr>
-        <p:txBody>
-          <a:bodyPr wrap="square" lIns="0" rIns="0" tIns="0" bIns="0" anchor="ctr"/>
-          <a:lstStyle/>
-          <a:p>
-            <a:pPr algn="ctr">
-              <a:spcBef>
-                <a:spcPts val="0"/>
-              </a:spcBef>
-              <a:spcAft>
-                <a:spcPts val="0"/>
-              </a:spcAft>
-            </a:pPr>
-            <a:r>
-              <a:rPr sz="1100" b="1">
-                <a:solidFill>
-                  <a:srgbClr val="583E82"/>
-                </a:solidFill>
-                <a:latin typeface="Microsoft YaHei"/>
-                <a:ea typeface="Microsoft YaHei"/>
-                <a:cs typeface="Microsoft YaHei"/>
-              </a:rPr>
-              <a:t>32×OSFP</a:t>
-            </a:r>
-          </a:p>
-          <a:p>
-            <a:pPr algn="ctr">
-              <a:spcBef>
-                <a:spcPts val="0"/>
-              </a:spcBef>
-              <a:spcAft>
-                <a:spcPts val="0"/>
-              </a:spcAft>
-            </a:pPr>
-            <a:r>
-              <a:rPr sz="1100" b="1">
-                <a:solidFill>
-                  <a:srgbClr val="583E82"/>
-                </a:solidFill>
-                <a:latin typeface="Microsoft YaHei"/>
-                <a:ea typeface="Microsoft YaHei"/>
-                <a:cs typeface="Microsoft YaHei"/>
-              </a:rPr>
-              <a:t>单层光</a:t>
-            </a:r>
-          </a:p>
-        </p:txBody>
-      </p:sp>
-      <p:sp>
-        <p:nvSpPr>
-          <p:cNvPr id="54" name="Rectangle 53"/>
+          <p:cNvPr id="51" name="Rectangle 50"/>
           <p:cNvSpPr/>
           <p:nvPr/>
         </p:nvSpPr>
@@ -6361,7 +6214,7 @@
       </p:sp>
       <p:sp>
         <p:nvSpPr>
-          <p:cNvPr id="55" name="Rectangle 54"/>
+          <p:cNvPr id="52" name="Rectangle 51"/>
           <p:cNvSpPr/>
           <p:nvPr/>
         </p:nvSpPr>
@@ -6404,7 +6257,7 @@
       </p:sp>
       <p:sp>
         <p:nvSpPr>
-          <p:cNvPr id="56" name="TextBox 55"/>
+          <p:cNvPr id="53" name="TextBox 52"/>
           <p:cNvSpPr txBox="1"/>
           <p:nvPr/>
         </p:nvSpPr>
@@ -6446,7 +6299,7 @@
       </p:sp>
       <p:sp>
         <p:nvSpPr>
-          <p:cNvPr id="57" name="TextBox 56"/>
+          <p:cNvPr id="54" name="TextBox 53"/>
           <p:cNvSpPr txBox="1"/>
           <p:nvPr/>
         </p:nvSpPr>
@@ -6488,7 +6341,7 @@
       </p:sp>
       <p:sp>
         <p:nvSpPr>
-          <p:cNvPr id="58" name="Rectangle 57"/>
+          <p:cNvPr id="55" name="Rectangle 54"/>
           <p:cNvSpPr/>
           <p:nvPr/>
         </p:nvSpPr>
@@ -6533,7 +6386,7 @@
       </p:sp>
       <p:sp>
         <p:nvSpPr>
-          <p:cNvPr id="59" name="Rectangle 58"/>
+          <p:cNvPr id="56" name="Rectangle 55"/>
           <p:cNvSpPr/>
           <p:nvPr/>
         </p:nvSpPr>
@@ -6576,7 +6429,7 @@
       </p:sp>
       <p:sp>
         <p:nvSpPr>
-          <p:cNvPr id="60" name="TextBox 59"/>
+          <p:cNvPr id="57" name="TextBox 56"/>
           <p:cNvSpPr txBox="1"/>
           <p:nvPr/>
         </p:nvSpPr>
@@ -6618,7 +6471,7 @@
       </p:sp>
       <p:sp>
         <p:nvSpPr>
-          <p:cNvPr id="61" name="TextBox 60"/>
+          <p:cNvPr id="58" name="TextBox 57"/>
           <p:cNvSpPr txBox="1"/>
           <p:nvPr/>
         </p:nvSpPr>
@@ -6660,7 +6513,7 @@
       </p:sp>
       <p:sp>
         <p:nvSpPr>
-          <p:cNvPr id="62" name="Rectangle 61"/>
+          <p:cNvPr id="59" name="Rectangle 58"/>
           <p:cNvSpPr/>
           <p:nvPr/>
         </p:nvSpPr>
@@ -6705,7 +6558,7 @@
       </p:sp>
       <p:sp>
         <p:nvSpPr>
-          <p:cNvPr id="63" name="Rectangle 62"/>
+          <p:cNvPr id="60" name="Rectangle 59"/>
           <p:cNvSpPr/>
           <p:nvPr/>
         </p:nvSpPr>
@@ -6748,7 +6601,7 @@
       </p:sp>
       <p:sp>
         <p:nvSpPr>
-          <p:cNvPr id="64" name="TextBox 63"/>
+          <p:cNvPr id="61" name="TextBox 60"/>
           <p:cNvSpPr txBox="1"/>
           <p:nvPr/>
         </p:nvSpPr>
@@ -6790,7 +6643,7 @@
       </p:sp>
       <p:sp>
         <p:nvSpPr>
-          <p:cNvPr id="65" name="TextBox 64"/>
+          <p:cNvPr id="62" name="TextBox 61"/>
           <p:cNvSpPr txBox="1"/>
           <p:nvPr/>
         </p:nvSpPr>
@@ -6832,7 +6685,7 @@
       </p:sp>
       <p:sp>
         <p:nvSpPr>
-          <p:cNvPr id="66" name="TextBox 65"/>
+          <p:cNvPr id="63" name="TextBox 62"/>
           <p:cNvSpPr txBox="1"/>
           <p:nvPr/>
         </p:nvSpPr>

</xml_diff>

<commit_message>
docs: redraw the STX rack as a labeled wiring diagram
Each hop is a line with its medium: NVMe inside the tray, 200 Gb/s copper into the spine, rear-port into the switch, and a single optical hop out to Spectrum-6 SPX.

Co-authored-by: 69515164-rgb <69515164-rgb@users.noreply.github.com>
</commit_message>
<xml_diff>
--- a/docs/stx-storage-pod.pptx
+++ b/docs/stx-storage-pod.pptx
@@ -3559,7 +3559,7 @@
         </p:nvSpPr>
         <p:spPr>
           <a:xfrm>
-            <a:off x="292608" y="128016"/>
+            <a:off x="292608" y="109728"/>
             <a:ext cx="11521440" cy="182880"/>
           </a:xfrm>
           <a:prstGeom prst="rect">
@@ -3601,8 +3601,8 @@
         </p:nvSpPr>
         <p:spPr>
           <a:xfrm>
-            <a:off x="292608" y="310896"/>
-            <a:ext cx="11612880" cy="310896"/>
+            <a:off x="292608" y="292608"/>
+            <a:ext cx="11612880" cy="292608"/>
           </a:xfrm>
           <a:prstGeom prst="rect">
             <a:avLst/>
@@ -3622,7 +3622,7 @@
               </a:spcAft>
             </a:pPr>
             <a:r>
-              <a:rPr sz="2200" b="1">
+              <a:rPr sz="2000" b="1">
                 <a:solidFill>
                   <a:srgbClr val="0E2A47"/>
                 </a:solidFill>
@@ -3630,7 +3630,7 @@
                 <a:ea typeface="Microsoft YaHei"/>
                 <a:cs typeface="Microsoft YaHei"/>
               </a:rPr>
-              <a:t>盘只进本托盘的 BlueField-4，托盘之间只经过铜质 Spine</a:t>
+              <a:t>每条线是一种连接：托盘内 NVMe，机架内铜缆，出机架单层光</a:t>
             </a:r>
           </a:p>
         </p:txBody>
@@ -3643,8 +3643,8 @@
         </p:nvSpPr>
         <p:spPr>
           <a:xfrm>
-            <a:off x="292608" y="694944"/>
-            <a:ext cx="64008" cy="310896"/>
+            <a:off x="292608" y="640080"/>
+            <a:ext cx="64008" cy="292608"/>
           </a:xfrm>
           <a:prstGeom prst="rect">
             <a:avLst/>
@@ -3686,8 +3686,8 @@
         </p:nvSpPr>
         <p:spPr>
           <a:xfrm>
-            <a:off x="438912" y="658368"/>
-            <a:ext cx="11430000" cy="365760"/>
+            <a:off x="438912" y="603504"/>
+            <a:ext cx="11430000" cy="347472"/>
           </a:xfrm>
           <a:prstGeom prst="rect">
             <a:avLst/>
@@ -3715,7 +3715,7 @@
                 <a:ea typeface="Microsoft YaHei"/>
                 <a:cs typeface="Microsoft YaHei"/>
               </a:rPr>
-              <a:t>出机架只有交换机托盘前置的光口。单层光连到 Spectrum-6 SPX，再接到计算节点上的 BlueField-4。</a:t>
+              <a:t>两条托盘的铜缆汇进同一条 Spine。交换机后端口接 Spine，前置光口离开机架，再接到计算节点。</a:t>
             </a:r>
           </a:p>
         </p:txBody>
@@ -3728,8 +3728,8 @@
         </p:nvSpPr>
         <p:spPr>
           <a:xfrm>
-            <a:off x="256032" y="1115568"/>
-            <a:ext cx="8275320" cy="3703320"/>
+            <a:off x="237744" y="1115568"/>
+            <a:ext cx="8229600" cy="2788920"/>
           </a:xfrm>
           <a:prstGeom prst="rect">
             <a:avLst/>
@@ -3773,8 +3773,8 @@
         </p:nvSpPr>
         <p:spPr>
           <a:xfrm>
-            <a:off x="365760" y="1152144"/>
-            <a:ext cx="5669280" cy="219456"/>
+            <a:off x="347472" y="1133856"/>
+            <a:ext cx="5120640" cy="182880"/>
           </a:xfrm>
           <a:prstGeom prst="rect">
             <a:avLst/>
@@ -3794,7 +3794,7 @@
               </a:spcAft>
             </a:pPr>
             <a:r>
-              <a:rPr sz="1200" b="1">
+              <a:rPr sz="1100" b="1">
                 <a:solidFill>
                   <a:srgbClr val="145A96"/>
                 </a:solidFill>
@@ -3802,7 +3802,7 @@
                 <a:ea typeface="Microsoft YaHei"/>
                 <a:cs typeface="Microsoft YaHei"/>
               </a:rPr>
-              <a:t>STX 存储机架内部  ·  MGX ETL，Spectrum-X 铜质 Spine</a:t>
+              <a:t>机架内  ·  MGX ETL</a:t>
             </a:r>
           </a:p>
         </p:txBody>
@@ -3815,8 +3815,8 @@
         </p:nvSpPr>
         <p:spPr>
           <a:xfrm>
-            <a:off x="402336" y="1426464"/>
-            <a:ext cx="1353312" cy="1389888"/>
+            <a:off x="365760" y="1353312"/>
+            <a:ext cx="1298448" cy="1078992"/>
           </a:xfrm>
           <a:prstGeom prst="rect">
             <a:avLst/>
@@ -3858,8 +3858,8 @@
         </p:nvSpPr>
         <p:spPr>
           <a:xfrm>
-            <a:off x="475488" y="1517904"/>
-            <a:ext cx="1207008" cy="256032"/>
+            <a:off x="438912" y="1426464"/>
+            <a:ext cx="1152144" cy="237744"/>
           </a:xfrm>
           <a:prstGeom prst="rect">
             <a:avLst/>
@@ -3879,7 +3879,7 @@
               </a:spcAft>
             </a:pPr>
             <a:r>
-              <a:rPr sz="1400" b="1">
+              <a:rPr sz="1300" b="1">
                 <a:solidFill>
                   <a:srgbClr val="FFFFFF"/>
                 </a:solidFill>
@@ -3900,8 +3900,8 @@
         </p:nvSpPr>
         <p:spPr>
           <a:xfrm>
-            <a:off x="475488" y="1810512"/>
-            <a:ext cx="1207008" cy="877824"/>
+            <a:off x="438912" y="1682495"/>
+            <a:ext cx="1152144" cy="658368"/>
           </a:xfrm>
           <a:prstGeom prst="rect">
             <a:avLst/>
@@ -3929,7 +3929,7 @@
                 <a:ea typeface="Microsoft YaHei"/>
                 <a:cs typeface="Microsoft YaHei"/>
               </a:rPr>
-              <a:t>本托盘的 KV 介质。</a:t>
+              <a:t>托盘 1</a:t>
             </a:r>
           </a:p>
           <a:p>
@@ -3950,7 +3950,7 @@
                 <a:ea typeface="Microsoft YaHei"/>
                 <a:cs typeface="Microsoft YaHei"/>
               </a:rPr>
-              <a:t>G3.5 上下文层。</a:t>
+              <a:t>KV 介质</a:t>
             </a:r>
           </a:p>
           <a:p>
@@ -3971,64 +3971,21 @@
                 <a:ea typeface="Microsoft YaHei"/>
                 <a:cs typeface="Microsoft YaHei"/>
               </a:rPr>
-              <a:t>不直接上交换机。</a:t>
-            </a:r>
-          </a:p>
-        </p:txBody>
-      </p:sp>
-      <p:sp>
-        <p:nvSpPr>
-          <p:cNvPr id="12" name="Right Arrow 11"/>
+              <a:t>G3.5</a:t>
+            </a:r>
+          </a:p>
+        </p:txBody>
+      </p:sp>
+      <p:sp>
+        <p:nvSpPr>
+          <p:cNvPr id="12" name="Rectangle 11"/>
           <p:cNvSpPr/>
           <p:nvPr/>
         </p:nvSpPr>
         <p:spPr>
           <a:xfrm>
-            <a:off x="1792224" y="2011680"/>
-            <a:ext cx="201168" cy="201168"/>
-          </a:xfrm>
-          <a:prstGeom prst="rightArrow">
-            <a:avLst/>
-          </a:prstGeom>
-          <a:solidFill>
-            <a:srgbClr val="7A541C"/>
-          </a:solidFill>
-          <a:ln>
-            <a:noFill/>
-          </a:ln>
-        </p:spPr>
-        <p:style>
-          <a:lnRef idx="1">
-            <a:schemeClr val="accent1"/>
-          </a:lnRef>
-          <a:fillRef idx="3">
-            <a:schemeClr val="accent1"/>
-          </a:fillRef>
-          <a:effectRef idx="2">
-            <a:schemeClr val="accent1"/>
-          </a:effectRef>
-          <a:fontRef idx="minor">
-            <a:schemeClr val="lt1"/>
-          </a:fontRef>
-        </p:style>
-        <p:txBody>
-          <a:bodyPr rtlCol="0" anchor="ctr"/>
-          <a:lstStyle/>
-          <a:p>
-            <a:pPr algn="ctr"/>
-          </a:p>
-        </p:txBody>
-      </p:sp>
-      <p:sp>
-        <p:nvSpPr>
-          <p:cNvPr id="13" name="Rectangle 12"/>
-          <p:cNvSpPr/>
-          <p:nvPr/>
-        </p:nvSpPr>
-        <p:spPr>
-          <a:xfrm>
-            <a:off x="2029968" y="1426464"/>
-            <a:ext cx="2487168" cy="1389888"/>
+            <a:off x="2267712" y="1353312"/>
+            <a:ext cx="2084831" cy="1078992"/>
           </a:xfrm>
           <a:prstGeom prst="rect">
             <a:avLst/>
@@ -4066,14 +4023,14 @@
       </p:sp>
       <p:sp>
         <p:nvSpPr>
-          <p:cNvPr id="14" name="Rectangle 13"/>
+          <p:cNvPr id="13" name="Rectangle 12"/>
           <p:cNvSpPr/>
           <p:nvPr/>
         </p:nvSpPr>
         <p:spPr>
           <a:xfrm>
-            <a:off x="2029968" y="1426464"/>
-            <a:ext cx="73152" cy="1389888"/>
+            <a:off x="2267712" y="1353312"/>
+            <a:ext cx="64008" cy="1078992"/>
           </a:xfrm>
           <a:prstGeom prst="rect">
             <a:avLst/>
@@ -4109,14 +4066,14 @@
       </p:sp>
       <p:sp>
         <p:nvSpPr>
-          <p:cNvPr id="15" name="TextBox 14"/>
+          <p:cNvPr id="14" name="TextBox 13"/>
           <p:cNvSpPr txBox="1"/>
           <p:nvPr/>
         </p:nvSpPr>
         <p:spPr>
           <a:xfrm>
-            <a:off x="2176272" y="1481328"/>
-            <a:ext cx="2267712" cy="219456"/>
+            <a:off x="2395728" y="1389888"/>
+            <a:ext cx="1883663" cy="201168"/>
           </a:xfrm>
           <a:prstGeom prst="rect">
             <a:avLst/>
@@ -4144,21 +4101,21 @@
                 <a:ea typeface="Microsoft YaHei"/>
                 <a:cs typeface="Microsoft YaHei"/>
               </a:rPr>
-              <a:t>存储托盘 1  ·  BlueField-4 STX</a:t>
-            </a:r>
-          </a:p>
-        </p:txBody>
-      </p:sp>
-      <p:sp>
-        <p:nvSpPr>
-          <p:cNvPr id="16" name="Rectangle 15"/>
+              <a:t>BlueField-4 STX</a:t>
+            </a:r>
+          </a:p>
+        </p:txBody>
+      </p:sp>
+      <p:sp>
+        <p:nvSpPr>
+          <p:cNvPr id="15" name="Rectangle 14"/>
           <p:cNvSpPr/>
           <p:nvPr/>
         </p:nvSpPr>
         <p:spPr>
           <a:xfrm>
-            <a:off x="2176272" y="1755648"/>
-            <a:ext cx="2231136" cy="457200"/>
+            <a:off x="2395728" y="1609344"/>
+            <a:ext cx="1865376" cy="347472"/>
           </a:xfrm>
           <a:prstGeom prst="rect">
             <a:avLst/>
@@ -4194,14 +4151,14 @@
       </p:sp>
       <p:sp>
         <p:nvSpPr>
-          <p:cNvPr id="17" name="TextBox 16"/>
+          <p:cNvPr id="16" name="TextBox 15"/>
           <p:cNvSpPr txBox="1"/>
           <p:nvPr/>
         </p:nvSpPr>
         <p:spPr>
           <a:xfrm>
-            <a:off x="2231136" y="1755648"/>
-            <a:ext cx="2121408" cy="457200"/>
+            <a:off x="2432304" y="1609344"/>
+            <a:ext cx="1792223" cy="347472"/>
           </a:xfrm>
           <a:prstGeom prst="rect">
             <a:avLst/>
@@ -4221,7 +4178,7 @@
               </a:spcAft>
             </a:pPr>
             <a:r>
-              <a:rPr sz="1100" b="0">
+              <a:rPr sz="1100" b="1">
                 <a:solidFill>
                   <a:srgbClr val="0E2A47"/>
                 </a:solidFill>
@@ -4229,42 +4186,21 @@
                 <a:ea typeface="Microsoft YaHei"/>
                 <a:cs typeface="Microsoft YaHei"/>
               </a:rPr>
-              <a:t>Vera CPU</a:t>
-            </a:r>
-          </a:p>
-          <a:p>
-            <a:pPr algn="l">
-              <a:spcBef>
-                <a:spcPts val="0"/>
-              </a:spcBef>
-              <a:spcAft>
-                <a:spcPts val="0"/>
-              </a:spcAft>
-            </a:pPr>
-            <a:r>
-              <a:rPr sz="1100" b="0">
-                <a:solidFill>
-                  <a:srgbClr val="0E2A47"/>
-                </a:solidFill>
-                <a:latin typeface="Microsoft YaHei"/>
-                <a:ea typeface="Microsoft YaHei"/>
-                <a:cs typeface="Microsoft YaHei"/>
-              </a:rPr>
-              <a:t>DOCA Memos：KV 放置与存储服务</a:t>
-            </a:r>
-          </a:p>
-        </p:txBody>
-      </p:sp>
-      <p:sp>
-        <p:nvSpPr>
-          <p:cNvPr id="18" name="Rectangle 17"/>
+              <a:t>Vera CPU    DOCA Memos</a:t>
+            </a:r>
+          </a:p>
+        </p:txBody>
+      </p:sp>
+      <p:sp>
+        <p:nvSpPr>
+          <p:cNvPr id="17" name="Rectangle 16"/>
           <p:cNvSpPr/>
           <p:nvPr/>
         </p:nvSpPr>
         <p:spPr>
           <a:xfrm>
-            <a:off x="2176272" y="2267712"/>
-            <a:ext cx="2231136" cy="457200"/>
+            <a:off x="2395728" y="2066543"/>
+            <a:ext cx="1865376" cy="310896"/>
           </a:xfrm>
           <a:prstGeom prst="rect">
             <a:avLst/>
@@ -4300,14 +4236,14 @@
       </p:sp>
       <p:sp>
         <p:nvSpPr>
-          <p:cNvPr id="19" name="TextBox 18"/>
+          <p:cNvPr id="18" name="TextBox 17"/>
           <p:cNvSpPr txBox="1"/>
           <p:nvPr/>
         </p:nvSpPr>
         <p:spPr>
           <a:xfrm>
-            <a:off x="2231136" y="2267712"/>
-            <a:ext cx="2121408" cy="457200"/>
+            <a:off x="2432304" y="2066543"/>
+            <a:ext cx="1792223" cy="310896"/>
           </a:xfrm>
           <a:prstGeom prst="rect">
             <a:avLst/>
@@ -4327,7 +4263,7 @@
               </a:spcAft>
             </a:pPr>
             <a:r>
-              <a:rPr sz="1100" b="0">
+              <a:rPr sz="1100" b="1">
                 <a:solidFill>
                   <a:srgbClr val="0E2A47"/>
                 </a:solidFill>
@@ -4335,9 +4271,66 @@
                 <a:ea typeface="Microsoft YaHei"/>
                 <a:cs typeface="Microsoft YaHei"/>
               </a:rPr>
-              <a:t>ConnectX-9 SuperNIC</a:t>
-            </a:r>
-          </a:p>
+              <a:t>ConnectX-9    数据面</a:t>
+            </a:r>
+          </a:p>
+        </p:txBody>
+      </p:sp>
+      <p:cxnSp>
+        <p:nvCxnSpPr>
+          <p:cNvPr id="19" name="Connector 18"/>
+          <p:cNvCxnSpPr/>
+          <p:nvPr/>
+        </p:nvCxnSpPr>
+        <p:spPr>
+          <a:xfrm>
+            <a:off x="2770632" y="1956816"/>
+            <a:ext cx="0" cy="109727"/>
+          </a:xfrm>
+          <a:prstGeom prst="line">
+            <a:avLst/>
+          </a:prstGeom>
+          <a:ln w="28575">
+            <a:solidFill>
+              <a:srgbClr val="0E7A76"/>
+            </a:solidFill>
+            <a:tailEnd type="triangle" w="med" len="sm"/>
+          </a:ln>
+        </p:spPr>
+        <p:style>
+          <a:lnRef idx="2">
+            <a:schemeClr val="accent1"/>
+          </a:lnRef>
+          <a:fillRef idx="0">
+            <a:schemeClr val="accent1"/>
+          </a:fillRef>
+          <a:effectRef idx="1">
+            <a:schemeClr val="accent1"/>
+          </a:effectRef>
+          <a:fontRef idx="minor">
+            <a:schemeClr val="tx1"/>
+          </a:fontRef>
+        </p:style>
+      </p:cxnSp>
+      <p:sp>
+        <p:nvSpPr>
+          <p:cNvPr id="20" name="TextBox 19"/>
+          <p:cNvSpPr txBox="1"/>
+          <p:nvPr/>
+        </p:nvSpPr>
+        <p:spPr>
+          <a:xfrm>
+            <a:off x="2889504" y="1920240"/>
+            <a:ext cx="640080" cy="164592"/>
+          </a:xfrm>
+          <a:prstGeom prst="rect">
+            <a:avLst/>
+          </a:prstGeom>
+          <a:noFill/>
+        </p:spPr>
+        <p:txBody>
+          <a:bodyPr wrap="square" lIns="0" rIns="0" tIns="0" bIns="0" anchor="ctr"/>
+          <a:lstStyle/>
           <a:p>
             <a:pPr algn="l">
               <a:spcBef>
@@ -4348,59 +4341,16 @@
               </a:spcAft>
             </a:pPr>
             <a:r>
-              <a:rPr sz="1100" b="0">
-                <a:solidFill>
-                  <a:srgbClr val="0E2A47"/>
+              <a:rPr sz="1000" b="1">
+                <a:solidFill>
+                  <a:srgbClr val="0E7A76"/>
                 </a:solidFill>
                 <a:latin typeface="Microsoft YaHei"/>
                 <a:ea typeface="Microsoft YaHei"/>
                 <a:cs typeface="Microsoft YaHei"/>
               </a:rPr>
-              <a:t>NVMe-oF / RDMA，加密与 CRC</a:t>
-            </a:r>
-          </a:p>
-        </p:txBody>
-      </p:sp>
-      <p:sp>
-        <p:nvSpPr>
-          <p:cNvPr id="20" name="Right Arrow 19"/>
-          <p:cNvSpPr/>
-          <p:nvPr/>
-        </p:nvSpPr>
-        <p:spPr>
-          <a:xfrm>
-            <a:off x="4553712" y="1993392"/>
-            <a:ext cx="237744" cy="201168"/>
-          </a:xfrm>
-          <a:prstGeom prst="rightArrow">
-            <a:avLst/>
-          </a:prstGeom>
-          <a:solidFill>
-            <a:srgbClr val="0E7A76"/>
-          </a:solidFill>
-          <a:ln>
-            <a:noFill/>
-          </a:ln>
-        </p:spPr>
-        <p:style>
-          <a:lnRef idx="1">
-            <a:schemeClr val="accent1"/>
-          </a:lnRef>
-          <a:fillRef idx="3">
-            <a:schemeClr val="accent1"/>
-          </a:fillRef>
-          <a:effectRef idx="2">
-            <a:schemeClr val="accent1"/>
-          </a:effectRef>
-          <a:fontRef idx="minor">
-            <a:schemeClr val="lt1"/>
-          </a:fontRef>
-        </p:style>
-        <p:txBody>
-          <a:bodyPr rtlCol="0" anchor="ctr"/>
-          <a:lstStyle/>
-          <a:p>
-            <a:pPr algn="ctr"/>
+              <a:t>片内</a:t>
+            </a:r>
           </a:p>
         </p:txBody>
       </p:sp>
@@ -4412,8 +4362,8 @@
         </p:nvSpPr>
         <p:spPr>
           <a:xfrm>
-            <a:off x="402336" y="2944368"/>
-            <a:ext cx="1353312" cy="1389888"/>
+            <a:off x="365760" y="2615184"/>
+            <a:ext cx="1298448" cy="1078992"/>
           </a:xfrm>
           <a:prstGeom prst="rect">
             <a:avLst/>
@@ -4455,8 +4405,8 @@
         </p:nvSpPr>
         <p:spPr>
           <a:xfrm>
-            <a:off x="475488" y="3035808"/>
-            <a:ext cx="1207008" cy="256032"/>
+            <a:off x="438912" y="2688336"/>
+            <a:ext cx="1152144" cy="237744"/>
           </a:xfrm>
           <a:prstGeom prst="rect">
             <a:avLst/>
@@ -4476,7 +4426,7 @@
               </a:spcAft>
             </a:pPr>
             <a:r>
-              <a:rPr sz="1400" b="1">
+              <a:rPr sz="1300" b="1">
                 <a:solidFill>
                   <a:srgbClr val="FFFFFF"/>
                 </a:solidFill>
@@ -4497,8 +4447,8 @@
         </p:nvSpPr>
         <p:spPr>
           <a:xfrm>
-            <a:off x="475488" y="3328416"/>
-            <a:ext cx="1207008" cy="877824"/>
+            <a:off x="438912" y="2944368"/>
+            <a:ext cx="1152144" cy="658368"/>
           </a:xfrm>
           <a:prstGeom prst="rect">
             <a:avLst/>
@@ -4526,7 +4476,7 @@
                 <a:ea typeface="Microsoft YaHei"/>
                 <a:cs typeface="Microsoft YaHei"/>
               </a:rPr>
-              <a:t>本托盘的 KV 介质。</a:t>
+              <a:t>托盘 2</a:t>
             </a:r>
           </a:p>
           <a:p>
@@ -4547,7 +4497,7 @@
                 <a:ea typeface="Microsoft YaHei"/>
                 <a:cs typeface="Microsoft YaHei"/>
               </a:rPr>
-              <a:t>G3.5 上下文层。</a:t>
+              <a:t>KV 介质</a:t>
             </a:r>
           </a:p>
           <a:p>
@@ -4568,64 +4518,21 @@
                 <a:ea typeface="Microsoft YaHei"/>
                 <a:cs typeface="Microsoft YaHei"/>
               </a:rPr>
-              <a:t>不直接上交换机。</a:t>
-            </a:r>
-          </a:p>
-        </p:txBody>
-      </p:sp>
-      <p:sp>
-        <p:nvSpPr>
-          <p:cNvPr id="24" name="Right Arrow 23"/>
+              <a:t>G3.5</a:t>
+            </a:r>
+          </a:p>
+        </p:txBody>
+      </p:sp>
+      <p:sp>
+        <p:nvSpPr>
+          <p:cNvPr id="24" name="Rectangle 23"/>
           <p:cNvSpPr/>
           <p:nvPr/>
         </p:nvSpPr>
         <p:spPr>
           <a:xfrm>
-            <a:off x="1792224" y="3529584"/>
-            <a:ext cx="201168" cy="201168"/>
-          </a:xfrm>
-          <a:prstGeom prst="rightArrow">
-            <a:avLst/>
-          </a:prstGeom>
-          <a:solidFill>
-            <a:srgbClr val="7A541C"/>
-          </a:solidFill>
-          <a:ln>
-            <a:noFill/>
-          </a:ln>
-        </p:spPr>
-        <p:style>
-          <a:lnRef idx="1">
-            <a:schemeClr val="accent1"/>
-          </a:lnRef>
-          <a:fillRef idx="3">
-            <a:schemeClr val="accent1"/>
-          </a:fillRef>
-          <a:effectRef idx="2">
-            <a:schemeClr val="accent1"/>
-          </a:effectRef>
-          <a:fontRef idx="minor">
-            <a:schemeClr val="lt1"/>
-          </a:fontRef>
-        </p:style>
-        <p:txBody>
-          <a:bodyPr rtlCol="0" anchor="ctr"/>
-          <a:lstStyle/>
-          <a:p>
-            <a:pPr algn="ctr"/>
-          </a:p>
-        </p:txBody>
-      </p:sp>
-      <p:sp>
-        <p:nvSpPr>
-          <p:cNvPr id="25" name="Rectangle 24"/>
-          <p:cNvSpPr/>
-          <p:nvPr/>
-        </p:nvSpPr>
-        <p:spPr>
-          <a:xfrm>
-            <a:off x="2029968" y="2944368"/>
-            <a:ext cx="2487168" cy="1389888"/>
+            <a:off x="2267712" y="2615184"/>
+            <a:ext cx="2084831" cy="1078992"/>
           </a:xfrm>
           <a:prstGeom prst="rect">
             <a:avLst/>
@@ -4663,14 +4570,14 @@
       </p:sp>
       <p:sp>
         <p:nvSpPr>
-          <p:cNvPr id="26" name="Rectangle 25"/>
+          <p:cNvPr id="25" name="Rectangle 24"/>
           <p:cNvSpPr/>
           <p:nvPr/>
         </p:nvSpPr>
         <p:spPr>
           <a:xfrm>
-            <a:off x="2029968" y="2944368"/>
-            <a:ext cx="73152" cy="1389888"/>
+            <a:off x="2267712" y="2615184"/>
+            <a:ext cx="64008" cy="1078992"/>
           </a:xfrm>
           <a:prstGeom prst="rect">
             <a:avLst/>
@@ -4706,14 +4613,14 @@
       </p:sp>
       <p:sp>
         <p:nvSpPr>
-          <p:cNvPr id="27" name="TextBox 26"/>
+          <p:cNvPr id="26" name="TextBox 25"/>
           <p:cNvSpPr txBox="1"/>
           <p:nvPr/>
         </p:nvSpPr>
         <p:spPr>
           <a:xfrm>
-            <a:off x="2176272" y="2999232"/>
-            <a:ext cx="2267712" cy="219456"/>
+            <a:off x="2395728" y="2651760"/>
+            <a:ext cx="1883663" cy="201168"/>
           </a:xfrm>
           <a:prstGeom prst="rect">
             <a:avLst/>
@@ -4741,21 +4648,21 @@
                 <a:ea typeface="Microsoft YaHei"/>
                 <a:cs typeface="Microsoft YaHei"/>
               </a:rPr>
-              <a:t>存储托盘 2  ·  BlueField-4 STX</a:t>
-            </a:r>
-          </a:p>
-        </p:txBody>
-      </p:sp>
-      <p:sp>
-        <p:nvSpPr>
-          <p:cNvPr id="28" name="Rectangle 27"/>
+              <a:t>BlueField-4 STX</a:t>
+            </a:r>
+          </a:p>
+        </p:txBody>
+      </p:sp>
+      <p:sp>
+        <p:nvSpPr>
+          <p:cNvPr id="27" name="Rectangle 26"/>
           <p:cNvSpPr/>
           <p:nvPr/>
         </p:nvSpPr>
         <p:spPr>
           <a:xfrm>
-            <a:off x="2176272" y="3273552"/>
-            <a:ext cx="2231136" cy="457200"/>
+            <a:off x="2395728" y="2871215"/>
+            <a:ext cx="1865376" cy="347472"/>
           </a:xfrm>
           <a:prstGeom prst="rect">
             <a:avLst/>
@@ -4791,14 +4698,14 @@
       </p:sp>
       <p:sp>
         <p:nvSpPr>
-          <p:cNvPr id="29" name="TextBox 28"/>
+          <p:cNvPr id="28" name="TextBox 27"/>
           <p:cNvSpPr txBox="1"/>
           <p:nvPr/>
         </p:nvSpPr>
         <p:spPr>
           <a:xfrm>
-            <a:off x="2231136" y="3273552"/>
-            <a:ext cx="2121408" cy="457200"/>
+            <a:off x="2432304" y="2871215"/>
+            <a:ext cx="1792223" cy="347472"/>
           </a:xfrm>
           <a:prstGeom prst="rect">
             <a:avLst/>
@@ -4818,7 +4725,7 @@
               </a:spcAft>
             </a:pPr>
             <a:r>
-              <a:rPr sz="1100" b="0">
+              <a:rPr sz="1100" b="1">
                 <a:solidFill>
                   <a:srgbClr val="0E2A47"/>
                 </a:solidFill>
@@ -4826,42 +4733,21 @@
                 <a:ea typeface="Microsoft YaHei"/>
                 <a:cs typeface="Microsoft YaHei"/>
               </a:rPr>
-              <a:t>Vera CPU</a:t>
-            </a:r>
-          </a:p>
-          <a:p>
-            <a:pPr algn="l">
-              <a:spcBef>
-                <a:spcPts val="0"/>
-              </a:spcBef>
-              <a:spcAft>
-                <a:spcPts val="0"/>
-              </a:spcAft>
-            </a:pPr>
-            <a:r>
-              <a:rPr sz="1100" b="0">
-                <a:solidFill>
-                  <a:srgbClr val="0E2A47"/>
-                </a:solidFill>
-                <a:latin typeface="Microsoft YaHei"/>
-                <a:ea typeface="Microsoft YaHei"/>
-                <a:cs typeface="Microsoft YaHei"/>
-              </a:rPr>
-              <a:t>DOCA Memos：KV 放置与存储服务</a:t>
-            </a:r>
-          </a:p>
-        </p:txBody>
-      </p:sp>
-      <p:sp>
-        <p:nvSpPr>
-          <p:cNvPr id="30" name="Rectangle 29"/>
+              <a:t>Vera CPU    DOCA Memos</a:t>
+            </a:r>
+          </a:p>
+        </p:txBody>
+      </p:sp>
+      <p:sp>
+        <p:nvSpPr>
+          <p:cNvPr id="29" name="Rectangle 28"/>
           <p:cNvSpPr/>
           <p:nvPr/>
         </p:nvSpPr>
         <p:spPr>
           <a:xfrm>
-            <a:off x="2176272" y="3785616"/>
-            <a:ext cx="2231136" cy="457200"/>
+            <a:off x="2395728" y="3328415"/>
+            <a:ext cx="1865376" cy="310896"/>
           </a:xfrm>
           <a:prstGeom prst="rect">
             <a:avLst/>
@@ -4897,14 +4783,14 @@
       </p:sp>
       <p:sp>
         <p:nvSpPr>
-          <p:cNvPr id="31" name="TextBox 30"/>
+          <p:cNvPr id="30" name="TextBox 29"/>
           <p:cNvSpPr txBox="1"/>
           <p:nvPr/>
         </p:nvSpPr>
         <p:spPr>
           <a:xfrm>
-            <a:off x="2231136" y="3785616"/>
-            <a:ext cx="2121408" cy="457200"/>
+            <a:off x="2432304" y="3328415"/>
+            <a:ext cx="1792223" cy="310896"/>
           </a:xfrm>
           <a:prstGeom prst="rect">
             <a:avLst/>
@@ -4924,7 +4810,7 @@
               </a:spcAft>
             </a:pPr>
             <a:r>
-              <a:rPr sz="1100" b="0">
+              <a:rPr sz="1100" b="1">
                 <a:solidFill>
                   <a:srgbClr val="0E2A47"/>
                 </a:solidFill>
@@ -4932,9 +4818,66 @@
                 <a:ea typeface="Microsoft YaHei"/>
                 <a:cs typeface="Microsoft YaHei"/>
               </a:rPr>
-              <a:t>ConnectX-9 SuperNIC</a:t>
-            </a:r>
-          </a:p>
+              <a:t>ConnectX-9    数据面</a:t>
+            </a:r>
+          </a:p>
+        </p:txBody>
+      </p:sp>
+      <p:cxnSp>
+        <p:nvCxnSpPr>
+          <p:cNvPr id="31" name="Connector 30"/>
+          <p:cNvCxnSpPr/>
+          <p:nvPr/>
+        </p:nvCxnSpPr>
+        <p:spPr>
+          <a:xfrm>
+            <a:off x="2770632" y="3218688"/>
+            <a:ext cx="0" cy="109727"/>
+          </a:xfrm>
+          <a:prstGeom prst="line">
+            <a:avLst/>
+          </a:prstGeom>
+          <a:ln w="28575">
+            <a:solidFill>
+              <a:srgbClr val="0E7A76"/>
+            </a:solidFill>
+            <a:tailEnd type="triangle" w="med" len="sm"/>
+          </a:ln>
+        </p:spPr>
+        <p:style>
+          <a:lnRef idx="2">
+            <a:schemeClr val="accent1"/>
+          </a:lnRef>
+          <a:fillRef idx="0">
+            <a:schemeClr val="accent1"/>
+          </a:fillRef>
+          <a:effectRef idx="1">
+            <a:schemeClr val="accent1"/>
+          </a:effectRef>
+          <a:fontRef idx="minor">
+            <a:schemeClr val="tx1"/>
+          </a:fontRef>
+        </p:style>
+      </p:cxnSp>
+      <p:sp>
+        <p:nvSpPr>
+          <p:cNvPr id="32" name="TextBox 31"/>
+          <p:cNvSpPr txBox="1"/>
+          <p:nvPr/>
+        </p:nvSpPr>
+        <p:spPr>
+          <a:xfrm>
+            <a:off x="2889504" y="3182112"/>
+            <a:ext cx="640080" cy="164592"/>
+          </a:xfrm>
+          <a:prstGeom prst="rect">
+            <a:avLst/>
+          </a:prstGeom>
+          <a:noFill/>
+        </p:spPr>
+        <p:txBody>
+          <a:bodyPr wrap="square" lIns="0" rIns="0" tIns="0" bIns="0" anchor="ctr"/>
+          <a:lstStyle/>
           <a:p>
             <a:pPr algn="l">
               <a:spcBef>
@@ -4945,59 +4888,16 @@
               </a:spcAft>
             </a:pPr>
             <a:r>
-              <a:rPr sz="1100" b="0">
-                <a:solidFill>
-                  <a:srgbClr val="0E2A47"/>
+              <a:rPr sz="1000" b="1">
+                <a:solidFill>
+                  <a:srgbClr val="0E7A76"/>
                 </a:solidFill>
                 <a:latin typeface="Microsoft YaHei"/>
                 <a:ea typeface="Microsoft YaHei"/>
                 <a:cs typeface="Microsoft YaHei"/>
               </a:rPr>
-              <a:t>NVMe-oF / RDMA，加密与 CRC</a:t>
-            </a:r>
-          </a:p>
-        </p:txBody>
-      </p:sp>
-      <p:sp>
-        <p:nvSpPr>
-          <p:cNvPr id="32" name="Right Arrow 31"/>
-          <p:cNvSpPr/>
-          <p:nvPr/>
-        </p:nvSpPr>
-        <p:spPr>
-          <a:xfrm>
-            <a:off x="4553712" y="3511296"/>
-            <a:ext cx="237744" cy="201168"/>
-          </a:xfrm>
-          <a:prstGeom prst="rightArrow">
-            <a:avLst/>
-          </a:prstGeom>
-          <a:solidFill>
-            <a:srgbClr val="0E7A76"/>
-          </a:solidFill>
-          <a:ln>
-            <a:noFill/>
-          </a:ln>
-        </p:spPr>
-        <p:style>
-          <a:lnRef idx="1">
-            <a:schemeClr val="accent1"/>
-          </a:lnRef>
-          <a:fillRef idx="3">
-            <a:schemeClr val="accent1"/>
-          </a:fillRef>
-          <a:effectRef idx="2">
-            <a:schemeClr val="accent1"/>
-          </a:effectRef>
-          <a:fontRef idx="minor">
-            <a:schemeClr val="lt1"/>
-          </a:fontRef>
-        </p:style>
-        <p:txBody>
-          <a:bodyPr rtlCol="0" anchor="ctr"/>
-          <a:lstStyle/>
-          <a:p>
-            <a:pPr algn="ctr"/>
+              <a:t>片内</a:t>
+            </a:r>
           </a:p>
         </p:txBody>
       </p:sp>
@@ -5009,8 +4909,8 @@
         </p:nvSpPr>
         <p:spPr>
           <a:xfrm>
-            <a:off x="4828032" y="1426464"/>
-            <a:ext cx="1298448" cy="2907792"/>
+            <a:off x="5532120" y="1353312"/>
+            <a:ext cx="1078992" cy="2340864"/>
           </a:xfrm>
           <a:prstGeom prst="rect">
             <a:avLst/>
@@ -5052,8 +4952,8 @@
         </p:nvSpPr>
         <p:spPr>
           <a:xfrm>
-            <a:off x="4901184" y="1572768"/>
-            <a:ext cx="1152144" cy="2377440"/>
+            <a:off x="5586983" y="1463040"/>
+            <a:ext cx="969264" cy="2011680"/>
           </a:xfrm>
           <a:prstGeom prst="rect">
             <a:avLst/>
@@ -5081,7 +4981,28 @@
                 <a:ea typeface="Microsoft YaHei"/>
                 <a:cs typeface="Microsoft YaHei"/>
               </a:rPr>
-              <a:t>铜质 Spine</a:t>
+              <a:t>铜质</a:t>
+            </a:r>
+          </a:p>
+          <a:p>
+            <a:pPr algn="l">
+              <a:spcBef>
+                <a:spcPts val="0"/>
+              </a:spcBef>
+              <a:spcAft>
+                <a:spcPts val="0"/>
+              </a:spcAft>
+            </a:pPr>
+            <a:r>
+              <a:rPr sz="1200" b="1">
+                <a:solidFill>
+                  <a:srgbClr val="FFFFFF"/>
+                </a:solidFill>
+                <a:latin typeface="Microsoft YaHei"/>
+                <a:ea typeface="Microsoft YaHei"/>
+                <a:cs typeface="Microsoft YaHei"/>
+              </a:rPr>
+              <a:t>Spine</a:t>
             </a:r>
           </a:p>
           <a:p>
@@ -5123,7 +5044,28 @@
                 <a:ea typeface="Microsoft YaHei"/>
                 <a:cs typeface="Microsoft YaHei"/>
               </a:rPr>
-              <a:t>预集成线缆盒</a:t>
+              <a:t>预集成</a:t>
+            </a:r>
+          </a:p>
+          <a:p>
+            <a:pPr algn="l">
+              <a:spcBef>
+                <a:spcPts val="0"/>
+              </a:spcBef>
+              <a:spcAft>
+                <a:spcPts val="0"/>
+              </a:spcAft>
+            </a:pPr>
+            <a:r>
+              <a:rPr sz="1200" b="1">
+                <a:solidFill>
+                  <a:srgbClr val="FFFFFF"/>
+                </a:solidFill>
+                <a:latin typeface="Microsoft YaHei"/>
+                <a:ea typeface="Microsoft YaHei"/>
+                <a:cs typeface="Microsoft YaHei"/>
+              </a:rPr>
+              <a:t>线缆盒</a:t>
             </a:r>
           </a:p>
           <a:p>
@@ -5165,7 +5107,7 @@
                 <a:ea typeface="Microsoft YaHei"/>
                 <a:cs typeface="Microsoft YaHei"/>
               </a:rPr>
-              <a:t>后端口进来</a:t>
+              <a:t>多对多</a:t>
             </a:r>
           </a:p>
           <a:p>
@@ -5186,148 +5128,21 @@
                 <a:ea typeface="Microsoft YaHei"/>
                 <a:cs typeface="Microsoft YaHei"/>
               </a:rPr>
-              <a:t/>
-            </a:r>
-          </a:p>
-          <a:p>
-            <a:pPr algn="l">
-              <a:spcBef>
-                <a:spcPts val="0"/>
-              </a:spcBef>
-              <a:spcAft>
-                <a:spcPts val="0"/>
-              </a:spcAft>
-            </a:pPr>
-            <a:r>
-              <a:rPr sz="1200" b="1">
-                <a:solidFill>
-                  <a:srgbClr val="FFFFFF"/>
-                </a:solidFill>
-                <a:latin typeface="Microsoft YaHei"/>
-                <a:ea typeface="Microsoft YaHei"/>
-                <a:cs typeface="Microsoft YaHei"/>
-              </a:rPr>
-              <a:t>托盘之间</a:t>
-            </a:r>
-          </a:p>
-          <a:p>
-            <a:pPr algn="l">
-              <a:spcBef>
-                <a:spcPts val="0"/>
-              </a:spcBef>
-              <a:spcAft>
-                <a:spcPts val="0"/>
-              </a:spcAft>
-            </a:pPr>
-            <a:r>
-              <a:rPr sz="1200" b="1">
-                <a:solidFill>
-                  <a:srgbClr val="FFFFFF"/>
-                </a:solidFill>
-                <a:latin typeface="Microsoft YaHei"/>
-                <a:ea typeface="Microsoft YaHei"/>
-                <a:cs typeface="Microsoft YaHei"/>
-              </a:rPr>
-              <a:t>多对多</a:t>
-            </a:r>
-          </a:p>
-          <a:p>
-            <a:pPr algn="l">
-              <a:spcBef>
-                <a:spcPts val="0"/>
-              </a:spcBef>
-              <a:spcAft>
-                <a:spcPts val="0"/>
-              </a:spcAft>
-            </a:pPr>
-            <a:r>
-              <a:rPr sz="1200" b="1">
-                <a:solidFill>
-                  <a:srgbClr val="FFFFFF"/>
-                </a:solidFill>
-                <a:latin typeface="Microsoft YaHei"/>
-                <a:ea typeface="Microsoft YaHei"/>
-                <a:cs typeface="Microsoft YaHei"/>
-              </a:rPr>
-              <a:t/>
-            </a:r>
-          </a:p>
-          <a:p>
-            <a:pPr algn="l">
-              <a:spcBef>
-                <a:spcPts val="0"/>
-              </a:spcBef>
-              <a:spcAft>
-                <a:spcPts val="0"/>
-              </a:spcAft>
-            </a:pPr>
-            <a:r>
-              <a:rPr sz="1200" b="1">
-                <a:solidFill>
-                  <a:srgbClr val="FFFFFF"/>
-                </a:solidFill>
-                <a:latin typeface="Microsoft YaHei"/>
-                <a:ea typeface="Microsoft YaHei"/>
-                <a:cs typeface="Microsoft YaHei"/>
-              </a:rPr>
-              <a:t>仍是一层网络</a:t>
-            </a:r>
-          </a:p>
-        </p:txBody>
-      </p:sp>
-      <p:sp>
-        <p:nvSpPr>
-          <p:cNvPr id="35" name="Right Arrow 34"/>
+              <a:t>一层网络</a:t>
+            </a:r>
+          </a:p>
+        </p:txBody>
+      </p:sp>
+      <p:sp>
+        <p:nvSpPr>
+          <p:cNvPr id="35" name="Rectangle 34"/>
           <p:cNvSpPr/>
           <p:nvPr/>
         </p:nvSpPr>
         <p:spPr>
           <a:xfrm>
-            <a:off x="6163056" y="2660904"/>
-            <a:ext cx="219456" cy="201168"/>
-          </a:xfrm>
-          <a:prstGeom prst="rightArrow">
-            <a:avLst/>
-          </a:prstGeom>
-          <a:solidFill>
-            <a:srgbClr val="0E2A47"/>
-          </a:solidFill>
-          <a:ln>
-            <a:noFill/>
-          </a:ln>
-        </p:spPr>
-        <p:style>
-          <a:lnRef idx="1">
-            <a:schemeClr val="accent1"/>
-          </a:lnRef>
-          <a:fillRef idx="3">
-            <a:schemeClr val="accent1"/>
-          </a:fillRef>
-          <a:effectRef idx="2">
-            <a:schemeClr val="accent1"/>
-          </a:effectRef>
-          <a:fontRef idx="minor">
-            <a:schemeClr val="lt1"/>
-          </a:fontRef>
-        </p:style>
-        <p:txBody>
-          <a:bodyPr rtlCol="0" anchor="ctr"/>
-          <a:lstStyle/>
-          <a:p>
-            <a:pPr algn="ctr"/>
-          </a:p>
-        </p:txBody>
-      </p:sp>
-      <p:sp>
-        <p:nvSpPr>
-          <p:cNvPr id="36" name="Rectangle 35"/>
-          <p:cNvSpPr/>
-          <p:nvPr/>
-        </p:nvSpPr>
-        <p:spPr>
-          <a:xfrm>
-            <a:off x="6419088" y="1426464"/>
-            <a:ext cx="1938528" cy="2907792"/>
+            <a:off x="7114032" y="1691640"/>
+            <a:ext cx="1207008" cy="1691640"/>
           </a:xfrm>
           <a:prstGeom prst="rect">
             <a:avLst/>
@@ -5363,14 +5178,14 @@
       </p:sp>
       <p:sp>
         <p:nvSpPr>
-          <p:cNvPr id="37" name="TextBox 36"/>
+          <p:cNvPr id="36" name="TextBox 35"/>
           <p:cNvSpPr txBox="1"/>
           <p:nvPr/>
         </p:nvSpPr>
         <p:spPr>
           <a:xfrm>
-            <a:off x="6510527" y="1536192"/>
-            <a:ext cx="1755648" cy="2651760"/>
+            <a:off x="7168896" y="1783080"/>
+            <a:ext cx="1097280" cy="1508760"/>
           </a:xfrm>
           <a:prstGeom prst="rect">
             <a:avLst/>
@@ -5390,7 +5205,7 @@
               </a:spcAft>
             </a:pPr>
             <a:r>
-              <a:rPr sz="1300" b="1">
+              <a:rPr sz="1200" b="1">
                 <a:solidFill>
                   <a:srgbClr val="FFFFFF"/>
                 </a:solidFill>
@@ -5411,7 +5226,7 @@
               </a:spcAft>
             </a:pPr>
             <a:r>
-              <a:rPr sz="1300" b="1">
+              <a:rPr sz="1200" b="1">
                 <a:solidFill>
                   <a:srgbClr val="FFFFFF"/>
                 </a:solidFill>
@@ -5419,7 +5234,7 @@
                 <a:ea typeface="Microsoft YaHei"/>
                 <a:cs typeface="Microsoft YaHei"/>
               </a:rPr>
-              <a:t>1U 交换机托盘</a:t>
+              <a:t>交换机托盘</a:t>
             </a:r>
           </a:p>
           <a:p>
@@ -5432,7 +5247,7 @@
               </a:spcAft>
             </a:pPr>
             <a:r>
-              <a:rPr sz="1300" b="1">
+              <a:rPr sz="1200" b="1">
                 <a:solidFill>
                   <a:srgbClr val="FFFFFF"/>
                 </a:solidFill>
@@ -5453,7 +5268,7 @@
               </a:spcAft>
             </a:pPr>
             <a:r>
-              <a:rPr sz="1300" b="1">
+              <a:rPr sz="1200" b="1">
                 <a:solidFill>
                   <a:srgbClr val="FFFFFF"/>
                 </a:solidFill>
@@ -5474,7 +5289,7 @@
               </a:spcAft>
             </a:pPr>
             <a:r>
-              <a:rPr sz="1300" b="1">
+              <a:rPr sz="1200" b="1">
                 <a:solidFill>
                   <a:srgbClr val="FFFFFF"/>
                 </a:solidFill>
@@ -5482,7 +5297,7 @@
                 <a:ea typeface="Microsoft YaHei"/>
                 <a:cs typeface="Microsoft YaHei"/>
               </a:rPr>
-              <a:t>后端口</a:t>
+              <a:t>后端口入</a:t>
             </a:r>
           </a:p>
           <a:p>
@@ -5495,7 +5310,7 @@
               </a:spcAft>
             </a:pPr>
             <a:r>
-              <a:rPr sz="1300" b="1">
+              <a:rPr sz="1200" b="1">
                 <a:solidFill>
                   <a:srgbClr val="FFFFFF"/>
                 </a:solidFill>
@@ -5503,84 +5318,21 @@
                 <a:ea typeface="Microsoft YaHei"/>
                 <a:cs typeface="Microsoft YaHei"/>
               </a:rPr>
-              <a:t>接铜质 Spine</a:t>
-            </a:r>
-          </a:p>
-          <a:p>
-            <a:pPr algn="l">
-              <a:spcBef>
-                <a:spcPts val="0"/>
-              </a:spcBef>
-              <a:spcAft>
-                <a:spcPts val="0"/>
-              </a:spcAft>
-            </a:pPr>
-            <a:r>
-              <a:rPr sz="1300" b="1">
-                <a:solidFill>
-                  <a:srgbClr val="FFFFFF"/>
-                </a:solidFill>
-                <a:latin typeface="Microsoft YaHei"/>
-                <a:ea typeface="Microsoft YaHei"/>
-                <a:cs typeface="Microsoft YaHei"/>
-              </a:rPr>
-              <a:t/>
-            </a:r>
-          </a:p>
-          <a:p>
-            <a:pPr algn="l">
-              <a:spcBef>
-                <a:spcPts val="0"/>
-              </a:spcBef>
-              <a:spcAft>
-                <a:spcPts val="0"/>
-              </a:spcAft>
-            </a:pPr>
-            <a:r>
-              <a:rPr sz="1300" b="1">
-                <a:solidFill>
-                  <a:srgbClr val="FFFFFF"/>
-                </a:solidFill>
-                <a:latin typeface="Microsoft YaHei"/>
-                <a:ea typeface="Microsoft YaHei"/>
-                <a:cs typeface="Microsoft YaHei"/>
-              </a:rPr>
-              <a:t>前置 32 个 OSFP</a:t>
-            </a:r>
-          </a:p>
-          <a:p>
-            <a:pPr algn="l">
-              <a:spcBef>
-                <a:spcPts val="0"/>
-              </a:spcBef>
-              <a:spcAft>
-                <a:spcPts val="0"/>
-              </a:spcAft>
-            </a:pPr>
-            <a:r>
-              <a:rPr sz="1300" b="1">
-                <a:solidFill>
-                  <a:srgbClr val="FFFFFF"/>
-                </a:solidFill>
-                <a:latin typeface="Microsoft YaHei"/>
-                <a:ea typeface="Microsoft YaHei"/>
-                <a:cs typeface="Microsoft YaHei"/>
-              </a:rPr>
-              <a:t>光口朝机架外</a:t>
-            </a:r>
-          </a:p>
-        </p:txBody>
-      </p:sp>
-      <p:sp>
-        <p:nvSpPr>
-          <p:cNvPr id="38" name="Rectangle 37"/>
+              <a:t>前置光口出</a:t>
+            </a:r>
+          </a:p>
+        </p:txBody>
+      </p:sp>
+      <p:sp>
+        <p:nvSpPr>
+          <p:cNvPr id="37" name="Rectangle 36"/>
           <p:cNvSpPr/>
           <p:nvPr/>
         </p:nvSpPr>
         <p:spPr>
           <a:xfrm>
-            <a:off x="8705088" y="1115568"/>
-            <a:ext cx="3218688" cy="3703320"/>
+            <a:off x="8732520" y="1115568"/>
+            <a:ext cx="3200400" cy="5074920"/>
           </a:xfrm>
           <a:prstGeom prst="rect">
             <a:avLst/>
@@ -5618,14 +5370,14 @@
       </p:sp>
       <p:sp>
         <p:nvSpPr>
-          <p:cNvPr id="39" name="TextBox 38"/>
+          <p:cNvPr id="38" name="TextBox 37"/>
           <p:cNvSpPr txBox="1"/>
           <p:nvPr/>
         </p:nvSpPr>
         <p:spPr>
           <a:xfrm>
-            <a:off x="8814815" y="1152144"/>
-            <a:ext cx="2999232" cy="219456"/>
+            <a:off x="8842248" y="1152144"/>
+            <a:ext cx="2980944" cy="182880"/>
           </a:xfrm>
           <a:prstGeom prst="rect">
             <a:avLst/>
@@ -5645,7 +5397,7 @@
               </a:spcAft>
             </a:pPr>
             <a:r>
-              <a:rPr sz="1200" b="1">
+              <a:rPr sz="1100" b="1">
                 <a:solidFill>
                   <a:srgbClr val="583E82"/>
                 </a:solidFill>
@@ -5653,21 +5405,21 @@
                 <a:ea typeface="Microsoft YaHei"/>
                 <a:cs typeface="Microsoft YaHei"/>
               </a:rPr>
-              <a:t>机架外  ·  单层光</a:t>
-            </a:r>
-          </a:p>
-        </p:txBody>
-      </p:sp>
-      <p:sp>
-        <p:nvSpPr>
-          <p:cNvPr id="40" name="Rectangle 39"/>
+              <a:t>机架外</a:t>
+            </a:r>
+          </a:p>
+        </p:txBody>
+      </p:sp>
+      <p:sp>
+        <p:nvSpPr>
+          <p:cNvPr id="39" name="Rectangle 38"/>
           <p:cNvSpPr/>
           <p:nvPr/>
         </p:nvSpPr>
         <p:spPr>
           <a:xfrm>
-            <a:off x="8833104" y="1444752"/>
-            <a:ext cx="2962656" cy="868680"/>
+            <a:off x="9061704" y="1691640"/>
+            <a:ext cx="2706624" cy="1051560"/>
           </a:xfrm>
           <a:prstGeom prst="rect">
             <a:avLst/>
@@ -5703,14 +5455,14 @@
       </p:sp>
       <p:sp>
         <p:nvSpPr>
-          <p:cNvPr id="41" name="TextBox 40"/>
+          <p:cNvPr id="40" name="TextBox 39"/>
           <p:cNvSpPr txBox="1"/>
           <p:nvPr/>
         </p:nvSpPr>
         <p:spPr>
           <a:xfrm>
-            <a:off x="8906256" y="1481328"/>
-            <a:ext cx="2816352" cy="256032"/>
+            <a:off x="9153144" y="1764792"/>
+            <a:ext cx="2523744" cy="256032"/>
           </a:xfrm>
           <a:prstGeom prst="rect">
             <a:avLst/>
@@ -5730,7 +5482,7 @@
               </a:spcAft>
             </a:pPr>
             <a:r>
-              <a:rPr sz="1300" b="1">
+              <a:rPr sz="1400" b="1">
                 <a:solidFill>
                   <a:srgbClr val="FFFFFF"/>
                 </a:solidFill>
@@ -5738,21 +5490,21 @@
                 <a:ea typeface="Microsoft YaHei"/>
                 <a:cs typeface="Microsoft YaHei"/>
               </a:rPr>
-              <a:t>Spectrum-6 SPX 机架</a:t>
-            </a:r>
-          </a:p>
-        </p:txBody>
-      </p:sp>
-      <p:sp>
-        <p:nvSpPr>
-          <p:cNvPr id="42" name="TextBox 41"/>
+              <a:t>Spectrum-6 SPX</a:t>
+            </a:r>
+          </a:p>
+        </p:txBody>
+      </p:sp>
+      <p:sp>
+        <p:nvSpPr>
+          <p:cNvPr id="41" name="TextBox 40"/>
           <p:cNvSpPr txBox="1"/>
           <p:nvPr/>
         </p:nvSpPr>
         <p:spPr>
           <a:xfrm>
-            <a:off x="8906256" y="1755648"/>
-            <a:ext cx="2816352" cy="475488"/>
+            <a:off x="9153144" y="2057400"/>
+            <a:ext cx="2523744" cy="585216"/>
           </a:xfrm>
           <a:prstGeom prst="rect">
             <a:avLst/>
@@ -5780,7 +5532,7 @@
                 <a:ea typeface="Microsoft YaHei"/>
                 <a:cs typeface="Microsoft YaHei"/>
               </a:rPr>
-              <a:t>POD 内机架到机架。</a:t>
+              <a:t>POD 内机架互联</a:t>
             </a:r>
           </a:p>
           <a:p>
@@ -5801,64 +5553,21 @@
                 <a:ea typeface="Microsoft YaHei"/>
                 <a:cs typeface="Microsoft YaHei"/>
               </a:rPr>
-              <a:t>东西向与南北向都从这里走。</a:t>
-            </a:r>
-          </a:p>
-        </p:txBody>
-      </p:sp>
-      <p:sp>
-        <p:nvSpPr>
-          <p:cNvPr id="43" name="Down Arrow 42"/>
+              <a:t>东西向与南北向</a:t>
+            </a:r>
+          </a:p>
+        </p:txBody>
+      </p:sp>
+      <p:sp>
+        <p:nvSpPr>
+          <p:cNvPr id="42" name="Rectangle 41"/>
           <p:cNvSpPr/>
           <p:nvPr/>
         </p:nvSpPr>
         <p:spPr>
           <a:xfrm>
-            <a:off x="10058400" y="2340864"/>
-            <a:ext cx="256032" cy="219456"/>
-          </a:xfrm>
-          <a:prstGeom prst="downArrow">
-            <a:avLst/>
-          </a:prstGeom>
-          <a:solidFill>
-            <a:srgbClr val="583E82"/>
-          </a:solidFill>
-          <a:ln>
-            <a:noFill/>
-          </a:ln>
-        </p:spPr>
-        <p:style>
-          <a:lnRef idx="1">
-            <a:schemeClr val="accent1"/>
-          </a:lnRef>
-          <a:fillRef idx="3">
-            <a:schemeClr val="accent1"/>
-          </a:fillRef>
-          <a:effectRef idx="2">
-            <a:schemeClr val="accent1"/>
-          </a:effectRef>
-          <a:fontRef idx="minor">
-            <a:schemeClr val="lt1"/>
-          </a:fontRef>
-        </p:style>
-        <p:txBody>
-          <a:bodyPr rtlCol="0" anchor="ctr"/>
-          <a:lstStyle/>
-          <a:p>
-            <a:pPr algn="ctr"/>
-          </a:p>
-        </p:txBody>
-      </p:sp>
-      <p:sp>
-        <p:nvSpPr>
-          <p:cNvPr id="44" name="Rectangle 43"/>
-          <p:cNvSpPr/>
-          <p:nvPr/>
-        </p:nvSpPr>
-        <p:spPr>
-          <a:xfrm>
-            <a:off x="8833104" y="2596896"/>
-            <a:ext cx="2962656" cy="960120"/>
+            <a:off x="8897112" y="3246120"/>
+            <a:ext cx="2871216" cy="1143000"/>
           </a:xfrm>
           <a:prstGeom prst="rect">
             <a:avLst/>
@@ -5894,14 +5603,14 @@
       </p:sp>
       <p:sp>
         <p:nvSpPr>
-          <p:cNvPr id="45" name="TextBox 44"/>
+          <p:cNvPr id="43" name="TextBox 42"/>
           <p:cNvSpPr txBox="1"/>
           <p:nvPr/>
         </p:nvSpPr>
         <p:spPr>
           <a:xfrm>
-            <a:off x="8906256" y="2633472"/>
-            <a:ext cx="2816352" cy="237744"/>
+            <a:off x="8988552" y="3319272"/>
+            <a:ext cx="2688336" cy="256032"/>
           </a:xfrm>
           <a:prstGeom prst="rect">
             <a:avLst/>
@@ -5921,7 +5630,7 @@
               </a:spcAft>
             </a:pPr>
             <a:r>
-              <a:rPr sz="1300" b="1">
+              <a:rPr sz="1400" b="1">
                 <a:solidFill>
                   <a:srgbClr val="FFFFFF"/>
                 </a:solidFill>
@@ -5936,14 +5645,14 @@
       </p:sp>
       <p:sp>
         <p:nvSpPr>
-          <p:cNvPr id="46" name="TextBox 45"/>
+          <p:cNvPr id="44" name="TextBox 43"/>
           <p:cNvSpPr txBox="1"/>
           <p:nvPr/>
         </p:nvSpPr>
         <p:spPr>
           <a:xfrm>
-            <a:off x="8906256" y="2889504"/>
-            <a:ext cx="2816352" cy="585216"/>
+            <a:off x="8988552" y="3611879"/>
+            <a:ext cx="2688336" cy="676656"/>
           </a:xfrm>
           <a:prstGeom prst="rect">
             <a:avLst/>
@@ -5971,7 +5680,7 @@
                 <a:ea typeface="Microsoft YaHei"/>
                 <a:cs typeface="Microsoft YaHei"/>
               </a:rPr>
-              <a:t>KV I/O 平面。</a:t>
+              <a:t>KV I/O 平面</a:t>
             </a:r>
           </a:p>
           <a:p>
@@ -5992,64 +5701,21 @@
                 <a:ea typeface="Microsoft YaHei"/>
                 <a:cs typeface="Microsoft YaHei"/>
               </a:rPr>
-              <a:t>终结 NVMe-oF 与对象 RDMA。</a:t>
-            </a:r>
-          </a:p>
-        </p:txBody>
-      </p:sp>
-      <p:sp>
-        <p:nvSpPr>
-          <p:cNvPr id="47" name="Down Arrow 46"/>
+              <a:t>终结 NVMe-oF 与对象 RDMA</a:t>
+            </a:r>
+          </a:p>
+        </p:txBody>
+      </p:sp>
+      <p:sp>
+        <p:nvSpPr>
+          <p:cNvPr id="45" name="Rectangle 44"/>
           <p:cNvSpPr/>
           <p:nvPr/>
         </p:nvSpPr>
         <p:spPr>
           <a:xfrm>
-            <a:off x="10058400" y="3584448"/>
-            <a:ext cx="256032" cy="219456"/>
-          </a:xfrm>
-          <a:prstGeom prst="downArrow">
-            <a:avLst/>
-          </a:prstGeom>
-          <a:solidFill>
-            <a:srgbClr val="1B6E48"/>
-          </a:solidFill>
-          <a:ln>
-            <a:noFill/>
-          </a:ln>
-        </p:spPr>
-        <p:style>
-          <a:lnRef idx="1">
-            <a:schemeClr val="accent1"/>
-          </a:lnRef>
-          <a:fillRef idx="3">
-            <a:schemeClr val="accent1"/>
-          </a:fillRef>
-          <a:effectRef idx="2">
-            <a:schemeClr val="accent1"/>
-          </a:effectRef>
-          <a:fontRef idx="minor">
-            <a:schemeClr val="lt1"/>
-          </a:fontRef>
-        </p:style>
-        <p:txBody>
-          <a:bodyPr rtlCol="0" anchor="ctr"/>
-          <a:lstStyle/>
-          <a:p>
-            <a:pPr algn="ctr"/>
-          </a:p>
-        </p:txBody>
-      </p:sp>
-      <p:sp>
-        <p:nvSpPr>
-          <p:cNvPr id="48" name="Rectangle 47"/>
-          <p:cNvSpPr/>
-          <p:nvPr/>
-        </p:nvSpPr>
-        <p:spPr>
-          <a:xfrm>
-            <a:off x="8833104" y="3840480"/>
-            <a:ext cx="2962656" cy="804672"/>
+            <a:off x="8897112" y="4846320"/>
+            <a:ext cx="2871216" cy="1051560"/>
           </a:xfrm>
           <a:prstGeom prst="rect">
             <a:avLst/>
@@ -6085,14 +5751,14 @@
       </p:sp>
       <p:sp>
         <p:nvSpPr>
-          <p:cNvPr id="49" name="TextBox 48"/>
+          <p:cNvPr id="46" name="TextBox 45"/>
           <p:cNvSpPr txBox="1"/>
           <p:nvPr/>
         </p:nvSpPr>
         <p:spPr>
           <a:xfrm>
-            <a:off x="8906256" y="3877056"/>
-            <a:ext cx="2816352" cy="237744"/>
+            <a:off x="8988552" y="4919472"/>
+            <a:ext cx="2688336" cy="256032"/>
           </a:xfrm>
           <a:prstGeom prst="rect">
             <a:avLst/>
@@ -6112,7 +5778,7 @@
               </a:spcAft>
             </a:pPr>
             <a:r>
-              <a:rPr sz="1300" b="1">
+              <a:rPr sz="1400" b="1">
                 <a:solidFill>
                   <a:srgbClr val="FFFFFF"/>
                 </a:solidFill>
@@ -6127,14 +5793,14 @@
       </p:sp>
       <p:sp>
         <p:nvSpPr>
-          <p:cNvPr id="50" name="TextBox 49"/>
+          <p:cNvPr id="47" name="TextBox 46"/>
           <p:cNvSpPr txBox="1"/>
           <p:nvPr/>
         </p:nvSpPr>
         <p:spPr>
           <a:xfrm>
-            <a:off x="8906256" y="4133087"/>
-            <a:ext cx="2816352" cy="438912"/>
+            <a:off x="8988552" y="5212080"/>
+            <a:ext cx="2688336" cy="585216"/>
           </a:xfrm>
           <a:prstGeom prst="rect">
             <a:avLst/>
@@ -6162,21 +5828,186 @@
                 <a:ea typeface="Microsoft YaHei"/>
                 <a:cs typeface="Microsoft YaHei"/>
               </a:rPr>
-              <a:t>热 KV。解码前由 CMX 预取回来。</a:t>
-            </a:r>
-          </a:p>
-        </p:txBody>
-      </p:sp>
-      <p:sp>
-        <p:nvSpPr>
-          <p:cNvPr id="51" name="Rectangle 50"/>
+              <a:t>热 KV</a:t>
+            </a:r>
+          </a:p>
+          <a:p>
+            <a:pPr algn="l">
+              <a:spcBef>
+                <a:spcPts val="0"/>
+              </a:spcBef>
+              <a:spcAft>
+                <a:spcPts val="0"/>
+              </a:spcAft>
+            </a:pPr>
+            <a:r>
+              <a:rPr sz="1200" b="0">
+                <a:solidFill>
+                  <a:srgbClr val="FFFFFF"/>
+                </a:solidFill>
+                <a:latin typeface="Microsoft YaHei"/>
+                <a:ea typeface="Microsoft YaHei"/>
+                <a:cs typeface="Microsoft YaHei"/>
+              </a:rPr>
+              <a:t>解码前从 CMX 预取</a:t>
+            </a:r>
+          </a:p>
+        </p:txBody>
+      </p:sp>
+      <p:cxnSp>
+        <p:nvCxnSpPr>
+          <p:cNvPr id="48" name="Connector 47"/>
+          <p:cNvCxnSpPr/>
+          <p:nvPr/>
+        </p:nvCxnSpPr>
+        <p:spPr>
+          <a:xfrm>
+            <a:off x="1664207" y="1892807"/>
+            <a:ext cx="603505" cy="0"/>
+          </a:xfrm>
+          <a:prstGeom prst="line">
+            <a:avLst/>
+          </a:prstGeom>
+          <a:ln w="28575">
+            <a:solidFill>
+              <a:srgbClr val="7A541C"/>
+            </a:solidFill>
+            <a:tailEnd type="triangle" w="med" len="sm"/>
+          </a:ln>
+        </p:spPr>
+        <p:style>
+          <a:lnRef idx="2">
+            <a:schemeClr val="accent1"/>
+          </a:lnRef>
+          <a:fillRef idx="0">
+            <a:schemeClr val="accent1"/>
+          </a:fillRef>
+          <a:effectRef idx="1">
+            <a:schemeClr val="accent1"/>
+          </a:effectRef>
+          <a:fontRef idx="minor">
+            <a:schemeClr val="tx1"/>
+          </a:fontRef>
+        </p:style>
+      </p:cxnSp>
+      <p:cxnSp>
+        <p:nvCxnSpPr>
+          <p:cNvPr id="49" name="Connector 48"/>
+          <p:cNvCxnSpPr/>
+          <p:nvPr/>
+        </p:nvCxnSpPr>
+        <p:spPr>
+          <a:xfrm>
+            <a:off x="4352544" y="1892807"/>
+            <a:ext cx="1179576" cy="0"/>
+          </a:xfrm>
+          <a:prstGeom prst="line">
+            <a:avLst/>
+          </a:prstGeom>
+          <a:ln w="28575">
+            <a:solidFill>
+              <a:srgbClr val="0E7A76"/>
+            </a:solidFill>
+            <a:tailEnd type="triangle" w="med" len="sm"/>
+          </a:ln>
+        </p:spPr>
+        <p:style>
+          <a:lnRef idx="2">
+            <a:schemeClr val="accent1"/>
+          </a:lnRef>
+          <a:fillRef idx="0">
+            <a:schemeClr val="accent1"/>
+          </a:fillRef>
+          <a:effectRef idx="1">
+            <a:schemeClr val="accent1"/>
+          </a:effectRef>
+          <a:fontRef idx="minor">
+            <a:schemeClr val="tx1"/>
+          </a:fontRef>
+        </p:style>
+      </p:cxnSp>
+      <p:cxnSp>
+        <p:nvCxnSpPr>
+          <p:cNvPr id="50" name="Connector 49"/>
+          <p:cNvCxnSpPr/>
+          <p:nvPr/>
+        </p:nvCxnSpPr>
+        <p:spPr>
+          <a:xfrm>
+            <a:off x="1664207" y="3154679"/>
+            <a:ext cx="603505" cy="0"/>
+          </a:xfrm>
+          <a:prstGeom prst="line">
+            <a:avLst/>
+          </a:prstGeom>
+          <a:ln w="28575">
+            <a:solidFill>
+              <a:srgbClr val="7A541C"/>
+            </a:solidFill>
+            <a:tailEnd type="triangle" w="med" len="sm"/>
+          </a:ln>
+        </p:spPr>
+        <p:style>
+          <a:lnRef idx="2">
+            <a:schemeClr val="accent1"/>
+          </a:lnRef>
+          <a:fillRef idx="0">
+            <a:schemeClr val="accent1"/>
+          </a:fillRef>
+          <a:effectRef idx="1">
+            <a:schemeClr val="accent1"/>
+          </a:effectRef>
+          <a:fontRef idx="minor">
+            <a:schemeClr val="tx1"/>
+          </a:fontRef>
+        </p:style>
+      </p:cxnSp>
+      <p:cxnSp>
+        <p:nvCxnSpPr>
+          <p:cNvPr id="51" name="Connector 50"/>
+          <p:cNvCxnSpPr/>
+          <p:nvPr/>
+        </p:nvCxnSpPr>
+        <p:spPr>
+          <a:xfrm>
+            <a:off x="4352544" y="3154679"/>
+            <a:ext cx="1179576" cy="0"/>
+          </a:xfrm>
+          <a:prstGeom prst="line">
+            <a:avLst/>
+          </a:prstGeom>
+          <a:ln w="28575">
+            <a:solidFill>
+              <a:srgbClr val="0E7A76"/>
+            </a:solidFill>
+            <a:tailEnd type="triangle" w="med" len="sm"/>
+          </a:ln>
+        </p:spPr>
+        <p:style>
+          <a:lnRef idx="2">
+            <a:schemeClr val="accent1"/>
+          </a:lnRef>
+          <a:fillRef idx="0">
+            <a:schemeClr val="accent1"/>
+          </a:fillRef>
+          <a:effectRef idx="1">
+            <a:schemeClr val="accent1"/>
+          </a:effectRef>
+          <a:fontRef idx="minor">
+            <a:schemeClr val="tx1"/>
+          </a:fontRef>
+        </p:style>
+      </p:cxnSp>
+      <p:sp>
+        <p:nvSpPr>
+          <p:cNvPr id="52" name="Rectangle 51"/>
           <p:cNvSpPr/>
           <p:nvPr/>
         </p:nvSpPr>
         <p:spPr>
           <a:xfrm>
-            <a:off x="256032" y="4956048"/>
-            <a:ext cx="3819144" cy="1261872"/>
+            <a:off x="1700784" y="2331720"/>
+            <a:ext cx="530352" cy="219456"/>
           </a:xfrm>
           <a:prstGeom prst="rect">
             <a:avLst/>
@@ -6186,7 +6017,7 @@
           </a:solidFill>
           <a:ln w="9525">
             <a:solidFill>
-              <a:srgbClr val="D6DCE2"/>
+              <a:srgbClr val="FFFFFF"/>
             </a:solidFill>
           </a:ln>
         </p:spPr>
@@ -6205,77 +6036,10 @@
           </a:fontRef>
         </p:style>
         <p:txBody>
-          <a:bodyPr rtlCol="0" anchor="ctr"/>
-          <a:lstStyle/>
-          <a:p>
-            <a:pPr algn="ctr"/>
-          </a:p>
-        </p:txBody>
-      </p:sp>
-      <p:sp>
-        <p:nvSpPr>
-          <p:cNvPr id="52" name="Rectangle 51"/>
-          <p:cNvSpPr/>
-          <p:nvPr/>
-        </p:nvSpPr>
-        <p:spPr>
-          <a:xfrm>
-            <a:off x="256032" y="4956048"/>
-            <a:ext cx="3819144" cy="73152"/>
-          </a:xfrm>
-          <a:prstGeom prst="rect">
-            <a:avLst/>
-          </a:prstGeom>
-          <a:solidFill>
-            <a:srgbClr val="7A541C"/>
-          </a:solidFill>
-          <a:ln>
-            <a:noFill/>
-          </a:ln>
-        </p:spPr>
-        <p:style>
-          <a:lnRef idx="1">
-            <a:schemeClr val="accent1"/>
-          </a:lnRef>
-          <a:fillRef idx="3">
-            <a:schemeClr val="accent1"/>
-          </a:fillRef>
-          <a:effectRef idx="2">
-            <a:schemeClr val="accent1"/>
-          </a:effectRef>
-          <a:fontRef idx="minor">
-            <a:schemeClr val="lt1"/>
-          </a:fontRef>
-        </p:style>
-        <p:txBody>
-          <a:bodyPr rtlCol="0" anchor="ctr"/>
-          <a:lstStyle/>
-          <a:p>
-            <a:pPr algn="ctr"/>
-          </a:p>
-        </p:txBody>
-      </p:sp>
-      <p:sp>
-        <p:nvSpPr>
-          <p:cNvPr id="53" name="TextBox 52"/>
-          <p:cNvSpPr txBox="1"/>
-          <p:nvPr/>
-        </p:nvSpPr>
-        <p:spPr>
-          <a:xfrm>
-            <a:off x="384048" y="5102352"/>
-            <a:ext cx="3563112" cy="237744"/>
-          </a:xfrm>
-          <a:prstGeom prst="rect">
-            <a:avLst/>
-          </a:prstGeom>
-          <a:noFill/>
-        </p:spPr>
-        <p:txBody>
-          <a:bodyPr wrap="square" lIns="0" rIns="0" tIns="0" bIns="0" anchor="ctr"/>
-          <a:lstStyle/>
-          <a:p>
-            <a:pPr algn="l">
+          <a:bodyPr rtlCol="0" anchor="ctr" wrap="square" lIns="45720" rIns="45720" tIns="18288" bIns="18288"/>
+          <a:lstStyle/>
+          <a:p>
+            <a:pPr algn="ctr">
               <a:spcBef>
                 <a:spcPts val="0"/>
               </a:spcBef>
@@ -6284,7 +6048,7 @@
               </a:spcAft>
             </a:pPr>
             <a:r>
-              <a:rPr sz="1400" b="1">
+              <a:rPr sz="1100" b="1">
                 <a:solidFill>
                   <a:srgbClr val="7A541C"/>
                 </a:solidFill>
@@ -6292,63 +6056,21 @@
                 <a:ea typeface="Microsoft YaHei"/>
                 <a:cs typeface="Microsoft YaHei"/>
               </a:rPr>
-              <a:t>盘到处理器</a:t>
-            </a:r>
-          </a:p>
-        </p:txBody>
-      </p:sp>
-      <p:sp>
-        <p:nvSpPr>
-          <p:cNvPr id="54" name="TextBox 53"/>
-          <p:cNvSpPr txBox="1"/>
-          <p:nvPr/>
-        </p:nvSpPr>
-        <p:spPr>
-          <a:xfrm>
-            <a:off x="384048" y="5376672"/>
-            <a:ext cx="3563112" cy="749808"/>
-          </a:xfrm>
-          <a:prstGeom prst="rect">
-            <a:avLst/>
-          </a:prstGeom>
-          <a:noFill/>
-        </p:spPr>
-        <p:txBody>
-          <a:bodyPr wrap="square" lIns="0" rIns="0" tIns="0" bIns="0" anchor="t"/>
-          <a:lstStyle/>
-          <a:p>
-            <a:pPr algn="l">
-              <a:spcBef>
-                <a:spcPts val="0"/>
-              </a:spcBef>
-              <a:spcAft>
-                <a:spcPts val="0"/>
-              </a:spcAft>
-            </a:pPr>
-            <a:r>
-              <a:rPr sz="1300" b="0">
-                <a:solidFill>
-                  <a:srgbClr val="1C242E"/>
-                </a:solidFill>
-                <a:latin typeface="Microsoft YaHei"/>
-                <a:ea typeface="Microsoft YaHei"/>
-                <a:cs typeface="Microsoft YaHei"/>
-              </a:rPr>
-              <a:t>NVMe 只接到本托盘的 BlueField-4。Vera CPU 跑 DOCA Memos，ConnectX-9 走数据面。</a:t>
-            </a:r>
-          </a:p>
-        </p:txBody>
-      </p:sp>
-      <p:sp>
-        <p:nvSpPr>
-          <p:cNvPr id="55" name="Rectangle 54"/>
+              <a:t>NVMe</a:t>
+            </a:r>
+          </a:p>
+        </p:txBody>
+      </p:sp>
+      <p:sp>
+        <p:nvSpPr>
+          <p:cNvPr id="53" name="Rectangle 52"/>
           <p:cNvSpPr/>
           <p:nvPr/>
         </p:nvSpPr>
         <p:spPr>
           <a:xfrm>
-            <a:off x="4184904" y="4956048"/>
-            <a:ext cx="3819144" cy="1261872"/>
+            <a:off x="4407408" y="2267712"/>
+            <a:ext cx="1060704" cy="365760"/>
           </a:xfrm>
           <a:prstGeom prst="rect">
             <a:avLst/>
@@ -6358,7 +6080,7 @@
           </a:solidFill>
           <a:ln w="9525">
             <a:solidFill>
-              <a:srgbClr val="D6DCE2"/>
+              <a:srgbClr val="FFFFFF"/>
             </a:solidFill>
           </a:ln>
         </p:spPr>
@@ -6377,77 +6099,10 @@
           </a:fontRef>
         </p:style>
         <p:txBody>
-          <a:bodyPr rtlCol="0" anchor="ctr"/>
-          <a:lstStyle/>
-          <a:p>
-            <a:pPr algn="ctr"/>
-          </a:p>
-        </p:txBody>
-      </p:sp>
-      <p:sp>
-        <p:nvSpPr>
-          <p:cNvPr id="56" name="Rectangle 55"/>
-          <p:cNvSpPr/>
-          <p:nvPr/>
-        </p:nvSpPr>
-        <p:spPr>
-          <a:xfrm>
-            <a:off x="4184904" y="4956048"/>
-            <a:ext cx="3819144" cy="73152"/>
-          </a:xfrm>
-          <a:prstGeom prst="rect">
-            <a:avLst/>
-          </a:prstGeom>
-          <a:solidFill>
-            <a:srgbClr val="0E2A47"/>
-          </a:solidFill>
-          <a:ln>
-            <a:noFill/>
-          </a:ln>
-        </p:spPr>
-        <p:style>
-          <a:lnRef idx="1">
-            <a:schemeClr val="accent1"/>
-          </a:lnRef>
-          <a:fillRef idx="3">
-            <a:schemeClr val="accent1"/>
-          </a:fillRef>
-          <a:effectRef idx="2">
-            <a:schemeClr val="accent1"/>
-          </a:effectRef>
-          <a:fontRef idx="minor">
-            <a:schemeClr val="lt1"/>
-          </a:fontRef>
-        </p:style>
-        <p:txBody>
-          <a:bodyPr rtlCol="0" anchor="ctr"/>
-          <a:lstStyle/>
-          <a:p>
-            <a:pPr algn="ctr"/>
-          </a:p>
-        </p:txBody>
-      </p:sp>
-      <p:sp>
-        <p:nvSpPr>
-          <p:cNvPr id="57" name="TextBox 56"/>
-          <p:cNvSpPr txBox="1"/>
-          <p:nvPr/>
-        </p:nvSpPr>
-        <p:spPr>
-          <a:xfrm>
-            <a:off x="4312920" y="5102352"/>
-            <a:ext cx="3563112" cy="237744"/>
-          </a:xfrm>
-          <a:prstGeom prst="rect">
-            <a:avLst/>
-          </a:prstGeom>
-          <a:noFill/>
-        </p:spPr>
-        <p:txBody>
-          <a:bodyPr wrap="square" lIns="0" rIns="0" tIns="0" bIns="0" anchor="ctr"/>
-          <a:lstStyle/>
-          <a:p>
-            <a:pPr algn="l">
+          <a:bodyPr rtlCol="0" anchor="ctr" wrap="square" lIns="45720" rIns="45720" tIns="18288" bIns="18288"/>
+          <a:lstStyle/>
+          <a:p>
+            <a:pPr algn="ctr">
               <a:spcBef>
                 <a:spcPts val="0"/>
               </a:spcBef>
@@ -6456,40 +6111,19 @@
               </a:spcAft>
             </a:pPr>
             <a:r>
-              <a:rPr sz="1400" b="1">
-                <a:solidFill>
-                  <a:srgbClr val="0E2A47"/>
+              <a:rPr sz="1100" b="1">
+                <a:solidFill>
+                  <a:srgbClr val="0E7A76"/>
                 </a:solidFill>
                 <a:latin typeface="Microsoft YaHei"/>
                 <a:ea typeface="Microsoft YaHei"/>
                 <a:cs typeface="Microsoft YaHei"/>
               </a:rPr>
-              <a:t>机架内铜缆</a:t>
-            </a:r>
-          </a:p>
-        </p:txBody>
-      </p:sp>
-      <p:sp>
-        <p:nvSpPr>
-          <p:cNvPr id="58" name="TextBox 57"/>
-          <p:cNvSpPr txBox="1"/>
-          <p:nvPr/>
-        </p:nvSpPr>
-        <p:spPr>
-          <a:xfrm>
-            <a:off x="4312920" y="5376672"/>
-            <a:ext cx="3563112" cy="749808"/>
-          </a:xfrm>
-          <a:prstGeom prst="rect">
-            <a:avLst/>
-          </a:prstGeom>
-          <a:noFill/>
-        </p:spPr>
-        <p:txBody>
-          <a:bodyPr wrap="square" lIns="0" rIns="0" tIns="0" bIns="0" anchor="t"/>
-          <a:lstStyle/>
-          <a:p>
-            <a:pPr algn="l">
+              <a:t>200 Gb/s</a:t>
+            </a:r>
+          </a:p>
+          <a:p>
+            <a:pPr algn="ctr">
               <a:spcBef>
                 <a:spcPts val="0"/>
               </a:spcBef>
@@ -6498,29 +6132,65 @@
               </a:spcAft>
             </a:pPr>
             <a:r>
-              <a:rPr sz="1300" b="0">
-                <a:solidFill>
-                  <a:srgbClr val="1C242E"/>
+              <a:rPr sz="1100" b="1">
+                <a:solidFill>
+                  <a:srgbClr val="0E7A76"/>
                 </a:solidFill>
                 <a:latin typeface="Microsoft YaHei"/>
                 <a:ea typeface="Microsoft YaHei"/>
                 <a:cs typeface="Microsoft YaHei"/>
               </a:rPr>
-              <a:t>200 Gb/s 通道经多台 Spectrum-6 交换机扇出。托盘之间多对多，仍然是一层网络。</a:t>
-            </a:r>
-          </a:p>
-        </p:txBody>
-      </p:sp>
-      <p:sp>
-        <p:nvSpPr>
-          <p:cNvPr id="59" name="Rectangle 58"/>
+              <a:t>铜缆</a:t>
+            </a:r>
+          </a:p>
+        </p:txBody>
+      </p:sp>
+      <p:cxnSp>
+        <p:nvCxnSpPr>
+          <p:cNvPr id="54" name="Connector 53"/>
+          <p:cNvCxnSpPr/>
+          <p:nvPr/>
+        </p:nvCxnSpPr>
+        <p:spPr>
+          <a:xfrm>
+            <a:off x="6611112" y="2537460"/>
+            <a:ext cx="502920" cy="0"/>
+          </a:xfrm>
+          <a:prstGeom prst="line">
+            <a:avLst/>
+          </a:prstGeom>
+          <a:ln w="28575">
+            <a:solidFill>
+              <a:srgbClr val="0E2A47"/>
+            </a:solidFill>
+            <a:tailEnd type="triangle" w="med" len="sm"/>
+          </a:ln>
+        </p:spPr>
+        <p:style>
+          <a:lnRef idx="2">
+            <a:schemeClr val="accent1"/>
+          </a:lnRef>
+          <a:fillRef idx="0">
+            <a:schemeClr val="accent1"/>
+          </a:fillRef>
+          <a:effectRef idx="1">
+            <a:schemeClr val="accent1"/>
+          </a:effectRef>
+          <a:fontRef idx="minor">
+            <a:schemeClr val="tx1"/>
+          </a:fontRef>
+        </p:style>
+      </p:cxnSp>
+      <p:sp>
+        <p:nvSpPr>
+          <p:cNvPr id="55" name="Rectangle 54"/>
           <p:cNvSpPr/>
           <p:nvPr/>
         </p:nvSpPr>
         <p:spPr>
           <a:xfrm>
-            <a:off x="8113776" y="4956048"/>
-            <a:ext cx="3819144" cy="1261872"/>
+            <a:off x="6565392" y="2208276"/>
+            <a:ext cx="530352" cy="256032"/>
           </a:xfrm>
           <a:prstGeom prst="rect">
             <a:avLst/>
@@ -6530,7 +6200,7 @@
           </a:solidFill>
           <a:ln w="9525">
             <a:solidFill>
-              <a:srgbClr val="D6DCE2"/>
+              <a:srgbClr val="FFFFFF"/>
             </a:solidFill>
           </a:ln>
         </p:spPr>
@@ -6549,32 +6219,88 @@
           </a:fontRef>
         </p:style>
         <p:txBody>
-          <a:bodyPr rtlCol="0" anchor="ctr"/>
-          <a:lstStyle/>
-          <a:p>
-            <a:pPr algn="ctr"/>
-          </a:p>
-        </p:txBody>
-      </p:sp>
-      <p:sp>
-        <p:nvSpPr>
-          <p:cNvPr id="60" name="Rectangle 59"/>
+          <a:bodyPr rtlCol="0" anchor="ctr" wrap="square" lIns="45720" rIns="45720" tIns="18288" bIns="18288"/>
+          <a:lstStyle/>
+          <a:p>
+            <a:pPr algn="ctr">
+              <a:spcBef>
+                <a:spcPts val="0"/>
+              </a:spcBef>
+              <a:spcAft>
+                <a:spcPts val="0"/>
+              </a:spcAft>
+            </a:pPr>
+            <a:r>
+              <a:rPr sz="1100" b="1">
+                <a:solidFill>
+                  <a:srgbClr val="0E2A47"/>
+                </a:solidFill>
+                <a:latin typeface="Microsoft YaHei"/>
+                <a:ea typeface="Microsoft YaHei"/>
+                <a:cs typeface="Microsoft YaHei"/>
+              </a:rPr>
+              <a:t>后端口</a:t>
+            </a:r>
+          </a:p>
+        </p:txBody>
+      </p:sp>
+      <p:cxnSp>
+        <p:nvCxnSpPr>
+          <p:cNvPr id="56" name="Connector 55"/>
+          <p:cNvCxnSpPr/>
+          <p:nvPr/>
+        </p:nvCxnSpPr>
+        <p:spPr>
+          <a:xfrm>
+            <a:off x="8321040" y="2217420"/>
+            <a:ext cx="740664" cy="0"/>
+          </a:xfrm>
+          <a:prstGeom prst="line">
+            <a:avLst/>
+          </a:prstGeom>
+          <a:ln w="28575">
+            <a:solidFill>
+              <a:srgbClr val="583E82"/>
+            </a:solidFill>
+            <a:tailEnd type="triangle" w="med" len="sm"/>
+          </a:ln>
+        </p:spPr>
+        <p:style>
+          <a:lnRef idx="2">
+            <a:schemeClr val="accent1"/>
+          </a:lnRef>
+          <a:fillRef idx="0">
+            <a:schemeClr val="accent1"/>
+          </a:fillRef>
+          <a:effectRef idx="1">
+            <a:schemeClr val="accent1"/>
+          </a:effectRef>
+          <a:fontRef idx="minor">
+            <a:schemeClr val="tx1"/>
+          </a:fontRef>
+        </p:style>
+      </p:cxnSp>
+      <p:sp>
+        <p:nvSpPr>
+          <p:cNvPr id="57" name="Rectangle 56"/>
           <p:cNvSpPr/>
           <p:nvPr/>
         </p:nvSpPr>
         <p:spPr>
           <a:xfrm>
-            <a:off x="8113776" y="4956048"/>
-            <a:ext cx="3819144" cy="73152"/>
+            <a:off x="8339327" y="2034539"/>
+            <a:ext cx="694944" cy="365760"/>
           </a:xfrm>
           <a:prstGeom prst="rect">
             <a:avLst/>
           </a:prstGeom>
           <a:solidFill>
-            <a:srgbClr val="583E82"/>
+            <a:srgbClr val="FFFFFF"/>
           </a:solidFill>
-          <a:ln>
-            <a:noFill/>
+          <a:ln w="9525">
+            <a:solidFill>
+              <a:srgbClr val="FFFFFF"/>
+            </a:solidFill>
           </a:ln>
         </p:spPr>
         <p:style>
@@ -6592,23 +6318,260 @@
           </a:fontRef>
         </p:style>
         <p:txBody>
-          <a:bodyPr rtlCol="0" anchor="ctr"/>
-          <a:lstStyle/>
-          <a:p>
-            <a:pPr algn="ctr"/>
-          </a:p>
-        </p:txBody>
-      </p:sp>
-      <p:sp>
-        <p:nvSpPr>
-          <p:cNvPr id="61" name="TextBox 60"/>
+          <a:bodyPr rtlCol="0" anchor="ctr" wrap="square" lIns="45720" rIns="45720" tIns="18288" bIns="18288"/>
+          <a:lstStyle/>
+          <a:p>
+            <a:pPr algn="ctr">
+              <a:spcBef>
+                <a:spcPts val="0"/>
+              </a:spcBef>
+              <a:spcAft>
+                <a:spcPts val="0"/>
+              </a:spcAft>
+            </a:pPr>
+            <a:r>
+              <a:rPr sz="1100" b="1">
+                <a:solidFill>
+                  <a:srgbClr val="583E82"/>
+                </a:solidFill>
+                <a:latin typeface="Microsoft YaHei"/>
+                <a:ea typeface="Microsoft YaHei"/>
+                <a:cs typeface="Microsoft YaHei"/>
+              </a:rPr>
+              <a:t>32×OSFP</a:t>
+            </a:r>
+          </a:p>
+          <a:p>
+            <a:pPr algn="ctr">
+              <a:spcBef>
+                <a:spcPts val="0"/>
+              </a:spcBef>
+              <a:spcAft>
+                <a:spcPts val="0"/>
+              </a:spcAft>
+            </a:pPr>
+            <a:r>
+              <a:rPr sz="1100" b="1">
+                <a:solidFill>
+                  <a:srgbClr val="583E82"/>
+                </a:solidFill>
+                <a:latin typeface="Microsoft YaHei"/>
+                <a:ea typeface="Microsoft YaHei"/>
+                <a:cs typeface="Microsoft YaHei"/>
+              </a:rPr>
+              <a:t>单层光</a:t>
+            </a:r>
+          </a:p>
+        </p:txBody>
+      </p:sp>
+      <p:cxnSp>
+        <p:nvCxnSpPr>
+          <p:cNvPr id="58" name="Connector 57"/>
+          <p:cNvCxnSpPr/>
+          <p:nvPr/>
+        </p:nvCxnSpPr>
+        <p:spPr>
+          <a:xfrm>
+            <a:off x="10332720" y="2743200"/>
+            <a:ext cx="0" cy="502920"/>
+          </a:xfrm>
+          <a:prstGeom prst="line">
+            <a:avLst/>
+          </a:prstGeom>
+          <a:ln w="28575">
+            <a:solidFill>
+              <a:srgbClr val="583E82"/>
+            </a:solidFill>
+            <a:tailEnd type="triangle" w="med" len="sm"/>
+          </a:ln>
+        </p:spPr>
+        <p:style>
+          <a:lnRef idx="2">
+            <a:schemeClr val="accent1"/>
+          </a:lnRef>
+          <a:fillRef idx="0">
+            <a:schemeClr val="accent1"/>
+          </a:fillRef>
+          <a:effectRef idx="1">
+            <a:schemeClr val="accent1"/>
+          </a:effectRef>
+          <a:fontRef idx="minor">
+            <a:schemeClr val="tx1"/>
+          </a:fontRef>
+        </p:style>
+      </p:cxnSp>
+      <p:sp>
+        <p:nvSpPr>
+          <p:cNvPr id="59" name="Rectangle 58"/>
+          <p:cNvSpPr/>
+          <p:nvPr/>
+        </p:nvSpPr>
+        <p:spPr>
+          <a:xfrm>
+            <a:off x="10442448" y="2866644"/>
+            <a:ext cx="566928" cy="237744"/>
+          </a:xfrm>
+          <a:prstGeom prst="rect">
+            <a:avLst/>
+          </a:prstGeom>
+          <a:solidFill>
+            <a:srgbClr val="FFFFFF"/>
+          </a:solidFill>
+          <a:ln w="9525">
+            <a:solidFill>
+              <a:srgbClr val="FFFFFF"/>
+            </a:solidFill>
+          </a:ln>
+        </p:spPr>
+        <p:style>
+          <a:lnRef idx="1">
+            <a:schemeClr val="accent1"/>
+          </a:lnRef>
+          <a:fillRef idx="3">
+            <a:schemeClr val="accent1"/>
+          </a:fillRef>
+          <a:effectRef idx="2">
+            <a:schemeClr val="accent1"/>
+          </a:effectRef>
+          <a:fontRef idx="minor">
+            <a:schemeClr val="lt1"/>
+          </a:fontRef>
+        </p:style>
+        <p:txBody>
+          <a:bodyPr rtlCol="0" anchor="ctr" wrap="square" lIns="45720" rIns="45720" tIns="18288" bIns="18288"/>
+          <a:lstStyle/>
+          <a:p>
+            <a:pPr algn="ctr">
+              <a:spcBef>
+                <a:spcPts val="0"/>
+              </a:spcBef>
+              <a:spcAft>
+                <a:spcPts val="0"/>
+              </a:spcAft>
+            </a:pPr>
+            <a:r>
+              <a:rPr sz="1100" b="1">
+                <a:solidFill>
+                  <a:srgbClr val="583E82"/>
+                </a:solidFill>
+                <a:latin typeface="Microsoft YaHei"/>
+                <a:ea typeface="Microsoft YaHei"/>
+                <a:cs typeface="Microsoft YaHei"/>
+              </a:rPr>
+              <a:t>RDMA</a:t>
+            </a:r>
+          </a:p>
+        </p:txBody>
+      </p:sp>
+      <p:cxnSp>
+        <p:nvCxnSpPr>
+          <p:cNvPr id="60" name="Connector 59"/>
+          <p:cNvCxnSpPr/>
+          <p:nvPr/>
+        </p:nvCxnSpPr>
+        <p:spPr>
+          <a:xfrm>
+            <a:off x="10332720" y="4389120"/>
+            <a:ext cx="0" cy="457200"/>
+          </a:xfrm>
+          <a:prstGeom prst="line">
+            <a:avLst/>
+          </a:prstGeom>
+          <a:ln w="28575">
+            <a:solidFill>
+              <a:srgbClr val="1B6E48"/>
+            </a:solidFill>
+            <a:tailEnd type="triangle" w="med" len="sm"/>
+          </a:ln>
+        </p:spPr>
+        <p:style>
+          <a:lnRef idx="2">
+            <a:schemeClr val="accent1"/>
+          </a:lnRef>
+          <a:fillRef idx="0">
+            <a:schemeClr val="accent1"/>
+          </a:fillRef>
+          <a:effectRef idx="1">
+            <a:schemeClr val="accent1"/>
+          </a:effectRef>
+          <a:fontRef idx="minor">
+            <a:schemeClr val="tx1"/>
+          </a:fontRef>
+        </p:style>
+      </p:cxnSp>
+      <p:sp>
+        <p:nvSpPr>
+          <p:cNvPr id="61" name="Rectangle 60"/>
+          <p:cNvSpPr/>
+          <p:nvPr/>
+        </p:nvSpPr>
+        <p:spPr>
+          <a:xfrm>
+            <a:off x="10442448" y="4489704"/>
+            <a:ext cx="658368" cy="237744"/>
+          </a:xfrm>
+          <a:prstGeom prst="rect">
+            <a:avLst/>
+          </a:prstGeom>
+          <a:solidFill>
+            <a:srgbClr val="FFFFFF"/>
+          </a:solidFill>
+          <a:ln w="9525">
+            <a:solidFill>
+              <a:srgbClr val="FFFFFF"/>
+            </a:solidFill>
+          </a:ln>
+        </p:spPr>
+        <p:style>
+          <a:lnRef idx="1">
+            <a:schemeClr val="accent1"/>
+          </a:lnRef>
+          <a:fillRef idx="3">
+            <a:schemeClr val="accent1"/>
+          </a:fillRef>
+          <a:effectRef idx="2">
+            <a:schemeClr val="accent1"/>
+          </a:effectRef>
+          <a:fontRef idx="minor">
+            <a:schemeClr val="lt1"/>
+          </a:fontRef>
+        </p:style>
+        <p:txBody>
+          <a:bodyPr rtlCol="0" anchor="ctr" wrap="square" lIns="45720" rIns="45720" tIns="18288" bIns="18288"/>
+          <a:lstStyle/>
+          <a:p>
+            <a:pPr algn="ctr">
+              <a:spcBef>
+                <a:spcPts val="0"/>
+              </a:spcBef>
+              <a:spcAft>
+                <a:spcPts val="0"/>
+              </a:spcAft>
+            </a:pPr>
+            <a:r>
+              <a:rPr sz="1100" b="1">
+                <a:solidFill>
+                  <a:srgbClr val="1B6E48"/>
+                </a:solidFill>
+                <a:latin typeface="Microsoft YaHei"/>
+                <a:ea typeface="Microsoft YaHei"/>
+                <a:cs typeface="Microsoft YaHei"/>
+              </a:rPr>
+              <a:t>KV 预取</a:t>
+            </a:r>
+          </a:p>
+        </p:txBody>
+      </p:sp>
+      <p:sp>
+        <p:nvSpPr>
+          <p:cNvPr id="62" name="TextBox 61"/>
           <p:cNvSpPr txBox="1"/>
           <p:nvPr/>
         </p:nvSpPr>
         <p:spPr>
           <a:xfrm>
-            <a:off x="8241792" y="5102352"/>
-            <a:ext cx="3563112" cy="237744"/>
+            <a:off x="292608" y="6327648"/>
+            <a:ext cx="11612880" cy="365760"/>
           </a:xfrm>
           <a:prstGeom prst="rect">
             <a:avLst/>
@@ -6628,99 +6591,15 @@
               </a:spcAft>
             </a:pPr>
             <a:r>
-              <a:rPr sz="1400" b="1">
-                <a:solidFill>
-                  <a:srgbClr val="583E82"/>
+              <a:rPr sz="1200" b="0">
+                <a:solidFill>
+                  <a:srgbClr val="5A636E"/>
                 </a:solidFill>
                 <a:latin typeface="Microsoft YaHei"/>
                 <a:ea typeface="Microsoft YaHei"/>
                 <a:cs typeface="Microsoft YaHei"/>
               </a:rPr>
-              <a:t>机架外光缆</a:t>
-            </a:r>
-          </a:p>
-        </p:txBody>
-      </p:sp>
-      <p:sp>
-        <p:nvSpPr>
-          <p:cNvPr id="62" name="TextBox 61"/>
-          <p:cNvSpPr txBox="1"/>
-          <p:nvPr/>
-        </p:nvSpPr>
-        <p:spPr>
-          <a:xfrm>
-            <a:off x="8241792" y="5376672"/>
-            <a:ext cx="3563112" cy="749808"/>
-          </a:xfrm>
-          <a:prstGeom prst="rect">
-            <a:avLst/>
-          </a:prstGeom>
-          <a:noFill/>
-        </p:spPr>
-        <p:txBody>
-          <a:bodyPr wrap="square" lIns="0" rIns="0" tIns="0" bIns="0" anchor="t"/>
-          <a:lstStyle/>
-          <a:p>
-            <a:pPr algn="l">
-              <a:spcBef>
-                <a:spcPts val="0"/>
-              </a:spcBef>
-              <a:spcAft>
-                <a:spcPts val="0"/>
-              </a:spcAft>
-            </a:pPr>
-            <a:r>
-              <a:rPr sz="1300" b="0">
-                <a:solidFill>
-                  <a:srgbClr val="1C242E"/>
-                </a:solidFill>
-                <a:latin typeface="Microsoft YaHei"/>
-                <a:ea typeface="Microsoft YaHei"/>
-                <a:cs typeface="Microsoft YaHei"/>
-              </a:rPr>
-              <a:t>BlueField-4 STX 对计算侧的端口最高 800 Gb/s。计算侧由 Dynamo 与 NIXL 安排 KV 预取。</a:t>
-            </a:r>
-          </a:p>
-        </p:txBody>
-      </p:sp>
-      <p:sp>
-        <p:nvSpPr>
-          <p:cNvPr id="63" name="TextBox 62"/>
-          <p:cNvSpPr txBox="1"/>
-          <p:nvPr/>
-        </p:nvSpPr>
-        <p:spPr>
-          <a:xfrm>
-            <a:off x="292608" y="6291072"/>
-            <a:ext cx="11612880" cy="384048"/>
-          </a:xfrm>
-          <a:prstGeom prst="rect">
-            <a:avLst/>
-          </a:prstGeom>
-          <a:noFill/>
-        </p:spPr>
-        <p:txBody>
-          <a:bodyPr wrap="square" lIns="0" rIns="0" tIns="0" bIns="0" anchor="ctr"/>
-          <a:lstStyle/>
-          <a:p>
-            <a:pPr algn="l">
-              <a:spcBef>
-                <a:spcPts val="0"/>
-              </a:spcBef>
-              <a:spcAft>
-                <a:spcPts val="0"/>
-              </a:spcAft>
-            </a:pPr>
-            <a:r>
-              <a:rPr sz="1200" b="0">
-                <a:solidFill>
-                  <a:srgbClr val="5A636E"/>
-                </a:solidFill>
-                <a:latin typeface="Microsoft YaHei"/>
-                <a:ea typeface="Microsoft YaHei"/>
-                <a:cs typeface="Microsoft YaHei"/>
-              </a:rPr>
-              <a:t>托盘数和每托盘盘数公开架构没有给出，图中只画两条托盘代表接法。STX 是 MGX ETL 存储机架，不是 NVLink 计算域。</a:t>
+              <a:t>片内连线在 BlueField-4 的 Vera CPU 与 ConnectX-9 之间。托盘数和盘数公开材料没有给出，图中两条托盘只代表接法。STX 用的是 Spectrum-X 铜缆，不是 NVLink。</a:t>
             </a:r>
           </a:p>
         </p:txBody>

</xml_diff>

<commit_message>
docs: show how the disk, Vera CPU, and ConnectX-9 connect
Replace the rack wiring slide with one diagram: NVMe attaches over PCIe Gen6, and Vera CPU meets ConnectX-9 on the same BlueField-4 STX die.

Co-authored-by: 69515164-rgb <69515164-rgb@users.noreply.github.com>
</commit_message>
<xml_diff>
--- a/docs/stx-storage-pod.pptx
+++ b/docs/stx-storage-pod.pptx
@@ -502,7 +502,7 @@
           <a:lstStyle/>
           <a:p>
             <a:r>
-              <a:t>依据 NVIDIA Vera Rubin POD 技术博客（2026-03-19）与 CMX 技术博客（2026-03-16），以及 BlueField-4 STX 存储处理器产品说明。STX 存储机架基于 MGX ETL，Spine 为 Spectrum-X 以太网铜缆，不是 NVLink。1U Spectrum-6 交换机托盘位于机架中部，后端口接铜质 Spine，前置 32 个 OSFP 以单层光连接 POD 其余部分。机架内为 Spectrum-X 多平面，200 Gb/s 通道经多台交换机扇出，节点之间多对多且仍是一层网络。BlueField-4 STX 融合 Vera CPU 与 ConnectX-9，经 Spectrum-X 连接计算，每端口最高 800 Gb/s。CMX 是跑在该架构上的 G3.5 上下文层：NVMe 闪存保存可复用 KV，计算节点上的 BlueField-4 终结 NVMe-oF 与对象 RDMA。DOCA Memos 管理 KV 放置；Dynamo 与 NIXL 安排预取。Grove 按 KV 位置放置工作负载。盘数与托盘数未公开，图不标注具体个数。</a:t>
+              <a:t>依据 BlueField-4 STX 存储处理器产品说明，以及 NVIDIA Vera Rubin POD 技术博客（2026-03-19）。BlueField-4 STX 是自托管存储处理器：Vera CPU 与 ConnectX-9 做在同一颗上，数据路径上没有另挂一颗主机 CPU。NVMe 盘接到这颗处理器的 PCIe，规格为 Gen6、96 通道。图中这根线停在处理器边界，不表示每个字节都要由 CPU 核再拷贝一次。Vera CPU 与 ConnectX-9 之间是片内连接，中间不再拉一根线缆。CPU 侧做存储处理，包括元数据、加密、压缩、完整性与恢复。网口只在 ConnectX-9 上，面向 Spectrum-X 以太网，每端口最高 800 Gb/s。数据离开这颗处理器，只从这只网口出去。</a:t>
             </a:r>
           </a:p>
         </p:txBody>
@@ -3559,8 +3559,8 @@
         </p:nvSpPr>
         <p:spPr>
           <a:xfrm>
-            <a:off x="292608" y="109728"/>
-            <a:ext cx="11521440" cy="182880"/>
+            <a:off x="365760" y="182880"/>
+            <a:ext cx="11430000" cy="219456"/>
           </a:xfrm>
           <a:prstGeom prst="rect">
             <a:avLst/>
@@ -3580,7 +3580,7 @@
               </a:spcAft>
             </a:pPr>
             <a:r>
-              <a:rPr sz="1200" b="1">
+              <a:rPr sz="1400" b="1">
                 <a:solidFill>
                   <a:srgbClr val="145A96"/>
                 </a:solidFill>
@@ -3588,7 +3588,7 @@
                 <a:ea typeface="Microsoft YaHei"/>
                 <a:cs typeface="Microsoft YaHei"/>
               </a:rPr>
-              <a:t>NVIDIA Vera Rubin POD  ·  BlueField-4 STX</a:t>
+              <a:t>BlueField-4 STX</a:t>
             </a:r>
           </a:p>
         </p:txBody>
@@ -3601,8 +3601,8 @@
         </p:nvSpPr>
         <p:spPr>
           <a:xfrm>
-            <a:off x="292608" y="292608"/>
-            <a:ext cx="11612880" cy="292608"/>
+            <a:off x="365760" y="438912"/>
+            <a:ext cx="11430000" cy="384048"/>
           </a:xfrm>
           <a:prstGeom prst="rect">
             <a:avLst/>
@@ -3622,7 +3622,7 @@
               </a:spcAft>
             </a:pPr>
             <a:r>
-              <a:rPr sz="2000" b="1">
+              <a:rPr sz="2600" b="1">
                 <a:solidFill>
                   <a:srgbClr val="0E2A47"/>
                 </a:solidFill>
@@ -3630,64 +3630,21 @@
                 <a:ea typeface="Microsoft YaHei"/>
                 <a:cs typeface="Microsoft YaHei"/>
               </a:rPr>
-              <a:t>每条线是一种连接：托盘内 NVMe，机架内铜缆，出机架单层光</a:t>
-            </a:r>
-          </a:p>
-        </p:txBody>
-      </p:sp>
-      <p:sp>
-        <p:nvSpPr>
-          <p:cNvPr id="5" name="Rectangle 4"/>
-          <p:cNvSpPr/>
+              <a:t>盘用 PCIe 接到这颗处理器，CPU 和 ConnectX-9 在片内相连</a:t>
+            </a:r>
+          </a:p>
+        </p:txBody>
+      </p:sp>
+      <p:sp>
+        <p:nvSpPr>
+          <p:cNvPr id="5" name="TextBox 4"/>
+          <p:cNvSpPr txBox="1"/>
           <p:nvPr/>
         </p:nvSpPr>
         <p:spPr>
           <a:xfrm>
-            <a:off x="292608" y="640080"/>
-            <a:ext cx="64008" cy="292608"/>
-          </a:xfrm>
-          <a:prstGeom prst="rect">
-            <a:avLst/>
-          </a:prstGeom>
-          <a:solidFill>
-            <a:srgbClr val="145A96"/>
-          </a:solidFill>
-          <a:ln>
-            <a:noFill/>
-          </a:ln>
-        </p:spPr>
-        <p:style>
-          <a:lnRef idx="1">
-            <a:schemeClr val="accent1"/>
-          </a:lnRef>
-          <a:fillRef idx="3">
-            <a:schemeClr val="accent1"/>
-          </a:fillRef>
-          <a:effectRef idx="2">
-            <a:schemeClr val="accent1"/>
-          </a:effectRef>
-          <a:fontRef idx="minor">
-            <a:schemeClr val="lt1"/>
-          </a:fontRef>
-        </p:style>
-        <p:txBody>
-          <a:bodyPr rtlCol="0" anchor="ctr"/>
-          <a:lstStyle/>
-          <a:p>
-            <a:pPr algn="ctr"/>
-          </a:p>
-        </p:txBody>
-      </p:sp>
-      <p:sp>
-        <p:nvSpPr>
-          <p:cNvPr id="6" name="TextBox 5"/>
-          <p:cNvSpPr txBox="1"/>
-          <p:nvPr/>
-        </p:nvSpPr>
-        <p:spPr>
-          <a:xfrm>
-            <a:off x="438912" y="603504"/>
-            <a:ext cx="11430000" cy="347472"/>
+            <a:off x="365760" y="914400"/>
+            <a:ext cx="11430000" cy="329184"/>
           </a:xfrm>
           <a:prstGeom prst="rect">
             <a:avLst/>
@@ -3707,7 +3664,7 @@
               </a:spcAft>
             </a:pPr>
             <a:r>
-              <a:rPr sz="1400" b="1">
+              <a:rPr sz="1600" b="0">
                 <a:solidFill>
                   <a:srgbClr val="1C242E"/>
                 </a:solidFill>
@@ -3715,21 +3672,21 @@
                 <a:ea typeface="Microsoft YaHei"/>
                 <a:cs typeface="Microsoft YaHei"/>
               </a:rPr>
-              <a:t>两条托盘的铜缆汇进同一条 Spine。交换机后端口接 Spine，前置光口离开机架，再接到计算节点。</a:t>
-            </a:r>
-          </a:p>
-        </p:txBody>
-      </p:sp>
-      <p:sp>
-        <p:nvSpPr>
-          <p:cNvPr id="7" name="Rectangle 6"/>
+              <a:t>没有另挂一颗主机 CPU。网口只在 ConnectX-9 上。</a:t>
+            </a:r>
+          </a:p>
+        </p:txBody>
+      </p:sp>
+      <p:sp>
+        <p:nvSpPr>
+          <p:cNvPr id="6" name="Rectangle 5"/>
           <p:cNvSpPr/>
           <p:nvPr/>
         </p:nvSpPr>
         <p:spPr>
           <a:xfrm>
-            <a:off x="237744" y="1115568"/>
-            <a:ext cx="8229600" cy="2788920"/>
+            <a:off x="4114800" y="1874519"/>
+            <a:ext cx="7726679" cy="2880360"/>
           </a:xfrm>
           <a:prstGeom prst="rect">
             <a:avLst/>
@@ -3767,14 +3724,14 @@
       </p:sp>
       <p:sp>
         <p:nvSpPr>
-          <p:cNvPr id="8" name="TextBox 7"/>
+          <p:cNvPr id="7" name="TextBox 6"/>
           <p:cNvSpPr txBox="1"/>
           <p:nvPr/>
         </p:nvSpPr>
         <p:spPr>
           <a:xfrm>
-            <a:off x="347472" y="1133856"/>
-            <a:ext cx="5120640" cy="182880"/>
+            <a:off x="4315968" y="1947672"/>
+            <a:ext cx="7324344" cy="292608"/>
           </a:xfrm>
           <a:prstGeom prst="rect">
             <a:avLst/>
@@ -3794,7 +3751,7 @@
               </a:spcAft>
             </a:pPr>
             <a:r>
-              <a:rPr sz="1100" b="1">
+              <a:rPr sz="1600" b="1">
                 <a:solidFill>
                   <a:srgbClr val="145A96"/>
                 </a:solidFill>
@@ -3802,21 +3759,21 @@
                 <a:ea typeface="Microsoft YaHei"/>
                 <a:cs typeface="Microsoft YaHei"/>
               </a:rPr>
-              <a:t>机架内  ·  MGX ETL</a:t>
-            </a:r>
-          </a:p>
-        </p:txBody>
-      </p:sp>
-      <p:sp>
-        <p:nvSpPr>
-          <p:cNvPr id="9" name="Rectangle 8"/>
+              <a:t>同一颗 BlueField-4 STX</a:t>
+            </a:r>
+          </a:p>
+        </p:txBody>
+      </p:sp>
+      <p:sp>
+        <p:nvSpPr>
+          <p:cNvPr id="8" name="Rectangle 7"/>
           <p:cNvSpPr/>
           <p:nvPr/>
         </p:nvSpPr>
         <p:spPr>
           <a:xfrm>
-            <a:off x="365760" y="1353312"/>
-            <a:ext cx="1298448" cy="1078992"/>
+            <a:off x="365760" y="2331720"/>
+            <a:ext cx="2240280" cy="2011680"/>
           </a:xfrm>
           <a:prstGeom prst="rect">
             <a:avLst/>
@@ -3852,14 +3809,14 @@
       </p:sp>
       <p:sp>
         <p:nvSpPr>
-          <p:cNvPr id="10" name="TextBox 9"/>
+          <p:cNvPr id="9" name="TextBox 8"/>
           <p:cNvSpPr txBox="1"/>
           <p:nvPr/>
         </p:nvSpPr>
         <p:spPr>
           <a:xfrm>
-            <a:off x="438912" y="1426464"/>
-            <a:ext cx="1152144" cy="237744"/>
+            <a:off x="493776" y="2770632"/>
+            <a:ext cx="1984248" cy="420624"/>
           </a:xfrm>
           <a:prstGeom prst="rect">
             <a:avLst/>
@@ -3879,7 +3836,7 @@
               </a:spcAft>
             </a:pPr>
             <a:r>
-              <a:rPr sz="1300" b="1">
+              <a:rPr sz="2600" b="1">
                 <a:solidFill>
                   <a:srgbClr val="FFFFFF"/>
                 </a:solidFill>
@@ -3887,21 +3844,21 @@
                 <a:ea typeface="Microsoft YaHei"/>
                 <a:cs typeface="Microsoft YaHei"/>
               </a:rPr>
-              <a:t>NVMe 闪存</a:t>
-            </a:r>
-          </a:p>
-        </p:txBody>
-      </p:sp>
-      <p:sp>
-        <p:nvSpPr>
-          <p:cNvPr id="11" name="TextBox 10"/>
+              <a:t>NVMe 盘</a:t>
+            </a:r>
+          </a:p>
+        </p:txBody>
+      </p:sp>
+      <p:sp>
+        <p:nvSpPr>
+          <p:cNvPr id="10" name="TextBox 9"/>
           <p:cNvSpPr txBox="1"/>
           <p:nvPr/>
         </p:nvSpPr>
         <p:spPr>
           <a:xfrm>
-            <a:off x="438912" y="1682495"/>
-            <a:ext cx="1152144" cy="658368"/>
+            <a:off x="493776" y="3337560"/>
+            <a:ext cx="1984248" cy="731520"/>
           </a:xfrm>
           <a:prstGeom prst="rect">
             <a:avLst/>
@@ -3921,7 +3878,7 @@
               </a:spcAft>
             </a:pPr>
             <a:r>
-              <a:rPr sz="1200" b="0">
+              <a:rPr sz="1600" b="0">
                 <a:solidFill>
                   <a:srgbClr val="FFFFFF"/>
                 </a:solidFill>
@@ -3929,108 +3886,21 @@
                 <a:ea typeface="Microsoft YaHei"/>
                 <a:cs typeface="Microsoft YaHei"/>
               </a:rPr>
-              <a:t>托盘 1</a:t>
-            </a:r>
-          </a:p>
-          <a:p>
-            <a:pPr algn="l">
-              <a:spcBef>
-                <a:spcPts val="0"/>
-              </a:spcBef>
-              <a:spcAft>
-                <a:spcPts val="0"/>
-              </a:spcAft>
-            </a:pPr>
-            <a:r>
-              <a:rPr sz="1200" b="0">
-                <a:solidFill>
-                  <a:srgbClr val="FFFFFF"/>
-                </a:solidFill>
-                <a:latin typeface="Microsoft YaHei"/>
-                <a:ea typeface="Microsoft YaHei"/>
-                <a:cs typeface="Microsoft YaHei"/>
-              </a:rPr>
-              <a:t>KV 介质</a:t>
-            </a:r>
-          </a:p>
-          <a:p>
-            <a:pPr algn="l">
-              <a:spcBef>
-                <a:spcPts val="0"/>
-              </a:spcBef>
-              <a:spcAft>
-                <a:spcPts val="0"/>
-              </a:spcAft>
-            </a:pPr>
-            <a:r>
-              <a:rPr sz="1200" b="0">
-                <a:solidFill>
-                  <a:srgbClr val="FFFFFF"/>
-                </a:solidFill>
-                <a:latin typeface="Microsoft YaHei"/>
-                <a:ea typeface="Microsoft YaHei"/>
-                <a:cs typeface="Microsoft YaHei"/>
-              </a:rPr>
-              <a:t>G3.5</a:t>
-            </a:r>
-          </a:p>
-        </p:txBody>
-      </p:sp>
-      <p:sp>
-        <p:nvSpPr>
-          <p:cNvPr id="12" name="Rectangle 11"/>
+              <a:t>KV 所在的闪存</a:t>
+            </a:r>
+          </a:p>
+        </p:txBody>
+      </p:sp>
+      <p:sp>
+        <p:nvSpPr>
+          <p:cNvPr id="11" name="Rectangle 10"/>
           <p:cNvSpPr/>
           <p:nvPr/>
         </p:nvSpPr>
         <p:spPr>
           <a:xfrm>
-            <a:off x="2267712" y="1353312"/>
-            <a:ext cx="2084831" cy="1078992"/>
-          </a:xfrm>
-          <a:prstGeom prst="rect">
-            <a:avLst/>
-          </a:prstGeom>
-          <a:solidFill>
-            <a:srgbClr val="FFFFFF"/>
-          </a:solidFill>
-          <a:ln w="9525">
-            <a:solidFill>
-              <a:srgbClr val="D6DCE2"/>
-            </a:solidFill>
-          </a:ln>
-        </p:spPr>
-        <p:style>
-          <a:lnRef idx="1">
-            <a:schemeClr val="accent1"/>
-          </a:lnRef>
-          <a:fillRef idx="3">
-            <a:schemeClr val="accent1"/>
-          </a:fillRef>
-          <a:effectRef idx="2">
-            <a:schemeClr val="accent1"/>
-          </a:effectRef>
-          <a:fontRef idx="minor">
-            <a:schemeClr val="lt1"/>
-          </a:fontRef>
-        </p:style>
-        <p:txBody>
-          <a:bodyPr rtlCol="0" anchor="ctr"/>
-          <a:lstStyle/>
-          <a:p>
-            <a:pPr algn="ctr"/>
-          </a:p>
-        </p:txBody>
-      </p:sp>
-      <p:sp>
-        <p:nvSpPr>
-          <p:cNvPr id="13" name="Rectangle 12"/>
-          <p:cNvSpPr/>
-          <p:nvPr/>
-        </p:nvSpPr>
-        <p:spPr>
-          <a:xfrm>
-            <a:off x="2267712" y="1353312"/>
-            <a:ext cx="64008" cy="1078992"/>
+            <a:off x="4434840" y="2331720"/>
+            <a:ext cx="2880360" cy="2011680"/>
           </a:xfrm>
           <a:prstGeom prst="rect">
             <a:avLst/>
@@ -4066,14 +3936,14 @@
       </p:sp>
       <p:sp>
         <p:nvSpPr>
-          <p:cNvPr id="14" name="TextBox 13"/>
+          <p:cNvPr id="12" name="TextBox 11"/>
           <p:cNvSpPr txBox="1"/>
           <p:nvPr/>
         </p:nvSpPr>
         <p:spPr>
           <a:xfrm>
-            <a:off x="2395728" y="1389888"/>
-            <a:ext cx="1883663" cy="201168"/>
+            <a:off x="4562855" y="2770632"/>
+            <a:ext cx="2624328" cy="420624"/>
           </a:xfrm>
           <a:prstGeom prst="rect">
             <a:avLst/>
@@ -4093,72 +3963,29 @@
               </a:spcAft>
             </a:pPr>
             <a:r>
-              <a:rPr sz="1200" b="1">
+              <a:rPr sz="2600" b="1">
                 <a:solidFill>
-                  <a:srgbClr val="0E7A76"/>
+                  <a:srgbClr val="FFFFFF"/>
                 </a:solidFill>
                 <a:latin typeface="Microsoft YaHei"/>
                 <a:ea typeface="Microsoft YaHei"/>
                 <a:cs typeface="Microsoft YaHei"/>
               </a:rPr>
-              <a:t>BlueField-4 STX</a:t>
-            </a:r>
-          </a:p>
-        </p:txBody>
-      </p:sp>
-      <p:sp>
-        <p:nvSpPr>
-          <p:cNvPr id="15" name="Rectangle 14"/>
-          <p:cNvSpPr/>
+              <a:t>Vera CPU</a:t>
+            </a:r>
+          </a:p>
+        </p:txBody>
+      </p:sp>
+      <p:sp>
+        <p:nvSpPr>
+          <p:cNvPr id="13" name="TextBox 12"/>
+          <p:cNvSpPr txBox="1"/>
           <p:nvPr/>
         </p:nvSpPr>
         <p:spPr>
           <a:xfrm>
-            <a:off x="2395728" y="1609344"/>
-            <a:ext cx="1865376" cy="347472"/>
-          </a:xfrm>
-          <a:prstGeom prst="rect">
-            <a:avLst/>
-          </a:prstGeom>
-          <a:solidFill>
-            <a:srgbClr val="E8F3F2"/>
-          </a:solidFill>
-          <a:ln>
-            <a:noFill/>
-          </a:ln>
-        </p:spPr>
-        <p:style>
-          <a:lnRef idx="1">
-            <a:schemeClr val="accent1"/>
-          </a:lnRef>
-          <a:fillRef idx="3">
-            <a:schemeClr val="accent1"/>
-          </a:fillRef>
-          <a:effectRef idx="2">
-            <a:schemeClr val="accent1"/>
-          </a:effectRef>
-          <a:fontRef idx="minor">
-            <a:schemeClr val="lt1"/>
-          </a:fontRef>
-        </p:style>
-        <p:txBody>
-          <a:bodyPr rtlCol="0" anchor="ctr"/>
-          <a:lstStyle/>
-          <a:p>
-            <a:pPr algn="ctr"/>
-          </a:p>
-        </p:txBody>
-      </p:sp>
-      <p:sp>
-        <p:nvSpPr>
-          <p:cNvPr id="16" name="TextBox 15"/>
-          <p:cNvSpPr txBox="1"/>
-          <p:nvPr/>
-        </p:nvSpPr>
-        <p:spPr>
-          <a:xfrm>
-            <a:off x="2432304" y="1609344"/>
-            <a:ext cx="1792223" cy="347472"/>
+            <a:off x="4562855" y="3337560"/>
+            <a:ext cx="2624328" cy="731520"/>
           </a:xfrm>
           <a:prstGeom prst="rect">
             <a:avLst/>
@@ -4166,7 +3993,7 @@
           <a:noFill/>
         </p:spPr>
         <p:txBody>
-          <a:bodyPr wrap="square" lIns="0" rIns="0" tIns="0" bIns="0" anchor="ctr"/>
+          <a:bodyPr wrap="square" lIns="0" rIns="0" tIns="0" bIns="0" anchor="t"/>
           <a:lstStyle/>
           <a:p>
             <a:pPr algn="l">
@@ -4178,81 +4005,17 @@
               </a:spcAft>
             </a:pPr>
             <a:r>
-              <a:rPr sz="1100" b="1">
+              <a:rPr sz="1600" b="0">
                 <a:solidFill>
-                  <a:srgbClr val="0E2A47"/>
+                  <a:srgbClr val="FFFFFF"/>
                 </a:solidFill>
                 <a:latin typeface="Microsoft YaHei"/>
                 <a:ea typeface="Microsoft YaHei"/>
                 <a:cs typeface="Microsoft YaHei"/>
               </a:rPr>
-              <a:t>Vera CPU    DOCA Memos</a:t>
-            </a:r>
-          </a:p>
-        </p:txBody>
-      </p:sp>
-      <p:sp>
-        <p:nvSpPr>
-          <p:cNvPr id="17" name="Rectangle 16"/>
-          <p:cNvSpPr/>
-          <p:nvPr/>
-        </p:nvSpPr>
-        <p:spPr>
-          <a:xfrm>
-            <a:off x="2395728" y="2066543"/>
-            <a:ext cx="1865376" cy="310896"/>
-          </a:xfrm>
-          <a:prstGeom prst="rect">
-            <a:avLst/>
-          </a:prstGeom>
-          <a:solidFill>
-            <a:srgbClr val="E2ECF6"/>
-          </a:solidFill>
-          <a:ln>
-            <a:noFill/>
-          </a:ln>
-        </p:spPr>
-        <p:style>
-          <a:lnRef idx="1">
-            <a:schemeClr val="accent1"/>
-          </a:lnRef>
-          <a:fillRef idx="3">
-            <a:schemeClr val="accent1"/>
-          </a:fillRef>
-          <a:effectRef idx="2">
-            <a:schemeClr val="accent1"/>
-          </a:effectRef>
-          <a:fontRef idx="minor">
-            <a:schemeClr val="lt1"/>
-          </a:fontRef>
-        </p:style>
-        <p:txBody>
-          <a:bodyPr rtlCol="0" anchor="ctr"/>
-          <a:lstStyle/>
-          <a:p>
-            <a:pPr algn="ctr"/>
-          </a:p>
-        </p:txBody>
-      </p:sp>
-      <p:sp>
-        <p:nvSpPr>
-          <p:cNvPr id="18" name="TextBox 17"/>
-          <p:cNvSpPr txBox="1"/>
-          <p:nvPr/>
-        </p:nvSpPr>
-        <p:spPr>
-          <a:xfrm>
-            <a:off x="2432304" y="2066543"/>
-            <a:ext cx="1792223" cy="310896"/>
-          </a:xfrm>
-          <a:prstGeom prst="rect">
-            <a:avLst/>
-          </a:prstGeom>
-          <a:noFill/>
-        </p:spPr>
-        <p:txBody>
-          <a:bodyPr wrap="square" lIns="0" rIns="0" tIns="0" bIns="0" anchor="ctr"/>
-          <a:lstStyle/>
+              <a:t>存储处理</a:t>
+            </a:r>
+          </a:p>
           <a:p>
             <a:pPr algn="l">
               <a:spcBef>
@@ -4263,170 +4026,7 @@
               </a:spcAft>
             </a:pPr>
             <a:r>
-              <a:rPr sz="1100" b="1">
-                <a:solidFill>
-                  <a:srgbClr val="0E2A47"/>
-                </a:solidFill>
-                <a:latin typeface="Microsoft YaHei"/>
-                <a:ea typeface="Microsoft YaHei"/>
-                <a:cs typeface="Microsoft YaHei"/>
-              </a:rPr>
-              <a:t>ConnectX-9    数据面</a:t>
-            </a:r>
-          </a:p>
-        </p:txBody>
-      </p:sp>
-      <p:cxnSp>
-        <p:nvCxnSpPr>
-          <p:cNvPr id="19" name="Connector 18"/>
-          <p:cNvCxnSpPr/>
-          <p:nvPr/>
-        </p:nvCxnSpPr>
-        <p:spPr>
-          <a:xfrm>
-            <a:off x="2770632" y="1956816"/>
-            <a:ext cx="0" cy="109727"/>
-          </a:xfrm>
-          <a:prstGeom prst="line">
-            <a:avLst/>
-          </a:prstGeom>
-          <a:ln w="28575">
-            <a:solidFill>
-              <a:srgbClr val="0E7A76"/>
-            </a:solidFill>
-            <a:tailEnd type="triangle" w="med" len="sm"/>
-          </a:ln>
-        </p:spPr>
-        <p:style>
-          <a:lnRef idx="2">
-            <a:schemeClr val="accent1"/>
-          </a:lnRef>
-          <a:fillRef idx="0">
-            <a:schemeClr val="accent1"/>
-          </a:fillRef>
-          <a:effectRef idx="1">
-            <a:schemeClr val="accent1"/>
-          </a:effectRef>
-          <a:fontRef idx="minor">
-            <a:schemeClr val="tx1"/>
-          </a:fontRef>
-        </p:style>
-      </p:cxnSp>
-      <p:sp>
-        <p:nvSpPr>
-          <p:cNvPr id="20" name="TextBox 19"/>
-          <p:cNvSpPr txBox="1"/>
-          <p:nvPr/>
-        </p:nvSpPr>
-        <p:spPr>
-          <a:xfrm>
-            <a:off x="2889504" y="1920240"/>
-            <a:ext cx="640080" cy="164592"/>
-          </a:xfrm>
-          <a:prstGeom prst="rect">
-            <a:avLst/>
-          </a:prstGeom>
-          <a:noFill/>
-        </p:spPr>
-        <p:txBody>
-          <a:bodyPr wrap="square" lIns="0" rIns="0" tIns="0" bIns="0" anchor="ctr"/>
-          <a:lstStyle/>
-          <a:p>
-            <a:pPr algn="l">
-              <a:spcBef>
-                <a:spcPts val="0"/>
-              </a:spcBef>
-              <a:spcAft>
-                <a:spcPts val="0"/>
-              </a:spcAft>
-            </a:pPr>
-            <a:r>
-              <a:rPr sz="1000" b="1">
-                <a:solidFill>
-                  <a:srgbClr val="0E7A76"/>
-                </a:solidFill>
-                <a:latin typeface="Microsoft YaHei"/>
-                <a:ea typeface="Microsoft YaHei"/>
-                <a:cs typeface="Microsoft YaHei"/>
-              </a:rPr>
-              <a:t>片内</a:t>
-            </a:r>
-          </a:p>
-        </p:txBody>
-      </p:sp>
-      <p:sp>
-        <p:nvSpPr>
-          <p:cNvPr id="21" name="Rectangle 20"/>
-          <p:cNvSpPr/>
-          <p:nvPr/>
-        </p:nvSpPr>
-        <p:spPr>
-          <a:xfrm>
-            <a:off x="365760" y="2615184"/>
-            <a:ext cx="1298448" cy="1078992"/>
-          </a:xfrm>
-          <a:prstGeom prst="rect">
-            <a:avLst/>
-          </a:prstGeom>
-          <a:solidFill>
-            <a:srgbClr val="7A541C"/>
-          </a:solidFill>
-          <a:ln>
-            <a:noFill/>
-          </a:ln>
-        </p:spPr>
-        <p:style>
-          <a:lnRef idx="1">
-            <a:schemeClr val="accent1"/>
-          </a:lnRef>
-          <a:fillRef idx="3">
-            <a:schemeClr val="accent1"/>
-          </a:fillRef>
-          <a:effectRef idx="2">
-            <a:schemeClr val="accent1"/>
-          </a:effectRef>
-          <a:fontRef idx="minor">
-            <a:schemeClr val="lt1"/>
-          </a:fontRef>
-        </p:style>
-        <p:txBody>
-          <a:bodyPr rtlCol="0" anchor="ctr"/>
-          <a:lstStyle/>
-          <a:p>
-            <a:pPr algn="ctr"/>
-          </a:p>
-        </p:txBody>
-      </p:sp>
-      <p:sp>
-        <p:nvSpPr>
-          <p:cNvPr id="22" name="TextBox 21"/>
-          <p:cNvSpPr txBox="1"/>
-          <p:nvPr/>
-        </p:nvSpPr>
-        <p:spPr>
-          <a:xfrm>
-            <a:off x="438912" y="2688336"/>
-            <a:ext cx="1152144" cy="237744"/>
-          </a:xfrm>
-          <a:prstGeom prst="rect">
-            <a:avLst/>
-          </a:prstGeom>
-          <a:noFill/>
-        </p:spPr>
-        <p:txBody>
-          <a:bodyPr wrap="square" lIns="0" rIns="0" tIns="0" bIns="0" anchor="ctr"/>
-          <a:lstStyle/>
-          <a:p>
-            <a:pPr algn="l">
-              <a:spcBef>
-                <a:spcPts val="0"/>
-              </a:spcBef>
-              <a:spcAft>
-                <a:spcPts val="0"/>
-              </a:spcAft>
-            </a:pPr>
-            <a:r>
-              <a:rPr sz="1300" b="1">
+              <a:rPr sz="1600" b="0">
                 <a:solidFill>
                   <a:srgbClr val="FFFFFF"/>
                 </a:solidFill>
@@ -4434,715 +4034,21 @@
                 <a:ea typeface="Microsoft YaHei"/>
                 <a:cs typeface="Microsoft YaHei"/>
               </a:rPr>
-              <a:t>NVMe 闪存</a:t>
-            </a:r>
-          </a:p>
-        </p:txBody>
-      </p:sp>
-      <p:sp>
-        <p:nvSpPr>
-          <p:cNvPr id="23" name="TextBox 22"/>
-          <p:cNvSpPr txBox="1"/>
+              <a:t>元数据、加密、压缩</a:t>
+            </a:r>
+          </a:p>
+        </p:txBody>
+      </p:sp>
+      <p:sp>
+        <p:nvSpPr>
+          <p:cNvPr id="14" name="Rectangle 13"/>
+          <p:cNvSpPr/>
           <p:nvPr/>
         </p:nvSpPr>
         <p:spPr>
           <a:xfrm>
-            <a:off x="438912" y="2944368"/>
-            <a:ext cx="1152144" cy="658368"/>
-          </a:xfrm>
-          <a:prstGeom prst="rect">
-            <a:avLst/>
-          </a:prstGeom>
-          <a:noFill/>
-        </p:spPr>
-        <p:txBody>
-          <a:bodyPr wrap="square" lIns="0" rIns="0" tIns="0" bIns="0" anchor="t"/>
-          <a:lstStyle/>
-          <a:p>
-            <a:pPr algn="l">
-              <a:spcBef>
-                <a:spcPts val="0"/>
-              </a:spcBef>
-              <a:spcAft>
-                <a:spcPts val="0"/>
-              </a:spcAft>
-            </a:pPr>
-            <a:r>
-              <a:rPr sz="1200" b="0">
-                <a:solidFill>
-                  <a:srgbClr val="FFFFFF"/>
-                </a:solidFill>
-                <a:latin typeface="Microsoft YaHei"/>
-                <a:ea typeface="Microsoft YaHei"/>
-                <a:cs typeface="Microsoft YaHei"/>
-              </a:rPr>
-              <a:t>托盘 2</a:t>
-            </a:r>
-          </a:p>
-          <a:p>
-            <a:pPr algn="l">
-              <a:spcBef>
-                <a:spcPts val="0"/>
-              </a:spcBef>
-              <a:spcAft>
-                <a:spcPts val="0"/>
-              </a:spcAft>
-            </a:pPr>
-            <a:r>
-              <a:rPr sz="1200" b="0">
-                <a:solidFill>
-                  <a:srgbClr val="FFFFFF"/>
-                </a:solidFill>
-                <a:latin typeface="Microsoft YaHei"/>
-                <a:ea typeface="Microsoft YaHei"/>
-                <a:cs typeface="Microsoft YaHei"/>
-              </a:rPr>
-              <a:t>KV 介质</a:t>
-            </a:r>
-          </a:p>
-          <a:p>
-            <a:pPr algn="l">
-              <a:spcBef>
-                <a:spcPts val="0"/>
-              </a:spcBef>
-              <a:spcAft>
-                <a:spcPts val="0"/>
-              </a:spcAft>
-            </a:pPr>
-            <a:r>
-              <a:rPr sz="1200" b="0">
-                <a:solidFill>
-                  <a:srgbClr val="FFFFFF"/>
-                </a:solidFill>
-                <a:latin typeface="Microsoft YaHei"/>
-                <a:ea typeface="Microsoft YaHei"/>
-                <a:cs typeface="Microsoft YaHei"/>
-              </a:rPr>
-              <a:t>G3.5</a:t>
-            </a:r>
-          </a:p>
-        </p:txBody>
-      </p:sp>
-      <p:sp>
-        <p:nvSpPr>
-          <p:cNvPr id="24" name="Rectangle 23"/>
-          <p:cNvSpPr/>
-          <p:nvPr/>
-        </p:nvSpPr>
-        <p:spPr>
-          <a:xfrm>
-            <a:off x="2267712" y="2615184"/>
-            <a:ext cx="2084831" cy="1078992"/>
-          </a:xfrm>
-          <a:prstGeom prst="rect">
-            <a:avLst/>
-          </a:prstGeom>
-          <a:solidFill>
-            <a:srgbClr val="FFFFFF"/>
-          </a:solidFill>
-          <a:ln w="9525">
-            <a:solidFill>
-              <a:srgbClr val="D6DCE2"/>
-            </a:solidFill>
-          </a:ln>
-        </p:spPr>
-        <p:style>
-          <a:lnRef idx="1">
-            <a:schemeClr val="accent1"/>
-          </a:lnRef>
-          <a:fillRef idx="3">
-            <a:schemeClr val="accent1"/>
-          </a:fillRef>
-          <a:effectRef idx="2">
-            <a:schemeClr val="accent1"/>
-          </a:effectRef>
-          <a:fontRef idx="minor">
-            <a:schemeClr val="lt1"/>
-          </a:fontRef>
-        </p:style>
-        <p:txBody>
-          <a:bodyPr rtlCol="0" anchor="ctr"/>
-          <a:lstStyle/>
-          <a:p>
-            <a:pPr algn="ctr"/>
-          </a:p>
-        </p:txBody>
-      </p:sp>
-      <p:sp>
-        <p:nvSpPr>
-          <p:cNvPr id="25" name="Rectangle 24"/>
-          <p:cNvSpPr/>
-          <p:nvPr/>
-        </p:nvSpPr>
-        <p:spPr>
-          <a:xfrm>
-            <a:off x="2267712" y="2615184"/>
-            <a:ext cx="64008" cy="1078992"/>
-          </a:xfrm>
-          <a:prstGeom prst="rect">
-            <a:avLst/>
-          </a:prstGeom>
-          <a:solidFill>
-            <a:srgbClr val="0E7A76"/>
-          </a:solidFill>
-          <a:ln>
-            <a:noFill/>
-          </a:ln>
-        </p:spPr>
-        <p:style>
-          <a:lnRef idx="1">
-            <a:schemeClr val="accent1"/>
-          </a:lnRef>
-          <a:fillRef idx="3">
-            <a:schemeClr val="accent1"/>
-          </a:fillRef>
-          <a:effectRef idx="2">
-            <a:schemeClr val="accent1"/>
-          </a:effectRef>
-          <a:fontRef idx="minor">
-            <a:schemeClr val="lt1"/>
-          </a:fontRef>
-        </p:style>
-        <p:txBody>
-          <a:bodyPr rtlCol="0" anchor="ctr"/>
-          <a:lstStyle/>
-          <a:p>
-            <a:pPr algn="ctr"/>
-          </a:p>
-        </p:txBody>
-      </p:sp>
-      <p:sp>
-        <p:nvSpPr>
-          <p:cNvPr id="26" name="TextBox 25"/>
-          <p:cNvSpPr txBox="1"/>
-          <p:nvPr/>
-        </p:nvSpPr>
-        <p:spPr>
-          <a:xfrm>
-            <a:off x="2395728" y="2651760"/>
-            <a:ext cx="1883663" cy="201168"/>
-          </a:xfrm>
-          <a:prstGeom prst="rect">
-            <a:avLst/>
-          </a:prstGeom>
-          <a:noFill/>
-        </p:spPr>
-        <p:txBody>
-          <a:bodyPr wrap="square" lIns="0" rIns="0" tIns="0" bIns="0" anchor="ctr"/>
-          <a:lstStyle/>
-          <a:p>
-            <a:pPr algn="l">
-              <a:spcBef>
-                <a:spcPts val="0"/>
-              </a:spcBef>
-              <a:spcAft>
-                <a:spcPts val="0"/>
-              </a:spcAft>
-            </a:pPr>
-            <a:r>
-              <a:rPr sz="1200" b="1">
-                <a:solidFill>
-                  <a:srgbClr val="0E7A76"/>
-                </a:solidFill>
-                <a:latin typeface="Microsoft YaHei"/>
-                <a:ea typeface="Microsoft YaHei"/>
-                <a:cs typeface="Microsoft YaHei"/>
-              </a:rPr>
-              <a:t>BlueField-4 STX</a:t>
-            </a:r>
-          </a:p>
-        </p:txBody>
-      </p:sp>
-      <p:sp>
-        <p:nvSpPr>
-          <p:cNvPr id="27" name="Rectangle 26"/>
-          <p:cNvSpPr/>
-          <p:nvPr/>
-        </p:nvSpPr>
-        <p:spPr>
-          <a:xfrm>
-            <a:off x="2395728" y="2871215"/>
-            <a:ext cx="1865376" cy="347472"/>
-          </a:xfrm>
-          <a:prstGeom prst="rect">
-            <a:avLst/>
-          </a:prstGeom>
-          <a:solidFill>
-            <a:srgbClr val="E8F3F2"/>
-          </a:solidFill>
-          <a:ln>
-            <a:noFill/>
-          </a:ln>
-        </p:spPr>
-        <p:style>
-          <a:lnRef idx="1">
-            <a:schemeClr val="accent1"/>
-          </a:lnRef>
-          <a:fillRef idx="3">
-            <a:schemeClr val="accent1"/>
-          </a:fillRef>
-          <a:effectRef idx="2">
-            <a:schemeClr val="accent1"/>
-          </a:effectRef>
-          <a:fontRef idx="minor">
-            <a:schemeClr val="lt1"/>
-          </a:fontRef>
-        </p:style>
-        <p:txBody>
-          <a:bodyPr rtlCol="0" anchor="ctr"/>
-          <a:lstStyle/>
-          <a:p>
-            <a:pPr algn="ctr"/>
-          </a:p>
-        </p:txBody>
-      </p:sp>
-      <p:sp>
-        <p:nvSpPr>
-          <p:cNvPr id="28" name="TextBox 27"/>
-          <p:cNvSpPr txBox="1"/>
-          <p:nvPr/>
-        </p:nvSpPr>
-        <p:spPr>
-          <a:xfrm>
-            <a:off x="2432304" y="2871215"/>
-            <a:ext cx="1792223" cy="347472"/>
-          </a:xfrm>
-          <a:prstGeom prst="rect">
-            <a:avLst/>
-          </a:prstGeom>
-          <a:noFill/>
-        </p:spPr>
-        <p:txBody>
-          <a:bodyPr wrap="square" lIns="0" rIns="0" tIns="0" bIns="0" anchor="ctr"/>
-          <a:lstStyle/>
-          <a:p>
-            <a:pPr algn="l">
-              <a:spcBef>
-                <a:spcPts val="0"/>
-              </a:spcBef>
-              <a:spcAft>
-                <a:spcPts val="0"/>
-              </a:spcAft>
-            </a:pPr>
-            <a:r>
-              <a:rPr sz="1100" b="1">
-                <a:solidFill>
-                  <a:srgbClr val="0E2A47"/>
-                </a:solidFill>
-                <a:latin typeface="Microsoft YaHei"/>
-                <a:ea typeface="Microsoft YaHei"/>
-                <a:cs typeface="Microsoft YaHei"/>
-              </a:rPr>
-              <a:t>Vera CPU    DOCA Memos</a:t>
-            </a:r>
-          </a:p>
-        </p:txBody>
-      </p:sp>
-      <p:sp>
-        <p:nvSpPr>
-          <p:cNvPr id="29" name="Rectangle 28"/>
-          <p:cNvSpPr/>
-          <p:nvPr/>
-        </p:nvSpPr>
-        <p:spPr>
-          <a:xfrm>
-            <a:off x="2395728" y="3328415"/>
-            <a:ext cx="1865376" cy="310896"/>
-          </a:xfrm>
-          <a:prstGeom prst="rect">
-            <a:avLst/>
-          </a:prstGeom>
-          <a:solidFill>
-            <a:srgbClr val="E2ECF6"/>
-          </a:solidFill>
-          <a:ln>
-            <a:noFill/>
-          </a:ln>
-        </p:spPr>
-        <p:style>
-          <a:lnRef idx="1">
-            <a:schemeClr val="accent1"/>
-          </a:lnRef>
-          <a:fillRef idx="3">
-            <a:schemeClr val="accent1"/>
-          </a:fillRef>
-          <a:effectRef idx="2">
-            <a:schemeClr val="accent1"/>
-          </a:effectRef>
-          <a:fontRef idx="minor">
-            <a:schemeClr val="lt1"/>
-          </a:fontRef>
-        </p:style>
-        <p:txBody>
-          <a:bodyPr rtlCol="0" anchor="ctr"/>
-          <a:lstStyle/>
-          <a:p>
-            <a:pPr algn="ctr"/>
-          </a:p>
-        </p:txBody>
-      </p:sp>
-      <p:sp>
-        <p:nvSpPr>
-          <p:cNvPr id="30" name="TextBox 29"/>
-          <p:cNvSpPr txBox="1"/>
-          <p:nvPr/>
-        </p:nvSpPr>
-        <p:spPr>
-          <a:xfrm>
-            <a:off x="2432304" y="3328415"/>
-            <a:ext cx="1792223" cy="310896"/>
-          </a:xfrm>
-          <a:prstGeom prst="rect">
-            <a:avLst/>
-          </a:prstGeom>
-          <a:noFill/>
-        </p:spPr>
-        <p:txBody>
-          <a:bodyPr wrap="square" lIns="0" rIns="0" tIns="0" bIns="0" anchor="ctr"/>
-          <a:lstStyle/>
-          <a:p>
-            <a:pPr algn="l">
-              <a:spcBef>
-                <a:spcPts val="0"/>
-              </a:spcBef>
-              <a:spcAft>
-                <a:spcPts val="0"/>
-              </a:spcAft>
-            </a:pPr>
-            <a:r>
-              <a:rPr sz="1100" b="1">
-                <a:solidFill>
-                  <a:srgbClr val="0E2A47"/>
-                </a:solidFill>
-                <a:latin typeface="Microsoft YaHei"/>
-                <a:ea typeface="Microsoft YaHei"/>
-                <a:cs typeface="Microsoft YaHei"/>
-              </a:rPr>
-              <a:t>ConnectX-9    数据面</a:t>
-            </a:r>
-          </a:p>
-        </p:txBody>
-      </p:sp>
-      <p:cxnSp>
-        <p:nvCxnSpPr>
-          <p:cNvPr id="31" name="Connector 30"/>
-          <p:cNvCxnSpPr/>
-          <p:nvPr/>
-        </p:nvCxnSpPr>
-        <p:spPr>
-          <a:xfrm>
-            <a:off x="2770632" y="3218688"/>
-            <a:ext cx="0" cy="109727"/>
-          </a:xfrm>
-          <a:prstGeom prst="line">
-            <a:avLst/>
-          </a:prstGeom>
-          <a:ln w="28575">
-            <a:solidFill>
-              <a:srgbClr val="0E7A76"/>
-            </a:solidFill>
-            <a:tailEnd type="triangle" w="med" len="sm"/>
-          </a:ln>
-        </p:spPr>
-        <p:style>
-          <a:lnRef idx="2">
-            <a:schemeClr val="accent1"/>
-          </a:lnRef>
-          <a:fillRef idx="0">
-            <a:schemeClr val="accent1"/>
-          </a:fillRef>
-          <a:effectRef idx="1">
-            <a:schemeClr val="accent1"/>
-          </a:effectRef>
-          <a:fontRef idx="minor">
-            <a:schemeClr val="tx1"/>
-          </a:fontRef>
-        </p:style>
-      </p:cxnSp>
-      <p:sp>
-        <p:nvSpPr>
-          <p:cNvPr id="32" name="TextBox 31"/>
-          <p:cNvSpPr txBox="1"/>
-          <p:nvPr/>
-        </p:nvSpPr>
-        <p:spPr>
-          <a:xfrm>
-            <a:off x="2889504" y="3182112"/>
-            <a:ext cx="640080" cy="164592"/>
-          </a:xfrm>
-          <a:prstGeom prst="rect">
-            <a:avLst/>
-          </a:prstGeom>
-          <a:noFill/>
-        </p:spPr>
-        <p:txBody>
-          <a:bodyPr wrap="square" lIns="0" rIns="0" tIns="0" bIns="0" anchor="ctr"/>
-          <a:lstStyle/>
-          <a:p>
-            <a:pPr algn="l">
-              <a:spcBef>
-                <a:spcPts val="0"/>
-              </a:spcBef>
-              <a:spcAft>
-                <a:spcPts val="0"/>
-              </a:spcAft>
-            </a:pPr>
-            <a:r>
-              <a:rPr sz="1000" b="1">
-                <a:solidFill>
-                  <a:srgbClr val="0E7A76"/>
-                </a:solidFill>
-                <a:latin typeface="Microsoft YaHei"/>
-                <a:ea typeface="Microsoft YaHei"/>
-                <a:cs typeface="Microsoft YaHei"/>
-              </a:rPr>
-              <a:t>片内</a:t>
-            </a:r>
-          </a:p>
-        </p:txBody>
-      </p:sp>
-      <p:sp>
-        <p:nvSpPr>
-          <p:cNvPr id="33" name="Rectangle 32"/>
-          <p:cNvSpPr/>
-          <p:nvPr/>
-        </p:nvSpPr>
-        <p:spPr>
-          <a:xfrm>
-            <a:off x="5532120" y="1353312"/>
-            <a:ext cx="1078992" cy="2340864"/>
-          </a:xfrm>
-          <a:prstGeom prst="rect">
-            <a:avLst/>
-          </a:prstGeom>
-          <a:solidFill>
-            <a:srgbClr val="0E2A47"/>
-          </a:solidFill>
-          <a:ln>
-            <a:noFill/>
-          </a:ln>
-        </p:spPr>
-        <p:style>
-          <a:lnRef idx="1">
-            <a:schemeClr val="accent1"/>
-          </a:lnRef>
-          <a:fillRef idx="3">
-            <a:schemeClr val="accent1"/>
-          </a:fillRef>
-          <a:effectRef idx="2">
-            <a:schemeClr val="accent1"/>
-          </a:effectRef>
-          <a:fontRef idx="minor">
-            <a:schemeClr val="lt1"/>
-          </a:fontRef>
-        </p:style>
-        <p:txBody>
-          <a:bodyPr rtlCol="0" anchor="ctr"/>
-          <a:lstStyle/>
-          <a:p>
-            <a:pPr algn="ctr"/>
-          </a:p>
-        </p:txBody>
-      </p:sp>
-      <p:sp>
-        <p:nvSpPr>
-          <p:cNvPr id="34" name="TextBox 33"/>
-          <p:cNvSpPr txBox="1"/>
-          <p:nvPr/>
-        </p:nvSpPr>
-        <p:spPr>
-          <a:xfrm>
-            <a:off x="5586983" y="1463040"/>
-            <a:ext cx="969264" cy="2011680"/>
-          </a:xfrm>
-          <a:prstGeom prst="rect">
-            <a:avLst/>
-          </a:prstGeom>
-          <a:noFill/>
-        </p:spPr>
-        <p:txBody>
-          <a:bodyPr wrap="square" lIns="0" rIns="0" tIns="0" bIns="0" anchor="t"/>
-          <a:lstStyle/>
-          <a:p>
-            <a:pPr algn="l">
-              <a:spcBef>
-                <a:spcPts val="0"/>
-              </a:spcBef>
-              <a:spcAft>
-                <a:spcPts val="0"/>
-              </a:spcAft>
-            </a:pPr>
-            <a:r>
-              <a:rPr sz="1200" b="1">
-                <a:solidFill>
-                  <a:srgbClr val="FFFFFF"/>
-                </a:solidFill>
-                <a:latin typeface="Microsoft YaHei"/>
-                <a:ea typeface="Microsoft YaHei"/>
-                <a:cs typeface="Microsoft YaHei"/>
-              </a:rPr>
-              <a:t>铜质</a:t>
-            </a:r>
-          </a:p>
-          <a:p>
-            <a:pPr algn="l">
-              <a:spcBef>
-                <a:spcPts val="0"/>
-              </a:spcBef>
-              <a:spcAft>
-                <a:spcPts val="0"/>
-              </a:spcAft>
-            </a:pPr>
-            <a:r>
-              <a:rPr sz="1200" b="1">
-                <a:solidFill>
-                  <a:srgbClr val="FFFFFF"/>
-                </a:solidFill>
-                <a:latin typeface="Microsoft YaHei"/>
-                <a:ea typeface="Microsoft YaHei"/>
-                <a:cs typeface="Microsoft YaHei"/>
-              </a:rPr>
-              <a:t>Spine</a:t>
-            </a:r>
-          </a:p>
-          <a:p>
-            <a:pPr algn="l">
-              <a:spcBef>
-                <a:spcPts val="0"/>
-              </a:spcBef>
-              <a:spcAft>
-                <a:spcPts val="0"/>
-              </a:spcAft>
-            </a:pPr>
-            <a:r>
-              <a:rPr sz="1200" b="1">
-                <a:solidFill>
-                  <a:srgbClr val="FFFFFF"/>
-                </a:solidFill>
-                <a:latin typeface="Microsoft YaHei"/>
-                <a:ea typeface="Microsoft YaHei"/>
-                <a:cs typeface="Microsoft YaHei"/>
-              </a:rPr>
-              <a:t/>
-            </a:r>
-          </a:p>
-          <a:p>
-            <a:pPr algn="l">
-              <a:spcBef>
-                <a:spcPts val="0"/>
-              </a:spcBef>
-              <a:spcAft>
-                <a:spcPts val="0"/>
-              </a:spcAft>
-            </a:pPr>
-            <a:r>
-              <a:rPr sz="1200" b="1">
-                <a:solidFill>
-                  <a:srgbClr val="FFFFFF"/>
-                </a:solidFill>
-                <a:latin typeface="Microsoft YaHei"/>
-                <a:ea typeface="Microsoft YaHei"/>
-                <a:cs typeface="Microsoft YaHei"/>
-              </a:rPr>
-              <a:t>预集成</a:t>
-            </a:r>
-          </a:p>
-          <a:p>
-            <a:pPr algn="l">
-              <a:spcBef>
-                <a:spcPts val="0"/>
-              </a:spcBef>
-              <a:spcAft>
-                <a:spcPts val="0"/>
-              </a:spcAft>
-            </a:pPr>
-            <a:r>
-              <a:rPr sz="1200" b="1">
-                <a:solidFill>
-                  <a:srgbClr val="FFFFFF"/>
-                </a:solidFill>
-                <a:latin typeface="Microsoft YaHei"/>
-                <a:ea typeface="Microsoft YaHei"/>
-                <a:cs typeface="Microsoft YaHei"/>
-              </a:rPr>
-              <a:t>线缆盒</a:t>
-            </a:r>
-          </a:p>
-          <a:p>
-            <a:pPr algn="l">
-              <a:spcBef>
-                <a:spcPts val="0"/>
-              </a:spcBef>
-              <a:spcAft>
-                <a:spcPts val="0"/>
-              </a:spcAft>
-            </a:pPr>
-            <a:r>
-              <a:rPr sz="1200" b="1">
-                <a:solidFill>
-                  <a:srgbClr val="FFFFFF"/>
-                </a:solidFill>
-                <a:latin typeface="Microsoft YaHei"/>
-                <a:ea typeface="Microsoft YaHei"/>
-                <a:cs typeface="Microsoft YaHei"/>
-              </a:rPr>
-              <a:t/>
-            </a:r>
-          </a:p>
-          <a:p>
-            <a:pPr algn="l">
-              <a:spcBef>
-                <a:spcPts val="0"/>
-              </a:spcBef>
-              <a:spcAft>
-                <a:spcPts val="0"/>
-              </a:spcAft>
-            </a:pPr>
-            <a:r>
-              <a:rPr sz="1200" b="1">
-                <a:solidFill>
-                  <a:srgbClr val="FFFFFF"/>
-                </a:solidFill>
-                <a:latin typeface="Microsoft YaHei"/>
-                <a:ea typeface="Microsoft YaHei"/>
-                <a:cs typeface="Microsoft YaHei"/>
-              </a:rPr>
-              <a:t>多对多</a:t>
-            </a:r>
-          </a:p>
-          <a:p>
-            <a:pPr algn="l">
-              <a:spcBef>
-                <a:spcPts val="0"/>
-              </a:spcBef>
-              <a:spcAft>
-                <a:spcPts val="0"/>
-              </a:spcAft>
-            </a:pPr>
-            <a:r>
-              <a:rPr sz="1200" b="1">
-                <a:solidFill>
-                  <a:srgbClr val="FFFFFF"/>
-                </a:solidFill>
-                <a:latin typeface="Microsoft YaHei"/>
-                <a:ea typeface="Microsoft YaHei"/>
-                <a:cs typeface="Microsoft YaHei"/>
-              </a:rPr>
-              <a:t>一层网络</a:t>
-            </a:r>
-          </a:p>
-        </p:txBody>
-      </p:sp>
-      <p:sp>
-        <p:nvSpPr>
-          <p:cNvPr id="35" name="Rectangle 34"/>
-          <p:cNvSpPr/>
-          <p:nvPr/>
-        </p:nvSpPr>
-        <p:spPr>
-          <a:xfrm>
-            <a:off x="7114032" y="1691640"/>
-            <a:ext cx="1207008" cy="1691640"/>
+            <a:off x="8732520" y="2331720"/>
+            <a:ext cx="2788920" cy="2011680"/>
           </a:xfrm>
           <a:prstGeom prst="rect">
             <a:avLst/>
@@ -5178,14 +4084,14 @@
       </p:sp>
       <p:sp>
         <p:nvSpPr>
-          <p:cNvPr id="36" name="TextBox 35"/>
+          <p:cNvPr id="15" name="TextBox 14"/>
           <p:cNvSpPr txBox="1"/>
           <p:nvPr/>
         </p:nvSpPr>
         <p:spPr>
           <a:xfrm>
-            <a:off x="7168896" y="1783080"/>
-            <a:ext cx="1097280" cy="1508760"/>
+            <a:off x="8860536" y="2770632"/>
+            <a:ext cx="2532887" cy="420624"/>
           </a:xfrm>
           <a:prstGeom prst="rect">
             <a:avLst/>
@@ -5193,7 +4099,7 @@
           <a:noFill/>
         </p:spPr>
         <p:txBody>
-          <a:bodyPr wrap="square" lIns="0" rIns="0" tIns="0" bIns="0" anchor="t"/>
+          <a:bodyPr wrap="square" lIns="0" rIns="0" tIns="0" bIns="0" anchor="ctr"/>
           <a:lstStyle/>
           <a:p>
             <a:pPr algn="l">
@@ -5205,7 +4111,7 @@
               </a:spcAft>
             </a:pPr>
             <a:r>
-              <a:rPr sz="1200" b="1">
+              <a:rPr sz="2400" b="1">
                 <a:solidFill>
                   <a:srgbClr val="FFFFFF"/>
                 </a:solidFill>
@@ -5213,9 +4119,30 @@
                 <a:ea typeface="Microsoft YaHei"/>
                 <a:cs typeface="Microsoft YaHei"/>
               </a:rPr>
-              <a:t>Spectrum-6</a:t>
-            </a:r>
-          </a:p>
+              <a:t>ConnectX-9</a:t>
+            </a:r>
+          </a:p>
+        </p:txBody>
+      </p:sp>
+      <p:sp>
+        <p:nvSpPr>
+          <p:cNvPr id="16" name="TextBox 15"/>
+          <p:cNvSpPr txBox="1"/>
+          <p:nvPr/>
+        </p:nvSpPr>
+        <p:spPr>
+          <a:xfrm>
+            <a:off x="8860536" y="3337560"/>
+            <a:ext cx="2532887" cy="731520"/>
+          </a:xfrm>
+          <a:prstGeom prst="rect">
+            <a:avLst/>
+          </a:prstGeom>
+          <a:noFill/>
+        </p:spPr>
+        <p:txBody>
+          <a:bodyPr wrap="square" lIns="0" rIns="0" tIns="0" bIns="0" anchor="t"/>
+          <a:lstStyle/>
           <a:p>
             <a:pPr algn="l">
               <a:spcBef>
@@ -5226,7 +4153,7 @@
               </a:spcAft>
             </a:pPr>
             <a:r>
-              <a:rPr sz="1200" b="1">
+              <a:rPr sz="1600" b="0">
                 <a:solidFill>
                   <a:srgbClr val="FFFFFF"/>
                 </a:solidFill>
@@ -5234,7 +4161,7 @@
                 <a:ea typeface="Microsoft YaHei"/>
                 <a:cs typeface="Microsoft YaHei"/>
               </a:rPr>
-              <a:t>交换机托盘</a:t>
+              <a:t>网口</a:t>
             </a:r>
           </a:p>
           <a:p>
@@ -5247,7 +4174,7 @@
               </a:spcAft>
             </a:pPr>
             <a:r>
-              <a:rPr sz="1200" b="1">
+              <a:rPr sz="1600" b="0">
                 <a:solidFill>
                   <a:srgbClr val="FFFFFF"/>
                 </a:solidFill>
@@ -5255,615 +4182,21 @@
                 <a:ea typeface="Microsoft YaHei"/>
                 <a:cs typeface="Microsoft YaHei"/>
               </a:rPr>
-              <a:t>机架中部</a:t>
-            </a:r>
-          </a:p>
-          <a:p>
-            <a:pPr algn="l">
-              <a:spcBef>
-                <a:spcPts val="0"/>
-              </a:spcBef>
-              <a:spcAft>
-                <a:spcPts val="0"/>
-              </a:spcAft>
-            </a:pPr>
-            <a:r>
-              <a:rPr sz="1200" b="1">
-                <a:solidFill>
-                  <a:srgbClr val="FFFFFF"/>
-                </a:solidFill>
-                <a:latin typeface="Microsoft YaHei"/>
-                <a:ea typeface="Microsoft YaHei"/>
-                <a:cs typeface="Microsoft YaHei"/>
-              </a:rPr>
-              <a:t/>
-            </a:r>
-          </a:p>
-          <a:p>
-            <a:pPr algn="l">
-              <a:spcBef>
-                <a:spcPts val="0"/>
-              </a:spcBef>
-              <a:spcAft>
-                <a:spcPts val="0"/>
-              </a:spcAft>
-            </a:pPr>
-            <a:r>
-              <a:rPr sz="1200" b="1">
-                <a:solidFill>
-                  <a:srgbClr val="FFFFFF"/>
-                </a:solidFill>
-                <a:latin typeface="Microsoft YaHei"/>
-                <a:ea typeface="Microsoft YaHei"/>
-                <a:cs typeface="Microsoft YaHei"/>
-              </a:rPr>
-              <a:t>后端口入</a:t>
-            </a:r>
-          </a:p>
-          <a:p>
-            <a:pPr algn="l">
-              <a:spcBef>
-                <a:spcPts val="0"/>
-              </a:spcBef>
-              <a:spcAft>
-                <a:spcPts val="0"/>
-              </a:spcAft>
-            </a:pPr>
-            <a:r>
-              <a:rPr sz="1200" b="1">
-                <a:solidFill>
-                  <a:srgbClr val="FFFFFF"/>
-                </a:solidFill>
-                <a:latin typeface="Microsoft YaHei"/>
-                <a:ea typeface="Microsoft YaHei"/>
-                <a:cs typeface="Microsoft YaHei"/>
-              </a:rPr>
-              <a:t>前置光口出</a:t>
-            </a:r>
-          </a:p>
-        </p:txBody>
-      </p:sp>
-      <p:sp>
-        <p:nvSpPr>
-          <p:cNvPr id="37" name="Rectangle 36"/>
-          <p:cNvSpPr/>
-          <p:nvPr/>
-        </p:nvSpPr>
-        <p:spPr>
-          <a:xfrm>
-            <a:off x="8732520" y="1115568"/>
-            <a:ext cx="3200400" cy="5074920"/>
-          </a:xfrm>
-          <a:prstGeom prst="rect">
-            <a:avLst/>
-          </a:prstGeom>
-          <a:solidFill>
-            <a:srgbClr val="FFFFFF"/>
-          </a:solidFill>
-          <a:ln w="9525">
-            <a:solidFill>
-              <a:srgbClr val="583E82"/>
-            </a:solidFill>
-          </a:ln>
-        </p:spPr>
-        <p:style>
-          <a:lnRef idx="1">
-            <a:schemeClr val="accent1"/>
-          </a:lnRef>
-          <a:fillRef idx="3">
-            <a:schemeClr val="accent1"/>
-          </a:fillRef>
-          <a:effectRef idx="2">
-            <a:schemeClr val="accent1"/>
-          </a:effectRef>
-          <a:fontRef idx="minor">
-            <a:schemeClr val="lt1"/>
-          </a:fontRef>
-        </p:style>
-        <p:txBody>
-          <a:bodyPr rtlCol="0" anchor="ctr"/>
-          <a:lstStyle/>
-          <a:p>
-            <a:pPr algn="ctr"/>
-          </a:p>
-        </p:txBody>
-      </p:sp>
-      <p:sp>
-        <p:nvSpPr>
-          <p:cNvPr id="38" name="TextBox 37"/>
-          <p:cNvSpPr txBox="1"/>
-          <p:nvPr/>
-        </p:nvSpPr>
-        <p:spPr>
-          <a:xfrm>
-            <a:off x="8842248" y="1152144"/>
-            <a:ext cx="2980944" cy="182880"/>
-          </a:xfrm>
-          <a:prstGeom prst="rect">
-            <a:avLst/>
-          </a:prstGeom>
-          <a:noFill/>
-        </p:spPr>
-        <p:txBody>
-          <a:bodyPr wrap="square" lIns="0" rIns="0" tIns="0" bIns="0" anchor="ctr"/>
-          <a:lstStyle/>
-          <a:p>
-            <a:pPr algn="l">
-              <a:spcBef>
-                <a:spcPts val="0"/>
-              </a:spcBef>
-              <a:spcAft>
-                <a:spcPts val="0"/>
-              </a:spcAft>
-            </a:pPr>
-            <a:r>
-              <a:rPr sz="1100" b="1">
-                <a:solidFill>
-                  <a:srgbClr val="583E82"/>
-                </a:solidFill>
-                <a:latin typeface="Microsoft YaHei"/>
-                <a:ea typeface="Microsoft YaHei"/>
-                <a:cs typeface="Microsoft YaHei"/>
-              </a:rPr>
-              <a:t>机架外</a:t>
-            </a:r>
-          </a:p>
-        </p:txBody>
-      </p:sp>
-      <p:sp>
-        <p:nvSpPr>
-          <p:cNvPr id="39" name="Rectangle 38"/>
-          <p:cNvSpPr/>
-          <p:nvPr/>
-        </p:nvSpPr>
-        <p:spPr>
-          <a:xfrm>
-            <a:off x="9061704" y="1691640"/>
-            <a:ext cx="2706624" cy="1051560"/>
-          </a:xfrm>
-          <a:prstGeom prst="rect">
-            <a:avLst/>
-          </a:prstGeom>
-          <a:solidFill>
-            <a:srgbClr val="583E82"/>
-          </a:solidFill>
-          <a:ln>
-            <a:noFill/>
-          </a:ln>
-        </p:spPr>
-        <p:style>
-          <a:lnRef idx="1">
-            <a:schemeClr val="accent1"/>
-          </a:lnRef>
-          <a:fillRef idx="3">
-            <a:schemeClr val="accent1"/>
-          </a:fillRef>
-          <a:effectRef idx="2">
-            <a:schemeClr val="accent1"/>
-          </a:effectRef>
-          <a:fontRef idx="minor">
-            <a:schemeClr val="lt1"/>
-          </a:fontRef>
-        </p:style>
-        <p:txBody>
-          <a:bodyPr rtlCol="0" anchor="ctr"/>
-          <a:lstStyle/>
-          <a:p>
-            <a:pPr algn="ctr"/>
-          </a:p>
-        </p:txBody>
-      </p:sp>
-      <p:sp>
-        <p:nvSpPr>
-          <p:cNvPr id="40" name="TextBox 39"/>
-          <p:cNvSpPr txBox="1"/>
-          <p:nvPr/>
-        </p:nvSpPr>
-        <p:spPr>
-          <a:xfrm>
-            <a:off x="9153144" y="1764792"/>
-            <a:ext cx="2523744" cy="256032"/>
-          </a:xfrm>
-          <a:prstGeom prst="rect">
-            <a:avLst/>
-          </a:prstGeom>
-          <a:noFill/>
-        </p:spPr>
-        <p:txBody>
-          <a:bodyPr wrap="square" lIns="0" rIns="0" tIns="0" bIns="0" anchor="ctr"/>
-          <a:lstStyle/>
-          <a:p>
-            <a:pPr algn="l">
-              <a:spcBef>
-                <a:spcPts val="0"/>
-              </a:spcBef>
-              <a:spcAft>
-                <a:spcPts val="0"/>
-              </a:spcAft>
-            </a:pPr>
-            <a:r>
-              <a:rPr sz="1400" b="1">
-                <a:solidFill>
-                  <a:srgbClr val="FFFFFF"/>
-                </a:solidFill>
-                <a:latin typeface="Microsoft YaHei"/>
-                <a:ea typeface="Microsoft YaHei"/>
-                <a:cs typeface="Microsoft YaHei"/>
-              </a:rPr>
-              <a:t>Spectrum-6 SPX</a:t>
-            </a:r>
-          </a:p>
-        </p:txBody>
-      </p:sp>
-      <p:sp>
-        <p:nvSpPr>
-          <p:cNvPr id="41" name="TextBox 40"/>
-          <p:cNvSpPr txBox="1"/>
-          <p:nvPr/>
-        </p:nvSpPr>
-        <p:spPr>
-          <a:xfrm>
-            <a:off x="9153144" y="2057400"/>
-            <a:ext cx="2523744" cy="585216"/>
-          </a:xfrm>
-          <a:prstGeom prst="rect">
-            <a:avLst/>
-          </a:prstGeom>
-          <a:noFill/>
-        </p:spPr>
-        <p:txBody>
-          <a:bodyPr wrap="square" lIns="0" rIns="0" tIns="0" bIns="0" anchor="t"/>
-          <a:lstStyle/>
-          <a:p>
-            <a:pPr algn="l">
-              <a:spcBef>
-                <a:spcPts val="0"/>
-              </a:spcBef>
-              <a:spcAft>
-                <a:spcPts val="0"/>
-              </a:spcAft>
-            </a:pPr>
-            <a:r>
-              <a:rPr sz="1200" b="0">
-                <a:solidFill>
-                  <a:srgbClr val="FFFFFF"/>
-                </a:solidFill>
-                <a:latin typeface="Microsoft YaHei"/>
-                <a:ea typeface="Microsoft YaHei"/>
-                <a:cs typeface="Microsoft YaHei"/>
-              </a:rPr>
-              <a:t>POD 内机架互联</a:t>
-            </a:r>
-          </a:p>
-          <a:p>
-            <a:pPr algn="l">
-              <a:spcBef>
-                <a:spcPts val="0"/>
-              </a:spcBef>
-              <a:spcAft>
-                <a:spcPts val="0"/>
-              </a:spcAft>
-            </a:pPr>
-            <a:r>
-              <a:rPr sz="1200" b="0">
-                <a:solidFill>
-                  <a:srgbClr val="FFFFFF"/>
-                </a:solidFill>
-                <a:latin typeface="Microsoft YaHei"/>
-                <a:ea typeface="Microsoft YaHei"/>
-                <a:cs typeface="Microsoft YaHei"/>
-              </a:rPr>
-              <a:t>东西向与南北向</a:t>
-            </a:r>
-          </a:p>
-        </p:txBody>
-      </p:sp>
-      <p:sp>
-        <p:nvSpPr>
-          <p:cNvPr id="42" name="Rectangle 41"/>
-          <p:cNvSpPr/>
-          <p:nvPr/>
-        </p:nvSpPr>
-        <p:spPr>
-          <a:xfrm>
-            <a:off x="8897112" y="3246120"/>
-            <a:ext cx="2871216" cy="1143000"/>
-          </a:xfrm>
-          <a:prstGeom prst="rect">
-            <a:avLst/>
-          </a:prstGeom>
-          <a:solidFill>
-            <a:srgbClr val="0E7A76"/>
-          </a:solidFill>
-          <a:ln>
-            <a:noFill/>
-          </a:ln>
-        </p:spPr>
-        <p:style>
-          <a:lnRef idx="1">
-            <a:schemeClr val="accent1"/>
-          </a:lnRef>
-          <a:fillRef idx="3">
-            <a:schemeClr val="accent1"/>
-          </a:fillRef>
-          <a:effectRef idx="2">
-            <a:schemeClr val="accent1"/>
-          </a:effectRef>
-          <a:fontRef idx="minor">
-            <a:schemeClr val="lt1"/>
-          </a:fontRef>
-        </p:style>
-        <p:txBody>
-          <a:bodyPr rtlCol="0" anchor="ctr"/>
-          <a:lstStyle/>
-          <a:p>
-            <a:pPr algn="ctr"/>
-          </a:p>
-        </p:txBody>
-      </p:sp>
-      <p:sp>
-        <p:nvSpPr>
-          <p:cNvPr id="43" name="TextBox 42"/>
-          <p:cNvSpPr txBox="1"/>
-          <p:nvPr/>
-        </p:nvSpPr>
-        <p:spPr>
-          <a:xfrm>
-            <a:off x="8988552" y="3319272"/>
-            <a:ext cx="2688336" cy="256032"/>
-          </a:xfrm>
-          <a:prstGeom prst="rect">
-            <a:avLst/>
-          </a:prstGeom>
-          <a:noFill/>
-        </p:spPr>
-        <p:txBody>
-          <a:bodyPr wrap="square" lIns="0" rIns="0" tIns="0" bIns="0" anchor="ctr"/>
-          <a:lstStyle/>
-          <a:p>
-            <a:pPr algn="l">
-              <a:spcBef>
-                <a:spcPts val="0"/>
-              </a:spcBef>
-              <a:spcAft>
-                <a:spcPts val="0"/>
-              </a:spcAft>
-            </a:pPr>
-            <a:r>
-              <a:rPr sz="1400" b="1">
-                <a:solidFill>
-                  <a:srgbClr val="FFFFFF"/>
-                </a:solidFill>
-                <a:latin typeface="Microsoft YaHei"/>
-                <a:ea typeface="Microsoft YaHei"/>
-                <a:cs typeface="Microsoft YaHei"/>
-              </a:rPr>
-              <a:t>计算节点 BlueField-4</a:t>
-            </a:r>
-          </a:p>
-        </p:txBody>
-      </p:sp>
-      <p:sp>
-        <p:nvSpPr>
-          <p:cNvPr id="44" name="TextBox 43"/>
-          <p:cNvSpPr txBox="1"/>
-          <p:nvPr/>
-        </p:nvSpPr>
-        <p:spPr>
-          <a:xfrm>
-            <a:off x="8988552" y="3611879"/>
-            <a:ext cx="2688336" cy="676656"/>
-          </a:xfrm>
-          <a:prstGeom prst="rect">
-            <a:avLst/>
-          </a:prstGeom>
-          <a:noFill/>
-        </p:spPr>
-        <p:txBody>
-          <a:bodyPr wrap="square" lIns="0" rIns="0" tIns="0" bIns="0" anchor="t"/>
-          <a:lstStyle/>
-          <a:p>
-            <a:pPr algn="l">
-              <a:spcBef>
-                <a:spcPts val="0"/>
-              </a:spcBef>
-              <a:spcAft>
-                <a:spcPts val="0"/>
-              </a:spcAft>
-            </a:pPr>
-            <a:r>
-              <a:rPr sz="1200" b="0">
-                <a:solidFill>
-                  <a:srgbClr val="FFFFFF"/>
-                </a:solidFill>
-                <a:latin typeface="Microsoft YaHei"/>
-                <a:ea typeface="Microsoft YaHei"/>
-                <a:cs typeface="Microsoft YaHei"/>
-              </a:rPr>
-              <a:t>KV I/O 平面</a:t>
-            </a:r>
-          </a:p>
-          <a:p>
-            <a:pPr algn="l">
-              <a:spcBef>
-                <a:spcPts val="0"/>
-              </a:spcBef>
-              <a:spcAft>
-                <a:spcPts val="0"/>
-              </a:spcAft>
-            </a:pPr>
-            <a:r>
-              <a:rPr sz="1200" b="0">
-                <a:solidFill>
-                  <a:srgbClr val="FFFFFF"/>
-                </a:solidFill>
-                <a:latin typeface="Microsoft YaHei"/>
-                <a:ea typeface="Microsoft YaHei"/>
-                <a:cs typeface="Microsoft YaHei"/>
-              </a:rPr>
-              <a:t>终结 NVMe-oF 与对象 RDMA</a:t>
-            </a:r>
-          </a:p>
-        </p:txBody>
-      </p:sp>
-      <p:sp>
-        <p:nvSpPr>
-          <p:cNvPr id="45" name="Rectangle 44"/>
-          <p:cNvSpPr/>
-          <p:nvPr/>
-        </p:nvSpPr>
-        <p:spPr>
-          <a:xfrm>
-            <a:off x="8897112" y="4846320"/>
-            <a:ext cx="2871216" cy="1051560"/>
-          </a:xfrm>
-          <a:prstGeom prst="rect">
-            <a:avLst/>
-          </a:prstGeom>
-          <a:solidFill>
-            <a:srgbClr val="1B6E48"/>
-          </a:solidFill>
-          <a:ln>
-            <a:noFill/>
-          </a:ln>
-        </p:spPr>
-        <p:style>
-          <a:lnRef idx="1">
-            <a:schemeClr val="accent1"/>
-          </a:lnRef>
-          <a:fillRef idx="3">
-            <a:schemeClr val="accent1"/>
-          </a:fillRef>
-          <a:effectRef idx="2">
-            <a:schemeClr val="accent1"/>
-          </a:effectRef>
-          <a:fontRef idx="minor">
-            <a:schemeClr val="lt1"/>
-          </a:fontRef>
-        </p:style>
-        <p:txBody>
-          <a:bodyPr rtlCol="0" anchor="ctr"/>
-          <a:lstStyle/>
-          <a:p>
-            <a:pPr algn="ctr"/>
-          </a:p>
-        </p:txBody>
-      </p:sp>
-      <p:sp>
-        <p:nvSpPr>
-          <p:cNvPr id="46" name="TextBox 45"/>
-          <p:cNvSpPr txBox="1"/>
-          <p:nvPr/>
-        </p:nvSpPr>
-        <p:spPr>
-          <a:xfrm>
-            <a:off x="8988552" y="4919472"/>
-            <a:ext cx="2688336" cy="256032"/>
-          </a:xfrm>
-          <a:prstGeom prst="rect">
-            <a:avLst/>
-          </a:prstGeom>
-          <a:noFill/>
-        </p:spPr>
-        <p:txBody>
-          <a:bodyPr wrap="square" lIns="0" rIns="0" tIns="0" bIns="0" anchor="ctr"/>
-          <a:lstStyle/>
-          <a:p>
-            <a:pPr algn="l">
-              <a:spcBef>
-                <a:spcPts val="0"/>
-              </a:spcBef>
-              <a:spcAft>
-                <a:spcPts val="0"/>
-              </a:spcAft>
-            </a:pPr>
-            <a:r>
-              <a:rPr sz="1400" b="1">
-                <a:solidFill>
-                  <a:srgbClr val="FFFFFF"/>
-                </a:solidFill>
-                <a:latin typeface="Microsoft YaHei"/>
-                <a:ea typeface="Microsoft YaHei"/>
-                <a:cs typeface="Microsoft YaHei"/>
-              </a:rPr>
-              <a:t>Rubin GPU  HBM</a:t>
-            </a:r>
-          </a:p>
-        </p:txBody>
-      </p:sp>
-      <p:sp>
-        <p:nvSpPr>
-          <p:cNvPr id="47" name="TextBox 46"/>
-          <p:cNvSpPr txBox="1"/>
-          <p:nvPr/>
-        </p:nvSpPr>
-        <p:spPr>
-          <a:xfrm>
-            <a:off x="8988552" y="5212080"/>
-            <a:ext cx="2688336" cy="585216"/>
-          </a:xfrm>
-          <a:prstGeom prst="rect">
-            <a:avLst/>
-          </a:prstGeom>
-          <a:noFill/>
-        </p:spPr>
-        <p:txBody>
-          <a:bodyPr wrap="square" lIns="0" rIns="0" tIns="0" bIns="0" anchor="t"/>
-          <a:lstStyle/>
-          <a:p>
-            <a:pPr algn="l">
-              <a:spcBef>
-                <a:spcPts val="0"/>
-              </a:spcBef>
-              <a:spcAft>
-                <a:spcPts val="0"/>
-              </a:spcAft>
-            </a:pPr>
-            <a:r>
-              <a:rPr sz="1200" b="0">
-                <a:solidFill>
-                  <a:srgbClr val="FFFFFF"/>
-                </a:solidFill>
-                <a:latin typeface="Microsoft YaHei"/>
-                <a:ea typeface="Microsoft YaHei"/>
-                <a:cs typeface="Microsoft YaHei"/>
-              </a:rPr>
-              <a:t>热 KV</a:t>
-            </a:r>
-          </a:p>
-          <a:p>
-            <a:pPr algn="l">
-              <a:spcBef>
-                <a:spcPts val="0"/>
-              </a:spcBef>
-              <a:spcAft>
-                <a:spcPts val="0"/>
-              </a:spcAft>
-            </a:pPr>
-            <a:r>
-              <a:rPr sz="1200" b="0">
-                <a:solidFill>
-                  <a:srgbClr val="FFFFFF"/>
-                </a:solidFill>
-                <a:latin typeface="Microsoft YaHei"/>
-                <a:ea typeface="Microsoft YaHei"/>
-                <a:cs typeface="Microsoft YaHei"/>
-              </a:rPr>
-              <a:t>解码前从 CMX 预取</a:t>
+              <a:t>每端口最高 800 Gb/s</a:t>
             </a:r>
           </a:p>
         </p:txBody>
       </p:sp>
       <p:cxnSp>
         <p:nvCxnSpPr>
-          <p:cNvPr id="48" name="Connector 47"/>
+          <p:cNvPr id="17" name="Connector 16"/>
           <p:cNvCxnSpPr/>
           <p:nvPr/>
         </p:nvCxnSpPr>
         <p:spPr>
           <a:xfrm>
-            <a:off x="1664207" y="1892807"/>
-            <a:ext cx="603505" cy="0"/>
+            <a:off x="2606040" y="3337560"/>
+            <a:ext cx="1828800" cy="0"/>
           </a:xfrm>
           <a:prstGeom prst="line">
             <a:avLst/>
@@ -5890,124 +4223,16 @@
           </a:fontRef>
         </p:style>
       </p:cxnSp>
-      <p:cxnSp>
-        <p:nvCxnSpPr>
-          <p:cNvPr id="49" name="Connector 48"/>
-          <p:cNvCxnSpPr/>
+      <p:sp>
+        <p:nvSpPr>
+          <p:cNvPr id="18" name="Rectangle 17"/>
+          <p:cNvSpPr/>
           <p:nvPr/>
-        </p:nvCxnSpPr>
+        </p:nvSpPr>
         <p:spPr>
           <a:xfrm>
-            <a:off x="4352544" y="1892807"/>
-            <a:ext cx="1179576" cy="0"/>
-          </a:xfrm>
-          <a:prstGeom prst="line">
-            <a:avLst/>
-          </a:prstGeom>
-          <a:ln w="28575">
-            <a:solidFill>
-              <a:srgbClr val="0E7A76"/>
-            </a:solidFill>
-            <a:tailEnd type="triangle" w="med" len="sm"/>
-          </a:ln>
-        </p:spPr>
-        <p:style>
-          <a:lnRef idx="2">
-            <a:schemeClr val="accent1"/>
-          </a:lnRef>
-          <a:fillRef idx="0">
-            <a:schemeClr val="accent1"/>
-          </a:fillRef>
-          <a:effectRef idx="1">
-            <a:schemeClr val="accent1"/>
-          </a:effectRef>
-          <a:fontRef idx="minor">
-            <a:schemeClr val="tx1"/>
-          </a:fontRef>
-        </p:style>
-      </p:cxnSp>
-      <p:cxnSp>
-        <p:nvCxnSpPr>
-          <p:cNvPr id="50" name="Connector 49"/>
-          <p:cNvCxnSpPr/>
-          <p:nvPr/>
-        </p:nvCxnSpPr>
-        <p:spPr>
-          <a:xfrm>
-            <a:off x="1664207" y="3154679"/>
-            <a:ext cx="603505" cy="0"/>
-          </a:xfrm>
-          <a:prstGeom prst="line">
-            <a:avLst/>
-          </a:prstGeom>
-          <a:ln w="28575">
-            <a:solidFill>
-              <a:srgbClr val="7A541C"/>
-            </a:solidFill>
-            <a:tailEnd type="triangle" w="med" len="sm"/>
-          </a:ln>
-        </p:spPr>
-        <p:style>
-          <a:lnRef idx="2">
-            <a:schemeClr val="accent1"/>
-          </a:lnRef>
-          <a:fillRef idx="0">
-            <a:schemeClr val="accent1"/>
-          </a:fillRef>
-          <a:effectRef idx="1">
-            <a:schemeClr val="accent1"/>
-          </a:effectRef>
-          <a:fontRef idx="minor">
-            <a:schemeClr val="tx1"/>
-          </a:fontRef>
-        </p:style>
-      </p:cxnSp>
-      <p:cxnSp>
-        <p:nvCxnSpPr>
-          <p:cNvPr id="51" name="Connector 50"/>
-          <p:cNvCxnSpPr/>
-          <p:nvPr/>
-        </p:nvCxnSpPr>
-        <p:spPr>
-          <a:xfrm>
-            <a:off x="4352544" y="3154679"/>
-            <a:ext cx="1179576" cy="0"/>
-          </a:xfrm>
-          <a:prstGeom prst="line">
-            <a:avLst/>
-          </a:prstGeom>
-          <a:ln w="28575">
-            <a:solidFill>
-              <a:srgbClr val="0E7A76"/>
-            </a:solidFill>
-            <a:tailEnd type="triangle" w="med" len="sm"/>
-          </a:ln>
-        </p:spPr>
-        <p:style>
-          <a:lnRef idx="2">
-            <a:schemeClr val="accent1"/>
-          </a:lnRef>
-          <a:fillRef idx="0">
-            <a:schemeClr val="accent1"/>
-          </a:fillRef>
-          <a:effectRef idx="1">
-            <a:schemeClr val="accent1"/>
-          </a:effectRef>
-          <a:fontRef idx="minor">
-            <a:schemeClr val="tx1"/>
-          </a:fontRef>
-        </p:style>
-      </p:cxnSp>
-      <p:sp>
-        <p:nvSpPr>
-          <p:cNvPr id="52" name="Rectangle 51"/>
-          <p:cNvSpPr/>
-          <p:nvPr/>
-        </p:nvSpPr>
-        <p:spPr>
-          <a:xfrm>
-            <a:off x="1700784" y="2331720"/>
-            <a:ext cx="530352" cy="219456"/>
+            <a:off x="2816352" y="3154679"/>
+            <a:ext cx="1078992" cy="365760"/>
           </a:xfrm>
           <a:prstGeom prst="rect">
             <a:avLst/>
@@ -6056,21 +4281,57 @@
                 <a:ea typeface="Microsoft YaHei"/>
                 <a:cs typeface="Microsoft YaHei"/>
               </a:rPr>
-              <a:t>NVMe</a:t>
-            </a:r>
-          </a:p>
-        </p:txBody>
-      </p:sp>
-      <p:sp>
-        <p:nvSpPr>
-          <p:cNvPr id="53" name="Rectangle 52"/>
+              <a:t>PCIe Gen6</a:t>
+            </a:r>
+          </a:p>
+        </p:txBody>
+      </p:sp>
+      <p:cxnSp>
+        <p:nvCxnSpPr>
+          <p:cNvPr id="19" name="Connector 18"/>
+          <p:cNvCxnSpPr/>
+          <p:nvPr/>
+        </p:nvCxnSpPr>
+        <p:spPr>
+          <a:xfrm>
+            <a:off x="7315200" y="3337560"/>
+            <a:ext cx="1417320" cy="0"/>
+          </a:xfrm>
+          <a:prstGeom prst="line">
+            <a:avLst/>
+          </a:prstGeom>
+          <a:ln w="28575">
+            <a:solidFill>
+              <a:srgbClr val="0E7A76"/>
+            </a:solidFill>
+            <a:tailEnd type="triangle" w="med" len="sm"/>
+          </a:ln>
+        </p:spPr>
+        <p:style>
+          <a:lnRef idx="2">
+            <a:schemeClr val="accent1"/>
+          </a:lnRef>
+          <a:fillRef idx="0">
+            <a:schemeClr val="accent1"/>
+          </a:fillRef>
+          <a:effectRef idx="1">
+            <a:schemeClr val="accent1"/>
+          </a:effectRef>
+          <a:fontRef idx="minor">
+            <a:schemeClr val="tx1"/>
+          </a:fontRef>
+        </p:style>
+      </p:cxnSp>
+      <p:sp>
+        <p:nvSpPr>
+          <p:cNvPr id="20" name="Rectangle 19"/>
           <p:cNvSpPr/>
           <p:nvPr/>
         </p:nvSpPr>
         <p:spPr>
           <a:xfrm>
-            <a:off x="4407408" y="2267712"/>
-            <a:ext cx="1060704" cy="365760"/>
+            <a:off x="7516368" y="3172968"/>
+            <a:ext cx="1005840" cy="329184"/>
           </a:xfrm>
           <a:prstGeom prst="rect">
             <a:avLst/>
@@ -6119,459 +4380,21 @@
                 <a:ea typeface="Microsoft YaHei"/>
                 <a:cs typeface="Microsoft YaHei"/>
               </a:rPr>
-              <a:t>200 Gb/s</a:t>
-            </a:r>
-          </a:p>
-          <a:p>
-            <a:pPr algn="ctr">
-              <a:spcBef>
-                <a:spcPts val="0"/>
-              </a:spcBef>
-              <a:spcAft>
-                <a:spcPts val="0"/>
-              </a:spcAft>
-            </a:pPr>
-            <a:r>
-              <a:rPr sz="1100" b="1">
-                <a:solidFill>
-                  <a:srgbClr val="0E7A76"/>
-                </a:solidFill>
-                <a:latin typeface="Microsoft YaHei"/>
-                <a:ea typeface="Microsoft YaHei"/>
-                <a:cs typeface="Microsoft YaHei"/>
-              </a:rPr>
-              <a:t>铜缆</a:t>
-            </a:r>
-          </a:p>
-        </p:txBody>
-      </p:sp>
-      <p:cxnSp>
-        <p:nvCxnSpPr>
-          <p:cNvPr id="54" name="Connector 53"/>
-          <p:cNvCxnSpPr/>
+              <a:t>片内</a:t>
+            </a:r>
+          </a:p>
+        </p:txBody>
+      </p:sp>
+      <p:sp>
+        <p:nvSpPr>
+          <p:cNvPr id="21" name="TextBox 20"/>
+          <p:cNvSpPr txBox="1"/>
           <p:nvPr/>
-        </p:nvCxnSpPr>
+        </p:nvSpPr>
         <p:spPr>
           <a:xfrm>
-            <a:off x="6611112" y="2537460"/>
-            <a:ext cx="502920" cy="0"/>
-          </a:xfrm>
-          <a:prstGeom prst="line">
-            <a:avLst/>
-          </a:prstGeom>
-          <a:ln w="28575">
-            <a:solidFill>
-              <a:srgbClr val="0E2A47"/>
-            </a:solidFill>
-            <a:tailEnd type="triangle" w="med" len="sm"/>
-          </a:ln>
-        </p:spPr>
-        <p:style>
-          <a:lnRef idx="2">
-            <a:schemeClr val="accent1"/>
-          </a:lnRef>
-          <a:fillRef idx="0">
-            <a:schemeClr val="accent1"/>
-          </a:fillRef>
-          <a:effectRef idx="1">
-            <a:schemeClr val="accent1"/>
-          </a:effectRef>
-          <a:fontRef idx="minor">
-            <a:schemeClr val="tx1"/>
-          </a:fontRef>
-        </p:style>
-      </p:cxnSp>
-      <p:sp>
-        <p:nvSpPr>
-          <p:cNvPr id="55" name="Rectangle 54"/>
-          <p:cNvSpPr/>
-          <p:nvPr/>
-        </p:nvSpPr>
-        <p:spPr>
-          <a:xfrm>
-            <a:off x="6565392" y="2208276"/>
-            <a:ext cx="530352" cy="256032"/>
-          </a:xfrm>
-          <a:prstGeom prst="rect">
-            <a:avLst/>
-          </a:prstGeom>
-          <a:solidFill>
-            <a:srgbClr val="FFFFFF"/>
-          </a:solidFill>
-          <a:ln w="9525">
-            <a:solidFill>
-              <a:srgbClr val="FFFFFF"/>
-            </a:solidFill>
-          </a:ln>
-        </p:spPr>
-        <p:style>
-          <a:lnRef idx="1">
-            <a:schemeClr val="accent1"/>
-          </a:lnRef>
-          <a:fillRef idx="3">
-            <a:schemeClr val="accent1"/>
-          </a:fillRef>
-          <a:effectRef idx="2">
-            <a:schemeClr val="accent1"/>
-          </a:effectRef>
-          <a:fontRef idx="minor">
-            <a:schemeClr val="lt1"/>
-          </a:fontRef>
-        </p:style>
-        <p:txBody>
-          <a:bodyPr rtlCol="0" anchor="ctr" wrap="square" lIns="45720" rIns="45720" tIns="18288" bIns="18288"/>
-          <a:lstStyle/>
-          <a:p>
-            <a:pPr algn="ctr">
-              <a:spcBef>
-                <a:spcPts val="0"/>
-              </a:spcBef>
-              <a:spcAft>
-                <a:spcPts val="0"/>
-              </a:spcAft>
-            </a:pPr>
-            <a:r>
-              <a:rPr sz="1100" b="1">
-                <a:solidFill>
-                  <a:srgbClr val="0E2A47"/>
-                </a:solidFill>
-                <a:latin typeface="Microsoft YaHei"/>
-                <a:ea typeface="Microsoft YaHei"/>
-                <a:cs typeface="Microsoft YaHei"/>
-              </a:rPr>
-              <a:t>后端口</a:t>
-            </a:r>
-          </a:p>
-        </p:txBody>
-      </p:sp>
-      <p:cxnSp>
-        <p:nvCxnSpPr>
-          <p:cNvPr id="56" name="Connector 55"/>
-          <p:cNvCxnSpPr/>
-          <p:nvPr/>
-        </p:nvCxnSpPr>
-        <p:spPr>
-          <a:xfrm>
-            <a:off x="8321040" y="2217420"/>
-            <a:ext cx="740664" cy="0"/>
-          </a:xfrm>
-          <a:prstGeom prst="line">
-            <a:avLst/>
-          </a:prstGeom>
-          <a:ln w="28575">
-            <a:solidFill>
-              <a:srgbClr val="583E82"/>
-            </a:solidFill>
-            <a:tailEnd type="triangle" w="med" len="sm"/>
-          </a:ln>
-        </p:spPr>
-        <p:style>
-          <a:lnRef idx="2">
-            <a:schemeClr val="accent1"/>
-          </a:lnRef>
-          <a:fillRef idx="0">
-            <a:schemeClr val="accent1"/>
-          </a:fillRef>
-          <a:effectRef idx="1">
-            <a:schemeClr val="accent1"/>
-          </a:effectRef>
-          <a:fontRef idx="minor">
-            <a:schemeClr val="tx1"/>
-          </a:fontRef>
-        </p:style>
-      </p:cxnSp>
-      <p:sp>
-        <p:nvSpPr>
-          <p:cNvPr id="57" name="Rectangle 56"/>
-          <p:cNvSpPr/>
-          <p:nvPr/>
-        </p:nvSpPr>
-        <p:spPr>
-          <a:xfrm>
-            <a:off x="8339327" y="2034539"/>
-            <a:ext cx="694944" cy="365760"/>
-          </a:xfrm>
-          <a:prstGeom prst="rect">
-            <a:avLst/>
-          </a:prstGeom>
-          <a:solidFill>
-            <a:srgbClr val="FFFFFF"/>
-          </a:solidFill>
-          <a:ln w="9525">
-            <a:solidFill>
-              <a:srgbClr val="FFFFFF"/>
-            </a:solidFill>
-          </a:ln>
-        </p:spPr>
-        <p:style>
-          <a:lnRef idx="1">
-            <a:schemeClr val="accent1"/>
-          </a:lnRef>
-          <a:fillRef idx="3">
-            <a:schemeClr val="accent1"/>
-          </a:fillRef>
-          <a:effectRef idx="2">
-            <a:schemeClr val="accent1"/>
-          </a:effectRef>
-          <a:fontRef idx="minor">
-            <a:schemeClr val="lt1"/>
-          </a:fontRef>
-        </p:style>
-        <p:txBody>
-          <a:bodyPr rtlCol="0" anchor="ctr" wrap="square" lIns="45720" rIns="45720" tIns="18288" bIns="18288"/>
-          <a:lstStyle/>
-          <a:p>
-            <a:pPr algn="ctr">
-              <a:spcBef>
-                <a:spcPts val="0"/>
-              </a:spcBef>
-              <a:spcAft>
-                <a:spcPts val="0"/>
-              </a:spcAft>
-            </a:pPr>
-            <a:r>
-              <a:rPr sz="1100" b="1">
-                <a:solidFill>
-                  <a:srgbClr val="583E82"/>
-                </a:solidFill>
-                <a:latin typeface="Microsoft YaHei"/>
-                <a:ea typeface="Microsoft YaHei"/>
-                <a:cs typeface="Microsoft YaHei"/>
-              </a:rPr>
-              <a:t>32×OSFP</a:t>
-            </a:r>
-          </a:p>
-          <a:p>
-            <a:pPr algn="ctr">
-              <a:spcBef>
-                <a:spcPts val="0"/>
-              </a:spcBef>
-              <a:spcAft>
-                <a:spcPts val="0"/>
-              </a:spcAft>
-            </a:pPr>
-            <a:r>
-              <a:rPr sz="1100" b="1">
-                <a:solidFill>
-                  <a:srgbClr val="583E82"/>
-                </a:solidFill>
-                <a:latin typeface="Microsoft YaHei"/>
-                <a:ea typeface="Microsoft YaHei"/>
-                <a:cs typeface="Microsoft YaHei"/>
-              </a:rPr>
-              <a:t>单层光</a:t>
-            </a:r>
-          </a:p>
-        </p:txBody>
-      </p:sp>
-      <p:cxnSp>
-        <p:nvCxnSpPr>
-          <p:cNvPr id="58" name="Connector 57"/>
-          <p:cNvCxnSpPr/>
-          <p:nvPr/>
-        </p:nvCxnSpPr>
-        <p:spPr>
-          <a:xfrm>
-            <a:off x="10332720" y="2743200"/>
-            <a:ext cx="0" cy="502920"/>
-          </a:xfrm>
-          <a:prstGeom prst="line">
-            <a:avLst/>
-          </a:prstGeom>
-          <a:ln w="28575">
-            <a:solidFill>
-              <a:srgbClr val="583E82"/>
-            </a:solidFill>
-            <a:tailEnd type="triangle" w="med" len="sm"/>
-          </a:ln>
-        </p:spPr>
-        <p:style>
-          <a:lnRef idx="2">
-            <a:schemeClr val="accent1"/>
-          </a:lnRef>
-          <a:fillRef idx="0">
-            <a:schemeClr val="accent1"/>
-          </a:fillRef>
-          <a:effectRef idx="1">
-            <a:schemeClr val="accent1"/>
-          </a:effectRef>
-          <a:fontRef idx="minor">
-            <a:schemeClr val="tx1"/>
-          </a:fontRef>
-        </p:style>
-      </p:cxnSp>
-      <p:sp>
-        <p:nvSpPr>
-          <p:cNvPr id="59" name="Rectangle 58"/>
-          <p:cNvSpPr/>
-          <p:nvPr/>
-        </p:nvSpPr>
-        <p:spPr>
-          <a:xfrm>
-            <a:off x="10442448" y="2866644"/>
-            <a:ext cx="566928" cy="237744"/>
-          </a:xfrm>
-          <a:prstGeom prst="rect">
-            <a:avLst/>
-          </a:prstGeom>
-          <a:solidFill>
-            <a:srgbClr val="FFFFFF"/>
-          </a:solidFill>
-          <a:ln w="9525">
-            <a:solidFill>
-              <a:srgbClr val="FFFFFF"/>
-            </a:solidFill>
-          </a:ln>
-        </p:spPr>
-        <p:style>
-          <a:lnRef idx="1">
-            <a:schemeClr val="accent1"/>
-          </a:lnRef>
-          <a:fillRef idx="3">
-            <a:schemeClr val="accent1"/>
-          </a:fillRef>
-          <a:effectRef idx="2">
-            <a:schemeClr val="accent1"/>
-          </a:effectRef>
-          <a:fontRef idx="minor">
-            <a:schemeClr val="lt1"/>
-          </a:fontRef>
-        </p:style>
-        <p:txBody>
-          <a:bodyPr rtlCol="0" anchor="ctr" wrap="square" lIns="45720" rIns="45720" tIns="18288" bIns="18288"/>
-          <a:lstStyle/>
-          <a:p>
-            <a:pPr algn="ctr">
-              <a:spcBef>
-                <a:spcPts val="0"/>
-              </a:spcBef>
-              <a:spcAft>
-                <a:spcPts val="0"/>
-              </a:spcAft>
-            </a:pPr>
-            <a:r>
-              <a:rPr sz="1100" b="1">
-                <a:solidFill>
-                  <a:srgbClr val="583E82"/>
-                </a:solidFill>
-                <a:latin typeface="Microsoft YaHei"/>
-                <a:ea typeface="Microsoft YaHei"/>
-                <a:cs typeface="Microsoft YaHei"/>
-              </a:rPr>
-              <a:t>RDMA</a:t>
-            </a:r>
-          </a:p>
-        </p:txBody>
-      </p:sp>
-      <p:cxnSp>
-        <p:nvCxnSpPr>
-          <p:cNvPr id="60" name="Connector 59"/>
-          <p:cNvCxnSpPr/>
-          <p:nvPr/>
-        </p:nvCxnSpPr>
-        <p:spPr>
-          <a:xfrm>
-            <a:off x="10332720" y="4389120"/>
-            <a:ext cx="0" cy="457200"/>
-          </a:xfrm>
-          <a:prstGeom prst="line">
-            <a:avLst/>
-          </a:prstGeom>
-          <a:ln w="28575">
-            <a:solidFill>
-              <a:srgbClr val="1B6E48"/>
-            </a:solidFill>
-            <a:tailEnd type="triangle" w="med" len="sm"/>
-          </a:ln>
-        </p:spPr>
-        <p:style>
-          <a:lnRef idx="2">
-            <a:schemeClr val="accent1"/>
-          </a:lnRef>
-          <a:fillRef idx="0">
-            <a:schemeClr val="accent1"/>
-          </a:fillRef>
-          <a:effectRef idx="1">
-            <a:schemeClr val="accent1"/>
-          </a:effectRef>
-          <a:fontRef idx="minor">
-            <a:schemeClr val="tx1"/>
-          </a:fontRef>
-        </p:style>
-      </p:cxnSp>
-      <p:sp>
-        <p:nvSpPr>
-          <p:cNvPr id="61" name="Rectangle 60"/>
-          <p:cNvSpPr/>
-          <p:nvPr/>
-        </p:nvSpPr>
-        <p:spPr>
-          <a:xfrm>
-            <a:off x="10442448" y="4489704"/>
-            <a:ext cx="658368" cy="237744"/>
-          </a:xfrm>
-          <a:prstGeom prst="rect">
-            <a:avLst/>
-          </a:prstGeom>
-          <a:solidFill>
-            <a:srgbClr val="FFFFFF"/>
-          </a:solidFill>
-          <a:ln w="9525">
-            <a:solidFill>
-              <a:srgbClr val="FFFFFF"/>
-            </a:solidFill>
-          </a:ln>
-        </p:spPr>
-        <p:style>
-          <a:lnRef idx="1">
-            <a:schemeClr val="accent1"/>
-          </a:lnRef>
-          <a:fillRef idx="3">
-            <a:schemeClr val="accent1"/>
-          </a:fillRef>
-          <a:effectRef idx="2">
-            <a:schemeClr val="accent1"/>
-          </a:effectRef>
-          <a:fontRef idx="minor">
-            <a:schemeClr val="lt1"/>
-          </a:fontRef>
-        </p:style>
-        <p:txBody>
-          <a:bodyPr rtlCol="0" anchor="ctr" wrap="square" lIns="45720" rIns="45720" tIns="18288" bIns="18288"/>
-          <a:lstStyle/>
-          <a:p>
-            <a:pPr algn="ctr">
-              <a:spcBef>
-                <a:spcPts val="0"/>
-              </a:spcBef>
-              <a:spcAft>
-                <a:spcPts val="0"/>
-              </a:spcAft>
-            </a:pPr>
-            <a:r>
-              <a:rPr sz="1100" b="1">
-                <a:solidFill>
-                  <a:srgbClr val="1B6E48"/>
-                </a:solidFill>
-                <a:latin typeface="Microsoft YaHei"/>
-                <a:ea typeface="Microsoft YaHei"/>
-                <a:cs typeface="Microsoft YaHei"/>
-              </a:rPr>
-              <a:t>KV 预取</a:t>
-            </a:r>
-          </a:p>
-        </p:txBody>
-      </p:sp>
-      <p:sp>
-        <p:nvSpPr>
-          <p:cNvPr id="62" name="TextBox 61"/>
-          <p:cNvSpPr txBox="1"/>
-          <p:nvPr/>
-        </p:nvSpPr>
-        <p:spPr>
-          <a:xfrm>
-            <a:off x="292608" y="6327648"/>
-            <a:ext cx="11612880" cy="365760"/>
+            <a:off x="365760" y="5074920"/>
+            <a:ext cx="11430000" cy="1325880"/>
           </a:xfrm>
           <a:prstGeom prst="rect">
             <a:avLst/>
@@ -6579,7 +4402,7 @@
           <a:noFill/>
         </p:spPr>
         <p:txBody>
-          <a:bodyPr wrap="square" lIns="0" rIns="0" tIns="0" bIns="0" anchor="ctr"/>
+          <a:bodyPr wrap="square" lIns="0" rIns="0" tIns="0" bIns="0" anchor="t"/>
           <a:lstStyle/>
           <a:p>
             <a:pPr algn="l">
@@ -6591,15 +4414,57 @@
               </a:spcAft>
             </a:pPr>
             <a:r>
-              <a:rPr sz="1200" b="0">
+              <a:rPr sz="1800" b="0">
                 <a:solidFill>
-                  <a:srgbClr val="5A636E"/>
+                  <a:srgbClr val="1C242E"/>
                 </a:solidFill>
                 <a:latin typeface="Microsoft YaHei"/>
                 <a:ea typeface="Microsoft YaHei"/>
                 <a:cs typeface="Microsoft YaHei"/>
               </a:rPr>
-              <a:t>片内连线在 BlueField-4 的 Vera CPU 与 ConnectX-9 之间。托盘数和盘数公开材料没有给出，图中两条托盘只代表接法。STX 用的是 Spectrum-X 铜缆，不是 NVLink。</a:t>
+              <a:t>盘接到这颗处理器的 PCIe，规格为 Gen6、96 通道。</a:t>
+            </a:r>
+          </a:p>
+          <a:p>
+            <a:pPr algn="l">
+              <a:spcBef>
+                <a:spcPts val="0"/>
+              </a:spcBef>
+              <a:spcAft>
+                <a:spcPts val="0"/>
+              </a:spcAft>
+            </a:pPr>
+            <a:r>
+              <a:rPr sz="1800" b="0">
+                <a:solidFill>
+                  <a:srgbClr val="1C242E"/>
+                </a:solidFill>
+                <a:latin typeface="Microsoft YaHei"/>
+                <a:ea typeface="Microsoft YaHei"/>
+                <a:cs typeface="Microsoft YaHei"/>
+              </a:rPr>
+              <a:t>Vera CPU 与 ConnectX-9 做在同一颗上，中间是片内连接，不再拉线缆。</a:t>
+            </a:r>
+          </a:p>
+          <a:p>
+            <a:pPr algn="l">
+              <a:spcBef>
+                <a:spcPts val="0"/>
+              </a:spcBef>
+              <a:spcAft>
+                <a:spcPts val="0"/>
+              </a:spcAft>
+            </a:pPr>
+            <a:r>
+              <a:rPr sz="1800" b="0">
+                <a:solidFill>
+                  <a:srgbClr val="1C242E"/>
+                </a:solidFill>
+                <a:latin typeface="Microsoft YaHei"/>
+                <a:ea typeface="Microsoft YaHei"/>
+                <a:cs typeface="Microsoft YaHei"/>
+              </a:rPr>
+              <a:t>网口只在 ConnectX-9 上。数据离开这颗处理器，只从这只网口出去。</a:t>
             </a:r>
           </a:p>
         </p:txBody>

</xml_diff>